<commit_message>
feat: update presentation files with new simulation visuals
</commit_message>
<xml_diff>
--- a/presentation/VISTARA-X_Hack01.pptx
+++ b/presentation/VISTARA-X_Hack01.pptx
@@ -122,13 +122,13 @@
   <p:extLst>
     <p:ext uri="{521415D9-36F7-43E2-AB2F-B90AF26B5E84}">
       <p14:sectionLst xmlns:p14="http://schemas.microsoft.com/office/powerpoint/2010/main">
-        <p14:section name="Introduction" id="{e7a20f3e-62e0-1753-52bb-bc238edadef4}">
+        <p14:section name="Introduction" id="{d01a72aa-7382-09d2-0230-ff37f99cd4fa}">
           <p14:sldIdLst>
             <p14:sldId id="256"/>
             <p14:sldId id="257"/>
           </p14:sldIdLst>
         </p14:section>
-        <p14:section name="Solution" id="{dfab33f6-a2c9-20e0-20c6-5b752aafabfe}">
+        <p14:section name="Solution" id="{8baf70c9-d5e1-8cef-d56a-7defd9dfb5bb}">
           <p14:sldIdLst>
             <p14:sldId id="258"/>
             <p14:sldId id="259"/>
@@ -136,7 +136,7 @@
             <p14:sldId id="261"/>
           </p14:sldIdLst>
         </p14:section>
-        <p14:section name="Hardware" id="{36654b69-1180-e2fc-072e-2ece3a4e5fec}">
+        <p14:section name="Hardware" id="{0b66cc9d-a19d-8303-95ed-a8d135fc162b}">
           <p14:sldIdLst>
             <p14:sldId id="262"/>
             <p14:sldId id="263"/>
@@ -148,7 +148,7 @@
             <p14:sldId id="269"/>
           </p14:sldIdLst>
         </p14:section>
-        <p14:section name="Close" id="{d953d218-c61c-681f-5b6c-3fa1b9b8bffb}">
+        <p14:section name="Close" id="{2e5709ae-64d7-44e2-08f6-fe5226f01f3b}">
           <p14:sldIdLst>
             <p14:sldId id="270"/>
             <p14:sldId id="271"/>
@@ -3919,7 +3919,7 @@
         <p:spPr>
           <a:xfrm>
             <a:off x="457200" y="1097280"/>
-            <a:ext cx="5001768" cy="3383280"/>
+            <a:ext cx="4837176" cy="3383280"/>
           </a:xfrm>
           <a:prstGeom prst="rect">
             <a:avLst/>
@@ -3935,7 +3935,7 @@
         <p:spPr>
           <a:xfrm>
             <a:off x="457200" y="1097280"/>
-            <a:ext cx="5001768" cy="3383280"/>
+            <a:ext cx="4837176" cy="3383280"/>
           </a:xfrm>
           <a:prstGeom prst="rect">
             <a:avLst/>
@@ -3956,8 +3956,8 @@
         </p:nvSpPr>
         <p:spPr>
           <a:xfrm>
-            <a:off x="5760720" y="1097280"/>
-            <a:ext cx="2926080" cy="365760"/>
+            <a:off x="5669280" y="1097280"/>
+            <a:ext cx="3017520" cy="365760"/>
           </a:xfrm>
           <a:prstGeom prst="rect">
             <a:avLst/>

</xml_diff>

<commit_message>
feat: update wokwi simulation image and presentation file with new content
</commit_message>
<xml_diff>
--- a/presentation/VISTARA-X_Hack01.pptx
+++ b/presentation/VISTARA-X_Hack01.pptx
@@ -4,9 +4,6 @@
   <p:sldMasterIdLst>
     <p:sldMasterId id="2147483648" r:id="rId1"/>
   </p:sldMasterIdLst>
-  <p:notesMasterIdLst>
-    <p:notesMasterId r:id="rId16"/>
-  </p:notesMasterIdLst>
   <p:sldIdLst>
     <p:sldId id="256" r:id="rId2"/>
     <p:sldId id="257" r:id="rId3"/>
@@ -23,7 +20,10 @@
     <p:sldId id="268" r:id="rId14"/>
     <p:sldId id="269" r:id="rId15"/>
   </p:sldIdLst>
-  <p:sldSz cx="9144000" cy="5143500" type="screen16x9"/>
+  <p:notesMasterIdLst>
+    <p:notesMasterId r:id="rId16"/>
+  </p:notesMasterIdLst>
+  <p:sldSz cx="9144000" cy="5143500"/>
   <p:notesSz cx="5143500" cy="9144000"/>
   <p:defaultTextStyle>
     <a:lvl1pPr marL="0" algn="l" defTabSz="914400" rtl="0" eaLnBrk="1" latinLnBrk="0" hangingPunct="1">
@@ -120,13 +120,13 @@
   <p:extLst>
     <p:ext uri="{521415D9-36F7-43E2-AB2F-B90AF26B5E84}">
       <p14:sectionLst xmlns:p14="http://schemas.microsoft.com/office/powerpoint/2010/main">
-        <p14:section name="Introduction" id="{EB7B6261-D540-04BA-ABBF-9197E48FCC4D}">
+        <p14:section name="Introduction" id="{29315915-2352-50e9-2b8b-815d178b03be}">
           <p14:sldIdLst>
             <p14:sldId id="256"/>
             <p14:sldId id="257"/>
           </p14:sldIdLst>
         </p14:section>
-        <p14:section name="How it works" id="{7CAB2AAF-59CD-6C7E-D1F4-CB1C4FE92916}">
+        <p14:section name="How it works" id="{b8f7344c-76e4-1068-f626-9dd08d87cc3b}">
           <p14:sldIdLst>
             <p14:sldId id="258"/>
             <p14:sldId id="259"/>
@@ -134,12 +134,12 @@
             <p14:sldId id="261"/>
           </p14:sldIdLst>
         </p14:section>
-        <p14:section name="Results" id="{7F047774-47B8-3603-5B34-BF66E88EB8F3}">
+        <p14:section name="Results" id="{b57b9541-9b5c-d7a3-b96c-e67712941c78}">
           <p14:sldIdLst>
             <p14:sldId id="262"/>
           </p14:sldIdLst>
         </p14:section>
-        <p14:section name="Hardware" id="{35D3CE76-C0CB-67FE-4C96-D4C034C25191}">
+        <p14:section name="Hardware" id="{41f527a4-3ef8-2018-1f18-0ef4c3985925}">
           <p14:sldIdLst>
             <p14:sldId id="263"/>
             <p14:sldId id="264"/>
@@ -149,7 +149,7 @@
             <p14:sldId id="268"/>
           </p14:sldIdLst>
         </p14:section>
-        <p14:section name="Close" id="{EFE58305-E47F-DAB2-8B99-7EA6F62578F4}">
+        <p14:section name="Close" id="{6050c5d8-91ca-c544-a3fa-eaab1494907b}">
           <p14:sldIdLst>
             <p14:sldId id="269"/>
           </p14:sldIdLst>
@@ -164,11 +164,9 @@
 </file>
 
 <file path=ppt/charts/chart1.xml><?xml version="1.0" encoding="utf-8"?>
-<c:chartSpace xmlns:c="http://schemas.openxmlformats.org/drawingml/2006/chart" xmlns:a="http://schemas.openxmlformats.org/drawingml/2006/main" xmlns:r="http://schemas.openxmlformats.org/officeDocument/2006/relationships" xmlns:c16r2="http://schemas.microsoft.com/office/drawing/2015/06/chart">
+<c:chartSpace xmlns:c="http://schemas.openxmlformats.org/drawingml/2006/chart" xmlns:a="http://schemas.openxmlformats.org/drawingml/2006/main" xmlns:r="http://schemas.openxmlformats.org/officeDocument/2006/relationships">
   <c:date1904 val="0"/>
-  <c:lang val="en-GB"/>
   <c:roundedCorners val="1"/>
-  <c:style val="2"/>
   <c:chart>
     <c:autoTitleDeleted val="1"/>
     <c:plotArea>
@@ -200,26 +198,18 @@
           <c:invertIfNegative val="0"/>
           <c:dLbls>
             <c:numFmt formatCode="#,##0" sourceLinked="0"/>
-            <c:spPr>
-              <a:noFill/>
-              <a:ln>
-                <a:noFill/>
-              </a:ln>
-              <a:effectLst/>
-            </c:spPr>
             <c:txPr>
               <a:bodyPr/>
               <a:lstStyle/>
               <a:p>
                 <a:pPr>
-                  <a:defRPr sz="1200" b="0" i="0" u="none" strike="noStrike">
+                  <a:defRPr b="0" i="0" strike="noStrike" sz="1200" u="none">
                     <a:solidFill>
                       <a:srgbClr val="101820"/>
                     </a:solidFill>
                     <a:latin typeface="+mn-lt"/>
                   </a:defRPr>
                 </a:pPr>
-                <a:endParaRPr lang="en-AS"/>
               </a:p>
             </c:txPr>
             <c:showLegendKey val="0"/>
@@ -229,28 +219,25 @@
             <c:showPercent val="0"/>
             <c:showBubbleSize val="0"/>
             <c:showLeaderLines val="0"/>
-            <c:extLst>
-              <c:ext xmlns:c15="http://schemas.microsoft.com/office/drawing/2012/chart" uri="{CE6537A1-D6FC-4f65-9D91-7224C49458BB}">
-                <c15:showLeaderLines val="0"/>
-              </c:ext>
-            </c:extLst>
           </c:dLbls>
           <c:cat>
-            <c:strRef>
+            <c:multiLvlStrRef>
               <c:f>Sheet1!$A$2:$A$4</c:f>
-              <c:strCache>
+              <c:multiLvlStrCache>
                 <c:ptCount val="3"/>
-                <c:pt idx="0">
-                  <c:v>Goals reached</c:v>
-                </c:pt>
-                <c:pt idx="1">
-                  <c:v>Collisions</c:v>
-                </c:pt>
-                <c:pt idx="2">
-                  <c:v>Near misses</c:v>
-                </c:pt>
-              </c:strCache>
-            </c:strRef>
+                <c:lvl>
+                  <c:pt idx="0">
+                    <c:v>Goals reached</c:v>
+                  </c:pt>
+                  <c:pt idx="1">
+                    <c:v>Collisions</c:v>
+                  </c:pt>
+                  <c:pt idx="2">
+                    <c:v>Near misses</c:v>
+                  </c:pt>
+                </c:lvl>
+              </c:multiLvlStrCache>
+            </c:multiLvlStrRef>
           </c:cat>
           <c:val>
             <c:numRef>
@@ -270,11 +257,6 @@
               </c:numCache>
             </c:numRef>
           </c:val>
-          <c:extLst>
-            <c:ext xmlns:c16="http://schemas.microsoft.com/office/drawing/2014/chart" uri="{C3380CC4-5D6E-409C-BE32-E72D297353CC}">
-              <c16:uniqueId val="{00000000-F380-455F-BD43-D1C1CA31D067}"/>
-            </c:ext>
-          </c:extLst>
         </c:ser>
         <c:ser>
           <c:idx val="1"/>
@@ -299,26 +281,18 @@
           <c:invertIfNegative val="0"/>
           <c:dLbls>
             <c:numFmt formatCode="#,##0" sourceLinked="0"/>
-            <c:spPr>
-              <a:noFill/>
-              <a:ln>
-                <a:noFill/>
-              </a:ln>
-              <a:effectLst/>
-            </c:spPr>
             <c:txPr>
               <a:bodyPr/>
               <a:lstStyle/>
               <a:p>
                 <a:pPr>
-                  <a:defRPr sz="1200" b="0" i="0" u="none" strike="noStrike">
+                  <a:defRPr b="0" i="0" strike="noStrike" sz="1200" u="none">
                     <a:solidFill>
                       <a:srgbClr val="101820"/>
                     </a:solidFill>
                     <a:latin typeface="+mn-lt"/>
                   </a:defRPr>
                 </a:pPr>
-                <a:endParaRPr lang="en-AS"/>
               </a:p>
             </c:txPr>
             <c:showLegendKey val="0"/>
@@ -328,28 +302,25 @@
             <c:showPercent val="0"/>
             <c:showBubbleSize val="0"/>
             <c:showLeaderLines val="0"/>
-            <c:extLst>
-              <c:ext xmlns:c15="http://schemas.microsoft.com/office/drawing/2012/chart" uri="{CE6537A1-D6FC-4f65-9D91-7224C49458BB}">
-                <c15:showLeaderLines val="0"/>
-              </c:ext>
-            </c:extLst>
           </c:dLbls>
           <c:cat>
-            <c:strRef>
+            <c:multiLvlStrRef>
               <c:f>Sheet1!$A$2:$A$4</c:f>
-              <c:strCache>
+              <c:multiLvlStrCache>
                 <c:ptCount val="3"/>
-                <c:pt idx="0">
-                  <c:v>Goals reached</c:v>
-                </c:pt>
-                <c:pt idx="1">
-                  <c:v>Collisions</c:v>
-                </c:pt>
-                <c:pt idx="2">
-                  <c:v>Near misses</c:v>
-                </c:pt>
-              </c:strCache>
-            </c:strRef>
+                <c:lvl>
+                  <c:pt idx="0">
+                    <c:v>Goals reached</c:v>
+                  </c:pt>
+                  <c:pt idx="1">
+                    <c:v>Collisions</c:v>
+                  </c:pt>
+                  <c:pt idx="2">
+                    <c:v>Near misses</c:v>
+                  </c:pt>
+                </c:lvl>
+              </c:multiLvlStrCache>
+            </c:multiLvlStrRef>
           </c:cat>
           <c:val>
             <c:numRef>
@@ -369,23 +340,36 @@
               </c:numCache>
             </c:numRef>
           </c:val>
-          <c:extLst>
-            <c:ext xmlns:c16="http://schemas.microsoft.com/office/drawing/2014/chart" uri="{C3380CC4-5D6E-409C-BE32-E72D297353CC}">
-              <c16:uniqueId val="{00000001-F380-455F-BD43-D1C1CA31D067}"/>
-            </c:ext>
-          </c:extLst>
         </c:ser>
         <c:dLbls>
+          <c:numFmt formatCode="#,##0" sourceLinked="0"/>
+          <c:txPr>
+            <a:bodyPr/>
+            <a:lstStyle/>
+            <a:p>
+              <a:pPr>
+                <a:defRPr b="0" i="0" strike="noStrike" sz="1200" u="none">
+                  <a:solidFill>
+                    <a:srgbClr val="101820"/>
+                  </a:solidFill>
+                  <a:latin typeface="+mn-lt"/>
+                </a:defRPr>
+              </a:pPr>
+            </a:p>
+          </c:txPr>
           <c:showLegendKey val="0"/>
           <c:showVal val="1"/>
           <c:showCatName val="0"/>
           <c:showSerName val="0"/>
           <c:showPercent val="0"/>
           <c:showBubbleSize val="0"/>
+          <c:showLeaderLines val="0"/>
         </c:dLbls>
         <c:gapWidth val="60"/>
+        <c:overlap val="0"/>
         <c:axId val="2094734554"/>
         <c:axId val="2094734552"/>
+        <c:axId val="2094734556"/>
       </c:barChart>
       <c:catAx>
         <c:axId val="2094734554"/>
@@ -426,7 +410,6 @@
         <c:crosses val="autoZero"/>
         <c:auto val="1"/>
         <c:lblAlgn val="ctr"/>
-        <c:lblOffset val="100"/>
         <c:noMultiLvlLbl val="1"/>
       </c:catAx>
       <c:valAx>
@@ -441,6 +424,30 @@
         <c:majorTickMark val="out"/>
         <c:minorTickMark val="none"/>
         <c:tickLblPos val="nextTo"/>
+        <c:spPr>
+          <a:ln w="12700" cap="flat">
+            <a:solidFill>
+              <a:srgbClr val="888888"/>
+            </a:solidFill>
+            <a:prstDash val="solid"/>
+            <a:round/>
+          </a:ln>
+        </c:spPr>
+        <c:txPr>
+          <a:bodyPr/>
+          <a:lstStyle/>
+          <a:p>
+            <a:pPr>
+              <a:defRPr sz="1200" b="0" i="0" u="none" strike="noStrike">
+                <a:solidFill>
+                  <a:srgbClr val="000000"/>
+                </a:solidFill>
+                <a:latin typeface="Arial"/>
+              </a:defRPr>
+            </a:pPr>
+            <a:endParaRPr lang="en-US"/>
+          </a:p>
+        </c:txPr>
         <c:crossAx val="2094734554"/>
         <c:crosses val="autoZero"/>
         <c:crossBetween val="between"/>
@@ -475,7 +482,6 @@
     </c:legend>
     <c:plotVisOnly val="1"/>
     <c:dispBlanksAs val="span"/>
-    <c:showDLblsOverMax val="1"/>
   </c:chart>
   <c:spPr>
     <a:noFill/>
@@ -491,11 +497,9 @@
 </file>
 
 <file path=ppt/charts/chart2.xml><?xml version="1.0" encoding="utf-8"?>
-<c:chartSpace xmlns:c="http://schemas.openxmlformats.org/drawingml/2006/chart" xmlns:a="http://schemas.openxmlformats.org/drawingml/2006/main" xmlns:r="http://schemas.openxmlformats.org/officeDocument/2006/relationships" xmlns:c16r2="http://schemas.microsoft.com/office/drawing/2015/06/chart">
+<c:chartSpace xmlns:c="http://schemas.openxmlformats.org/drawingml/2006/chart" xmlns:a="http://schemas.openxmlformats.org/drawingml/2006/main" xmlns:r="http://schemas.openxmlformats.org/officeDocument/2006/relationships">
   <c:date1904 val="0"/>
-  <c:lang val="en-GB"/>
   <c:roundedCorners val="1"/>
-  <c:style val="2"/>
   <c:chart>
     <c:title>
       <c:tx>
@@ -512,26 +516,18 @@
               </a:defRPr>
             </a:pPr>
             <a:r>
-              <a:rPr lang="en-AS" sz="1200" b="0" i="0" u="none" strike="noStrike">
+              <a:rPr sz="1200" b="0" i="0" u="none" strike="noStrike">
                 <a:solidFill>
                   <a:srgbClr val="4B5866"/>
                 </a:solidFill>
                 <a:latin typeface="+mn-lt"/>
               </a:rPr>
-              <a:t>₹ </a:t>
-            </a:r>
-            <a:r>
-              <a:rPr lang="en-US" sz="1200" b="0" i="0" u="none" strike="noStrike">
-                <a:solidFill>
-                  <a:srgbClr val="4B5866"/>
-                </a:solidFill>
-                <a:latin typeface="+mn-lt"/>
-              </a:rPr>
-              <a:t>thousand</a:t>
+              <a:t>₹ thousand</a:t>
             </a:r>
           </a:p>
         </c:rich>
       </c:tx>
+      <c:layout/>
       <c:overlay val="0"/>
     </c:title>
     <c:autoTitleDeleted val="0"/>
@@ -575,11 +571,6 @@
               </a:solidFill>
               <a:effectLst/>
             </c:spPr>
-            <c:extLst>
-              <c:ext xmlns:c16="http://schemas.microsoft.com/office/drawing/2014/chart" uri="{C3380CC4-5D6E-409C-BE32-E72D297353CC}">
-                <c16:uniqueId val="{00000001-E2ED-4218-8DC5-D8E50F42D6EA}"/>
-              </c:ext>
-            </c:extLst>
           </c:dPt>
           <c:dPt>
             <c:idx val="1"/>
@@ -590,11 +581,6 @@
               </a:solidFill>
               <a:effectLst/>
             </c:spPr>
-            <c:extLst>
-              <c:ext xmlns:c16="http://schemas.microsoft.com/office/drawing/2014/chart" uri="{C3380CC4-5D6E-409C-BE32-E72D297353CC}">
-                <c16:uniqueId val="{00000003-E2ED-4218-8DC5-D8E50F42D6EA}"/>
-              </c:ext>
-            </c:extLst>
           </c:dPt>
           <c:dPt>
             <c:idx val="2"/>
@@ -605,11 +591,6 @@
               </a:solidFill>
               <a:effectLst/>
             </c:spPr>
-            <c:extLst>
-              <c:ext xmlns:c16="http://schemas.microsoft.com/office/drawing/2014/chart" uri="{C3380CC4-5D6E-409C-BE32-E72D297353CC}">
-                <c16:uniqueId val="{00000005-E2ED-4218-8DC5-D8E50F42D6EA}"/>
-              </c:ext>
-            </c:extLst>
           </c:dPt>
           <c:dPt>
             <c:idx val="3"/>
@@ -620,11 +601,6 @@
               </a:solidFill>
               <a:effectLst/>
             </c:spPr>
-            <c:extLst>
-              <c:ext xmlns:c16="http://schemas.microsoft.com/office/drawing/2014/chart" uri="{C3380CC4-5D6E-409C-BE32-E72D297353CC}">
-                <c16:uniqueId val="{00000007-E2ED-4218-8DC5-D8E50F42D6EA}"/>
-              </c:ext>
-            </c:extLst>
           </c:dPt>
           <c:dPt>
             <c:idx val="4"/>
@@ -635,11 +611,6 @@
               </a:solidFill>
               <a:effectLst/>
             </c:spPr>
-            <c:extLst>
-              <c:ext xmlns:c16="http://schemas.microsoft.com/office/drawing/2014/chart" uri="{C3380CC4-5D6E-409C-BE32-E72D297353CC}">
-                <c16:uniqueId val="{00000009-E2ED-4218-8DC5-D8E50F42D6EA}"/>
-              </c:ext>
-            </c:extLst>
           </c:dPt>
           <c:dPt>
             <c:idx val="5"/>
@@ -650,11 +621,6 @@
               </a:solidFill>
               <a:effectLst/>
             </c:spPr>
-            <c:extLst>
-              <c:ext xmlns:c16="http://schemas.microsoft.com/office/drawing/2014/chart" uri="{C3380CC4-5D6E-409C-BE32-E72D297353CC}">
-                <c16:uniqueId val="{0000000B-E2ED-4218-8DC5-D8E50F42D6EA}"/>
-              </c:ext>
-            </c:extLst>
           </c:dPt>
           <c:dLbls>
             <c:dLbl>
@@ -673,7 +639,6 @@
                       <a:latin typeface="+mn-lt"/>
                     </a:defRPr>
                   </a:pPr>
-                  <a:endParaRPr lang="en-AS"/>
                 </a:p>
               </c:txPr>
               <c:showLegendKey val="0"/>
@@ -682,12 +647,6 @@
               <c:showSerName val="0"/>
               <c:showPercent val="0"/>
               <c:showBubbleSize val="0"/>
-              <c:extLst>
-                <c:ext xmlns:c15="http://schemas.microsoft.com/office/drawing/2012/chart" uri="{CE6537A1-D6FC-4f65-9D91-7224C49458BB}"/>
-                <c:ext xmlns:c16="http://schemas.microsoft.com/office/drawing/2014/chart" uri="{C3380CC4-5D6E-409C-BE32-E72D297353CC}">
-                  <c16:uniqueId val="{00000001-E2ED-4218-8DC5-D8E50F42D6EA}"/>
-                </c:ext>
-              </c:extLst>
             </c:dLbl>
             <c:dLbl>
               <c:idx val="1"/>
@@ -705,7 +664,6 @@
                       <a:latin typeface="+mn-lt"/>
                     </a:defRPr>
                   </a:pPr>
-                  <a:endParaRPr lang="en-AS"/>
                 </a:p>
               </c:txPr>
               <c:showLegendKey val="0"/>
@@ -714,12 +672,6 @@
               <c:showSerName val="0"/>
               <c:showPercent val="0"/>
               <c:showBubbleSize val="0"/>
-              <c:extLst>
-                <c:ext xmlns:c15="http://schemas.microsoft.com/office/drawing/2012/chart" uri="{CE6537A1-D6FC-4f65-9D91-7224C49458BB}"/>
-                <c:ext xmlns:c16="http://schemas.microsoft.com/office/drawing/2014/chart" uri="{C3380CC4-5D6E-409C-BE32-E72D297353CC}">
-                  <c16:uniqueId val="{00000003-E2ED-4218-8DC5-D8E50F42D6EA}"/>
-                </c:ext>
-              </c:extLst>
             </c:dLbl>
             <c:dLbl>
               <c:idx val="2"/>
@@ -737,7 +689,6 @@
                       <a:latin typeface="+mn-lt"/>
                     </a:defRPr>
                   </a:pPr>
-                  <a:endParaRPr lang="en-AS"/>
                 </a:p>
               </c:txPr>
               <c:showLegendKey val="0"/>
@@ -746,12 +697,6 @@
               <c:showSerName val="0"/>
               <c:showPercent val="0"/>
               <c:showBubbleSize val="0"/>
-              <c:extLst>
-                <c:ext xmlns:c15="http://schemas.microsoft.com/office/drawing/2012/chart" uri="{CE6537A1-D6FC-4f65-9D91-7224C49458BB}"/>
-                <c:ext xmlns:c16="http://schemas.microsoft.com/office/drawing/2014/chart" uri="{C3380CC4-5D6E-409C-BE32-E72D297353CC}">
-                  <c16:uniqueId val="{00000005-E2ED-4218-8DC5-D8E50F42D6EA}"/>
-                </c:ext>
-              </c:extLst>
             </c:dLbl>
             <c:dLbl>
               <c:idx val="3"/>
@@ -769,7 +714,6 @@
                       <a:latin typeface="+mn-lt"/>
                     </a:defRPr>
                   </a:pPr>
-                  <a:endParaRPr lang="en-AS"/>
                 </a:p>
               </c:txPr>
               <c:showLegendKey val="0"/>
@@ -778,12 +722,6 @@
               <c:showSerName val="0"/>
               <c:showPercent val="0"/>
               <c:showBubbleSize val="0"/>
-              <c:extLst>
-                <c:ext xmlns:c15="http://schemas.microsoft.com/office/drawing/2012/chart" uri="{CE6537A1-D6FC-4f65-9D91-7224C49458BB}"/>
-                <c:ext xmlns:c16="http://schemas.microsoft.com/office/drawing/2014/chart" uri="{C3380CC4-5D6E-409C-BE32-E72D297353CC}">
-                  <c16:uniqueId val="{00000007-E2ED-4218-8DC5-D8E50F42D6EA}"/>
-                </c:ext>
-              </c:extLst>
             </c:dLbl>
             <c:dLbl>
               <c:idx val="4"/>
@@ -801,7 +739,6 @@
                       <a:latin typeface="+mn-lt"/>
                     </a:defRPr>
                   </a:pPr>
-                  <a:endParaRPr lang="en-AS"/>
                 </a:p>
               </c:txPr>
               <c:showLegendKey val="0"/>
@@ -810,12 +747,6 @@
               <c:showSerName val="0"/>
               <c:showPercent val="0"/>
               <c:showBubbleSize val="0"/>
-              <c:extLst>
-                <c:ext xmlns:c15="http://schemas.microsoft.com/office/drawing/2012/chart" uri="{CE6537A1-D6FC-4f65-9D91-7224C49458BB}"/>
-                <c:ext xmlns:c16="http://schemas.microsoft.com/office/drawing/2014/chart" uri="{C3380CC4-5D6E-409C-BE32-E72D297353CC}">
-                  <c16:uniqueId val="{00000009-E2ED-4218-8DC5-D8E50F42D6EA}"/>
-                </c:ext>
-              </c:extLst>
             </c:dLbl>
             <c:dLbl>
               <c:idx val="5"/>
@@ -833,7 +764,6 @@
                       <a:latin typeface="+mn-lt"/>
                     </a:defRPr>
                   </a:pPr>
-                  <a:endParaRPr lang="en-AS"/>
                 </a:p>
               </c:txPr>
               <c:showLegendKey val="0"/>
@@ -842,21 +772,8 @@
               <c:showSerName val="0"/>
               <c:showPercent val="0"/>
               <c:showBubbleSize val="0"/>
-              <c:extLst>
-                <c:ext xmlns:c15="http://schemas.microsoft.com/office/drawing/2012/chart" uri="{CE6537A1-D6FC-4f65-9D91-7224C49458BB}"/>
-                <c:ext xmlns:c16="http://schemas.microsoft.com/office/drawing/2014/chart" uri="{C3380CC4-5D6E-409C-BE32-E72D297353CC}">
-                  <c16:uniqueId val="{0000000B-E2ED-4218-8DC5-D8E50F42D6EA}"/>
-                </c:ext>
-              </c:extLst>
             </c:dLbl>
             <c:numFmt formatCode="0.0" sourceLinked="0"/>
-            <c:spPr>
-              <a:noFill/>
-              <a:ln>
-                <a:noFill/>
-              </a:ln>
-              <a:effectLst/>
-            </c:spPr>
             <c:txPr>
               <a:bodyPr/>
               <a:lstStyle/>
@@ -869,7 +786,6 @@
                     <a:latin typeface="Arial"/>
                   </a:defRPr>
                 </a:pPr>
-                <a:endParaRPr lang="en-AS"/>
               </a:p>
             </c:txPr>
             <c:showLegendKey val="0"/>
@@ -879,9 +795,6 @@
             <c:showPercent val="1"/>
             <c:showBubbleSize val="0"/>
             <c:showLeaderLines val="0"/>
-            <c:extLst>
-              <c:ext xmlns:c15="http://schemas.microsoft.com/office/drawing/2012/chart" uri="{CE6537A1-D6FC-4f65-9D91-7224C49458BB}"/>
-            </c:extLst>
           </c:dLbls>
           <c:cat>
             <c:strRef>
@@ -913,13 +826,12 @@
             <c:numRef>
               <c:f>Sheet1!$B$2:$B$7</c:f>
               <c:numCache>
-                <c:formatCode>General</c:formatCode>
                 <c:ptCount val="6"/>
                 <c:pt idx="0">
                   <c:v>8.5</c:v>
                 </c:pt>
                 <c:pt idx="1">
-                  <c:v>5.0999999999999996</c:v>
+                  <c:v>5.1</c:v>
                 </c:pt>
                 <c:pt idx="2">
                   <c:v>2.1</c:v>
@@ -936,21 +848,7 @@
               </c:numCache>
             </c:numRef>
           </c:val>
-          <c:extLst>
-            <c:ext xmlns:c16="http://schemas.microsoft.com/office/drawing/2014/chart" uri="{C3380CC4-5D6E-409C-BE32-E72D297353CC}">
-              <c16:uniqueId val="{0000000C-E2ED-4218-8DC5-D8E50F42D6EA}"/>
-            </c:ext>
-          </c:extLst>
         </c:ser>
-        <c:dLbls>
-          <c:showLegendKey val="0"/>
-          <c:showVal val="0"/>
-          <c:showCatName val="0"/>
-          <c:showSerName val="0"/>
-          <c:showPercent val="0"/>
-          <c:showBubbleSize val="0"/>
-          <c:showLeaderLines val="0"/>
-        </c:dLbls>
         <c:firstSliceAng val="0"/>
         <c:holeSize val="55"/>
       </c:doughnutChart>
@@ -984,7 +882,6 @@
     </c:legend>
     <c:plotVisOnly val="1"/>
     <c:dispBlanksAs val="span"/>
-    <c:showDLblsOverMax val="1"/>
   </c:chart>
   <c:spPr>
     <a:noFill/>
@@ -1021,10 +918,234 @@
           <a:chExt cx="0" cy="0"/>
         </a:xfrm>
       </p:grpSpPr>
+      <p:sp>
+        <p:nvSpPr>
+          <p:cNvPr id="2" name="Header Placeholder 1"/>
+          <p:cNvSpPr>
+            <a:spLocks noGrp="1"/>
+          </p:cNvSpPr>
+          <p:nvPr>
+            <p:ph type="hdr" sz="quarter"/>
+          </p:nvPr>
+        </p:nvSpPr>
+        <p:spPr>
+          <a:xfrm>
+            <a:off x="0" y="0"/>
+            <a:ext cx="2971800" cy="458788"/>
+          </a:xfrm>
+          <a:prstGeom prst="rect">
+            <a:avLst/>
+          </a:prstGeom>
+        </p:spPr>
+        <p:txBody>
+          <a:bodyPr vert="horz" lIns="91440" tIns="45720" rIns="91440" bIns="45720" rtlCol="0"/>
+          <a:lstStyle>
+            <a:lvl1pPr algn="l">
+              <a:defRPr sz="1200"/>
+            </a:lvl1pPr>
+          </a:lstStyle>
+          <a:p>
+            <a:endParaRPr lang="en-US"/>
+          </a:p>
+        </p:txBody>
+      </p:sp>
+      <p:sp>
+        <p:nvSpPr>
+          <p:cNvPr id="3" name="Date Placeholder 2"/>
+          <p:cNvSpPr>
+            <a:spLocks noGrp="1"/>
+          </p:cNvSpPr>
+          <p:nvPr>
+            <p:ph type="dt" idx="1"/>
+          </p:nvPr>
+        </p:nvSpPr>
+        <p:spPr>
+          <a:xfrm>
+            <a:off x="3884613" y="0"/>
+            <a:ext cx="2971800" cy="458788"/>
+          </a:xfrm>
+          <a:prstGeom prst="rect">
+            <a:avLst/>
+          </a:prstGeom>
+        </p:spPr>
+        <p:txBody>
+          <a:bodyPr vert="horz" lIns="91440" tIns="45720" rIns="91440" bIns="45720" rtlCol="0"/>
+          <a:lstStyle>
+            <a:lvl1pPr algn="r">
+              <a:defRPr sz="1200"/>
+            </a:lvl1pPr>
+          </a:lstStyle>
+          <a:p>
+            <a:fld id="{5282F153-3F37-0F45-9E97-73ACFA13230C}" type="datetimeFigureOut">
+              <a:rPr lang="en-US"/>
+              <a:t>7/23/19</a:t>
+            </a:fld>
+            <a:endParaRPr lang="en-US"/>
+          </a:p>
+        </p:txBody>
+      </p:sp>
+      <p:sp>
+        <p:nvSpPr>
+          <p:cNvPr id="4" name="Slide Image Placeholder 3"/>
+          <p:cNvSpPr>
+            <a:spLocks noGrp="1" noRot="1" noChangeAspect="1"/>
+          </p:cNvSpPr>
+          <p:nvPr>
+            <p:ph type="sldImg" idx="2"/>
+          </p:nvPr>
+        </p:nvSpPr>
+        <p:spPr>
+          <a:xfrm>
+            <a:off x="685800" y="1143000"/>
+            <a:ext cx="5486400" cy="3086100"/>
+          </a:xfrm>
+          <a:prstGeom prst="rect">
+            <a:avLst/>
+          </a:prstGeom>
+          <a:noFill/>
+          <a:ln w="12700">
+            <a:solidFill>
+              <a:prstClr val="black"/>
+            </a:solidFill>
+          </a:ln>
+        </p:spPr>
+        <p:txBody>
+          <a:bodyPr vert="horz" lIns="91440" tIns="45720" rIns="91440" bIns="45720" rtlCol="0" anchor="ctr"/>
+          <a:lstStyle/>
+          <a:p>
+            <a:endParaRPr lang="en-US"/>
+          </a:p>
+        </p:txBody>
+      </p:sp>
+      <p:sp>
+        <p:nvSpPr>
+          <p:cNvPr id="5" name="Notes Placeholder 4"/>
+          <p:cNvSpPr>
+            <a:spLocks noGrp="1"/>
+          </p:cNvSpPr>
+          <p:nvPr>
+            <p:ph type="body" sz="quarter" idx="3"/>
+          </p:nvPr>
+        </p:nvSpPr>
+        <p:spPr>
+          <a:xfrm>
+            <a:off x="685800" y="4400550"/>
+            <a:ext cx="5486400" cy="3600450"/>
+          </a:xfrm>
+          <a:prstGeom prst="rect">
+            <a:avLst/>
+          </a:prstGeom>
+        </p:spPr>
+        <p:txBody>
+          <a:bodyPr vert="horz" lIns="91440" tIns="45720" rIns="91440" bIns="45720" rtlCol="0"/>
+          <a:lstStyle/>
+          <a:p>
+            <a:pPr lvl="0"/>
+            <a:r>
+              <a:rPr lang="en-US"/>
+              <a:t>Click to edit Master text styles</a:t>
+            </a:r>
+          </a:p>
+          <a:p>
+            <a:pPr lvl="1"/>
+            <a:r>
+              <a:rPr lang="en-US"/>
+              <a:t>Second level</a:t>
+            </a:r>
+          </a:p>
+          <a:p>
+            <a:pPr lvl="2"/>
+            <a:r>
+              <a:rPr lang="en-US"/>
+              <a:t>Third level</a:t>
+            </a:r>
+          </a:p>
+          <a:p>
+            <a:pPr lvl="3"/>
+            <a:r>
+              <a:rPr lang="en-US"/>
+              <a:t>Fourth level</a:t>
+            </a:r>
+          </a:p>
+          <a:p>
+            <a:pPr lvl="4"/>
+            <a:r>
+              <a:rPr lang="en-US"/>
+              <a:t>Fifth level</a:t>
+            </a:r>
+          </a:p>
+        </p:txBody>
+      </p:sp>
+      <p:sp>
+        <p:nvSpPr>
+          <p:cNvPr id="6" name="Footer Placeholder 5"/>
+          <p:cNvSpPr>
+            <a:spLocks noGrp="1"/>
+          </p:cNvSpPr>
+          <p:nvPr>
+            <p:ph type="ftr" sz="quarter" idx="4"/>
+          </p:nvPr>
+        </p:nvSpPr>
+        <p:spPr>
+          <a:xfrm>
+            <a:off x="0" y="8685213"/>
+            <a:ext cx="2971800" cy="458787"/>
+          </a:xfrm>
+          <a:prstGeom prst="rect">
+            <a:avLst/>
+          </a:prstGeom>
+        </p:spPr>
+        <p:txBody>
+          <a:bodyPr vert="horz" lIns="91440" tIns="45720" rIns="91440" bIns="45720" rtlCol="0" anchor="b"/>
+          <a:lstStyle>
+            <a:lvl1pPr algn="l">
+              <a:defRPr sz="1200"/>
+            </a:lvl1pPr>
+          </a:lstStyle>
+          <a:p>
+            <a:endParaRPr lang="en-US"/>
+          </a:p>
+        </p:txBody>
+      </p:sp>
+      <p:sp>
+        <p:nvSpPr>
+          <p:cNvPr id="7" name="Slide Number Placeholder 6"/>
+          <p:cNvSpPr>
+            <a:spLocks noGrp="1"/>
+          </p:cNvSpPr>
+          <p:nvPr>
+            <p:ph type="sldNum" sz="quarter" idx="5"/>
+          </p:nvPr>
+        </p:nvSpPr>
+        <p:spPr>
+          <a:xfrm>
+            <a:off x="3884613" y="8685213"/>
+            <a:ext cx="2971800" cy="458787"/>
+          </a:xfrm>
+          <a:prstGeom prst="rect">
+            <a:avLst/>
+          </a:prstGeom>
+        </p:spPr>
+        <p:txBody>
+          <a:bodyPr vert="horz" lIns="91440" tIns="45720" rIns="91440" bIns="45720" rtlCol="0" anchor="b"/>
+          <a:lstStyle>
+            <a:lvl1pPr algn="r">
+              <a:defRPr sz="1200"/>
+            </a:lvl1pPr>
+          </a:lstStyle>
+          <a:p>
+            <a:fld id="{CE5E9CC1-C706-0F49-92D6-E571CC5EEA8F}" type="slidenum">
+              <a:rPr lang="en-US"/>
+              <a:t>‹#›</a:t>
+            </a:fld>
+            <a:endParaRPr lang="en-US"/>
+          </a:p>
+        </p:txBody>
+      </p:sp>
     </p:spTree>
     <p:extLst>
       <p:ext uri="{BB962C8B-B14F-4D97-AF65-F5344CB8AC3E}">
-        <p14:creationId xmlns:p14="http://schemas.microsoft.com/office/powerpoint/2010/main" val="662931527"/>
+        <p14:creationId xmlns:p14="http://schemas.microsoft.com/office/powerpoint/2010/main" val="1024086991"/>
       </p:ext>
     </p:extLst>
   </p:cSld>
@@ -1172,6 +1293,7 @@
               <a:rPr lang="en-US" dirty="0"/>
               <a:t>We are Team Hack01. VISTARA-X is an autonomous navigation system for indoor robots that share corridors with people, like hospital or warehouse delivery robots. The picture is a screenshot of our own 3D digital twin.</a:t>
             </a:r>
+            <a:endParaRPr lang="en-US" dirty="0"/>
           </a:p>
         </p:txBody>
       </p:sp>
@@ -1259,6 +1381,7 @@
               <a:rPr lang="en-US" dirty="0"/>
               <a:t>Every connection with its pin: motor driver on 5 to 8, wheel encoders on interrupt pins 2 and 3, the six ultrasonic sensors on 30 to 41, the IMU on I2C, battery on A0, E-stop on 26.</a:t>
             </a:r>
+            <a:endParaRPr lang="en-US" dirty="0"/>
           </a:p>
         </p:txBody>
       </p:sp>
@@ -1344,8 +1467,9 @@
           <a:p>
             <a:r>
               <a:rPr lang="en-US" dirty="0"/>
-              <a:t>The firmware runs in Wokwi with the same pin map as the real robot. The robot's front points right, and each ultrasonic sensor sits on the side it faces. The motor LEDs show the PWM; moving a sensor's distance slows or stops the robot, the E-stop cuts everything at once and stays latched, and the battery knob triggers the low-battery rules.</a:t>
-            </a:r>
+              <a:t>The firmware runs in Wokwi with the same pin map as the real robot. When you press Start, an automatic tour shows every safety rule in about 46 seconds and explains each step in the serial monitor. The robot's front points right, and each ultrasonic sensor sits on the side it faces. The motor LEDs show the PWM; moving a sensor's distance slows or stops the robot, the E-stop cuts everything at once and stays latched, and the battery knob triggers the low-battery rules.</a:t>
+            </a:r>
+            <a:endParaRPr lang="en-US" dirty="0"/>
           </a:p>
         </p:txBody>
       </p:sp>
@@ -1433,6 +1557,7 @@
               <a:rPr lang="en-US" dirty="0"/>
               <a:t>Because the laptop does the computing, the robot costs about twenty-one thousand rupees. The LiDAR is the biggest single part. A depth camera is an optional upgrade. It runs about two hours per charge, and the software already sends it back to the dock when the battery is low.</a:t>
             </a:r>
+            <a:endParaRPr lang="en-US" dirty="0"/>
           </a:p>
         </p:txBody>
       </p:sp>
@@ -1520,6 +1645,7 @@
               <a:rPr lang="en-US" dirty="0"/>
               <a:t>Getting to a real robot takes about ten weeks. Week one is already de-risked because the same Arduino firmware runs in Wokwi today. The navigation code does not change, only the sensor source and the motor output.</a:t>
             </a:r>
+            <a:endParaRPr lang="en-US" dirty="0"/>
           </a:p>
         </p:txBody>
       </p:sp>
@@ -1607,6 +1733,7 @@
               <a:rPr lang="en-US" dirty="0"/>
               <a:t>Thank you. Everything is on GitHub: the code, the evaluation, the hardware design and the Wokwi simulation. The QR code opens the repository.</a:t>
             </a:r>
+            <a:endParaRPr lang="en-US" dirty="0"/>
           </a:p>
         </p:txBody>
       </p:sp>
@@ -1694,6 +1821,7 @@
               <a:rPr lang="en-US" dirty="0"/>
               <a:t>Most robots brake only for what is directly in front of them. In a hospital corridor people walk across and do not give way, and stopping does not stop someone walking into you. In our test the reactive robot was hit twice in nine runs; ours predicted the person's path and slowed early, with zero collisions.</a:t>
             </a:r>
+            <a:endParaRPr lang="en-US" dirty="0"/>
           </a:p>
         </p:txBody>
       </p:sp>
@@ -1781,6 +1909,7 @@
               <a:rPr lang="en-US" dirty="0"/>
               <a:t>This is the product from the user's side. A nurse says, in Hinglish, take the medicine from the pharmacy to Ward B. The robot confirms, plans a route on its map, drives there while predicting the people around it, and the recipient enters a PIN as proof of delivery. The Arduino safety layer is always on underneath.</a:t>
             </a:r>
+            <a:endParaRPr lang="en-US" dirty="0"/>
           </a:p>
         </p:txBody>
       </p:sp>
@@ -1868,6 +1997,7 @@
               <a:rPr lang="en-US" dirty="0"/>
               <a:t>The laptop runs our Python backend: speech commands, YOLO perception, LiDAR tracking and prediction, SLAM, A-star planning and the delivery missions. It sends a speed command twenty times a second to an Arduino Mega, which keeps the robot safe on its own: if the laptop freezes it stops in half a second, and the E-stop cuts motor power in hardware.</a:t>
             </a:r>
+            <a:endParaRPr lang="en-US" dirty="0"/>
           </a:p>
         </p:txBody>
       </p:sp>
@@ -1955,6 +2085,7 @@
               <a:rPr lang="en-US" dirty="0"/>
               <a:t>This is a real screenshot from our dashboard during the demo. The pipeline strip lights up only from live state. The boxes show where person T1 will be from half a second to three seconds ahead, with growing uncertainty. The radar shows the robot, its route and the predicted path, and the decision timeline logs every action with its reason.</a:t>
             </a:r>
+            <a:endParaRPr lang="en-US" dirty="0"/>
           </a:p>
         </p:txBody>
       </p:sp>
@@ -2042,6 +2173,7 @@
               <a:rPr lang="en-US" dirty="0"/>
               <a:t>This is our judge demo running in the browser. A person crosses without giving way and a cart turns. Each step on the right is ticked only from real telemetry: the pedestrian is tracked, its path predicted, the robot slows to fifty percent, re-routes and reaches the goal with zero collisions.</a:t>
             </a:r>
+            <a:endParaRPr lang="en-US" dirty="0"/>
           </a:p>
         </p:txBody>
       </p:sp>
@@ -2129,6 +2261,7 @@
               <a:rPr lang="en-US" dirty="0"/>
               <a:t>Our evaluation script runs the same nine crossing variants with prediction on and off. Predictive: nine of nine goals, zero collisions, zero near misses. Reactive: two collisions and three near misses. The cost is about one and a half seconds per mission. These are simulation results.</a:t>
             </a:r>
+            <a:endParaRPr lang="en-US" dirty="0"/>
           </a:p>
         </p:txBody>
       </p:sp>
@@ -2216,6 +2349,7 @@
               <a:rPr lang="en-US" dirty="0"/>
               <a:t>The electronics on the left are exactly the parts in our Wokwi simulation: an Arduino Mega, six ultrasonic sensors, an IMU, the emergency stop, a buzzer and the battery sense. The laptop we already own runs the backend. The rest is off the shelf: a 360-degree LiDAR, a webcam, two encoder gearmotors with a driver, a battery and the chassis, about twenty-one thousand rupees in total.</a:t>
             </a:r>
+            <a:endParaRPr lang="en-US" dirty="0"/>
           </a:p>
         </p:txBody>
       </p:sp>
@@ -2303,6 +2437,7 @@
               <a:rPr lang="en-US" dirty="0"/>
               <a:t>Read it left to right. Sense: ultrasonic sensors, encoders, IMU, E-stop and battery level go into the Arduino. Think: the laptop sends a speed command and the Arduino checks four safety rules every twenty milliseconds. Act: it drives the motors, the buzzer and the status LED. The power path is separate, so the E-stop cuts only the wheels.</a:t>
             </a:r>
+            <a:endParaRPr lang="en-US" dirty="0"/>
           </a:p>
         </p:txBody>
       </p:sp>
@@ -2380,7 +2515,6 @@
         <a:solidFill>
           <a:schemeClr val="bg1"/>
         </a:solidFill>
-        <a:effectLst/>
       </p:bgPr>
     </p:bg>
     <p:spTree>
@@ -2400,11 +2534,9 @@
       <p:sp>
         <p:nvSpPr>
           <p:cNvPr id="2" name="Text 0"/>
-          <p:cNvSpPr>
-            <a:spLocks noGrp="1"/>
-          </p:cNvSpPr>
+          <p:cNvSpPr/>
           <p:nvPr>
-            <p:ph type="title" idx="100" hasCustomPrompt="1"/>
+            <p:ph idx="100" type="title" hasCustomPrompt="1"/>
           </p:nvPr>
         </p:nvSpPr>
         <p:spPr>
@@ -2421,7 +2553,7 @@
         <p:txBody>
           <a:bodyPr wrap="square" rtlCol="0"/>
           <a:lstStyle>
-            <a:lvl1pPr marL="0" indent="0" algn="l">
+            <a:lvl1pPr algn="l" indent="0" marL="0">
               <a:buNone/>
               <a:defRPr lang="en-US" sz="2600" b="1" dirty="0">
                 <a:solidFill>
@@ -2431,7 +2563,7 @@
             </a:lvl1pPr>
           </a:lstStyle>
           <a:p>
-            <a:pPr marL="0" indent="0" algn="l">
+            <a:pPr algn="l" indent="0" marL="0">
               <a:buNone/>
             </a:pPr>
             <a:endParaRPr lang="en-US" sz="2600" dirty="0"/>
@@ -2459,7 +2591,7 @@
           <a:bodyPr wrap="square" lIns="0" tIns="0" rIns="0" bIns="0" rtlCol="0" anchor="ctr"/>
           <a:lstStyle/>
           <a:p>
-            <a:pPr marL="0" indent="0">
+            <a:pPr indent="0" marL="0">
               <a:buNone/>
             </a:pPr>
             <a:r>
@@ -2494,7 +2626,7 @@
           </a:prstGeom>
           <a:extLst>
             <a:ext uri="{C572A759-6A51-4108-AA02-DFA0A04FC94B}">
-              <ma14:wrappingTextBoxFlag xmlns:ma14="http://schemas.microsoft.com/office/mac/drawingml/2011/main" xmlns="" val="0"/>
+              <ma14:wrappingTextBoxFlag xmlns:ma14="http://schemas.microsoft.com/office/mac/drawingml/2011/main" val="0"/>
             </a:ext>
           </a:extLst>
         </p:spPr>
@@ -2512,8 +2644,8 @@
           <a:p>
             <a:pPr algn="r"/>
             <a:fld id="{F7021451-1387-4CA6-816F-3879F97B5CBC}" type="slidenum">
-              <a:rPr lang="en-US" b="0"/>
-              <a:t>‹#›</a:t>
+              <a:rPr b="0" lang="en-US"/>
+              <a:t>1002</a:t>
             </a:fld>
             <a:endParaRPr lang="en-US"/>
           </a:p>
@@ -2535,7 +2667,6 @@
         <a:solidFill>
           <a:schemeClr val="bg1"/>
         </a:solidFill>
-        <a:effectLst/>
       </p:bgPr>
     </p:bg>
     <p:spTree>
@@ -2563,11 +2694,6 @@
 <file path=ppt/slideMasters/slideMaster1.xml><?xml version="1.0" encoding="utf-8"?>
 <p:sldMaster xmlns:a="http://schemas.openxmlformats.org/drawingml/2006/main" xmlns:r="http://schemas.openxmlformats.org/officeDocument/2006/relationships" xmlns:p="http://schemas.openxmlformats.org/presentationml/2006/main">
   <p:cSld>
-    <p:bg>
-      <p:bgRef idx="1001">
-        <a:schemeClr val="bg1"/>
-      </p:bgRef>
-    </p:bg>
     <p:spTree>
       <p:nvGrpSpPr>
         <p:cNvPr id="1" name=""/>
@@ -2602,7 +2728,7 @@
           </a:prstGeom>
           <a:extLst>
             <a:ext uri="{C572A759-6A51-4108-AA02-DFA0A04FC94B}">
-              <ma14:wrappingTextBoxFlag xmlns:ma14="http://schemas.microsoft.com/office/mac/drawingml/2011/main" xmlns="" val="0"/>
+              <ma14:wrappingTextBoxFlag xmlns:ma14="http://schemas.microsoft.com/office/mac/drawingml/2011/main" val="0"/>
             </a:ext>
           </a:extLst>
         </p:spPr>
@@ -2620,8 +2746,8 @@
           <a:p>
             <a:pPr algn="r"/>
             <a:fld id="{F7021451-1387-4CA6-816F-3879F97B5CBC}" type="slidenum">
-              <a:rPr lang="en-US" b="0"/>
-              <a:t>‹#›</a:t>
+              <a:rPr b="0" lang="en-US"/>
+              <a:t>null</a:t>
             </a:fld>
             <a:endParaRPr lang="en-US"/>
           </a:p>
@@ -2927,7 +3053,7 @@
           <a:bodyPr wrap="square" lIns="0" tIns="0" rIns="0" bIns="0" rtlCol="0" anchor="t"/>
           <a:lstStyle/>
           <a:p>
-            <a:pPr marL="0" indent="0">
+            <a:pPr indent="0" marL="0">
               <a:buNone/>
             </a:pPr>
             <a:r>
@@ -2963,7 +3089,7 @@
           <a:bodyPr wrap="square" lIns="0" tIns="0" rIns="0" bIns="0" rtlCol="0" anchor="t"/>
           <a:lstStyle/>
           <a:p>
-            <a:pPr marL="0" indent="0">
+            <a:pPr indent="0" marL="0">
               <a:buNone/>
             </a:pPr>
             <a:r>
@@ -2999,7 +3125,7 @@
           <a:bodyPr wrap="square" lIns="0" tIns="0" rIns="0" bIns="0" rtlCol="0" anchor="t"/>
           <a:lstStyle/>
           <a:p>
-            <a:pPr marL="0" indent="0">
+            <a:pPr indent="0" marL="0">
               <a:buNone/>
             </a:pPr>
             <a:r>
@@ -3035,7 +3161,7 @@
           <a:bodyPr wrap="square" lIns="0" tIns="0" rIns="0" bIns="0" rtlCol="0" anchor="t"/>
           <a:lstStyle/>
           <a:p>
-            <a:pPr marL="0" indent="0">
+            <a:pPr indent="0" marL="0">
               <a:buNone/>
             </a:pPr>
             <a:r>
@@ -3049,7 +3175,7 @@
             <a:endParaRPr lang="en-US" sz="1300" dirty="0"/>
           </a:p>
           <a:p>
-            <a:pPr marL="0" indent="0">
+            <a:pPr indent="0" marL="0">
               <a:buNone/>
             </a:pPr>
             <a:r>
@@ -3063,7 +3189,7 @@
             <a:endParaRPr lang="en-US" sz="1300" dirty="0"/>
           </a:p>
           <a:p>
-            <a:pPr marL="0" indent="0">
+            <a:pPr indent="0" marL="0">
               <a:buNone/>
             </a:pPr>
             <a:r>
@@ -3077,7 +3203,7 @@
             <a:endParaRPr lang="en-US" sz="1300" dirty="0"/>
           </a:p>
           <a:p>
-            <a:pPr marL="0" indent="0">
+            <a:pPr indent="0" marL="0">
               <a:buNone/>
             </a:pPr>
             <a:r>
@@ -3091,7 +3217,7 @@
             <a:endParaRPr lang="en-US" sz="1300" dirty="0"/>
           </a:p>
           <a:p>
-            <a:pPr marL="0" indent="0">
+            <a:pPr indent="0" marL="0">
               <a:buNone/>
             </a:pPr>
             <a:r>
@@ -3108,14 +3234,14 @@
       </p:sp>
       <p:pic>
         <p:nvPicPr>
-          <p:cNvPr id="6" name="Digital twin screenshot" descr="Screenshot of the VISTARA-X 3D digital twin: warehouse aisles, the robot and a walking person"/>
+          <p:cNvPr id="6" name="Digital twin screenshot" descr="Screenshot of the VISTARA-X 3D digital twin: warehouse aisles, the robot and a walking person">    </p:cNvPr>
           <p:cNvPicPr>
             <a:picLocks noChangeAspect="1"/>
           </p:cNvPicPr>
           <p:nvPr/>
         </p:nvPicPr>
         <p:blipFill>
-          <a:blip r:embed="rId3"/>
+          <a:blip r:embed="rId1"/>
           <a:stretch>
             <a:fillRect/>
           </a:stretch>
@@ -3173,7 +3299,7 @@
           <a:bodyPr wrap="square" lIns="0" tIns="0" rIns="0" bIns="0" rtlCol="0" anchor="t"/>
           <a:lstStyle/>
           <a:p>
-            <a:pPr marL="0" indent="0">
+            <a:pPr indent="0" marL="0">
               <a:buNone/>
             </a:pPr>
             <a:r>
@@ -3216,11 +3342,9 @@
       <p:sp>
         <p:nvSpPr>
           <p:cNvPr id="2" name="Text 0"/>
-          <p:cNvSpPr>
-            <a:spLocks noGrp="1"/>
-          </p:cNvSpPr>
+          <p:cNvSpPr/>
           <p:nvPr>
-            <p:ph type="title" idx="100" hasCustomPrompt="1"/>
+            <p:ph idx="100" type="title" hasCustomPrompt="1"/>
           </p:nvPr>
         </p:nvSpPr>
         <p:spPr>
@@ -3238,7 +3362,7 @@
           <a:bodyPr wrap="square" lIns="0" tIns="0" rIns="0" bIns="0" rtlCol="0" anchor="ctr"/>
           <a:lstStyle/>
           <a:p>
-            <a:pPr marL="0" indent="0" algn="l">
+            <a:pPr algn="l" indent="0" marL="0">
               <a:buNone/>
             </a:pPr>
             <a:r>
@@ -3255,14 +3379,14 @@
       </p:sp>
       <p:pic>
         <p:nvPicPr>
-          <p:cNvPr id="3" name="Circuit diagram" descr="Arduino Mega pin map: motor driver D5-D8, encoders D2/D24 and D3/D25, ultrasonic D30-D41, IMU D20/D21, battery A0, E-stop D26, buzzer D28, LED D13"/>
+          <p:cNvPr id="3" name="Circuit diagram" descr="Arduino Mega pin map: motor driver D5-D8, encoders D2/D24 and D3/D25, ultrasonic D30-D41, IMU D20/D21, battery A0, E-stop D26, buzzer D28, LED D13">    </p:cNvPr>
           <p:cNvPicPr>
             <a:picLocks noChangeAspect="1"/>
           </p:cNvPicPr>
           <p:nvPr/>
         </p:nvPicPr>
         <p:blipFill>
-          <a:blip r:embed="rId3"/>
+          <a:blip r:embed="rId1"/>
           <a:stretch>
             <a:fillRect/>
           </a:stretch>
@@ -3297,7 +3421,7 @@
           </a:prstGeom>
           <a:extLst>
             <a:ext uri="{C572A759-6A51-4108-AA02-DFA0A04FC94B}">
-              <ma14:wrappingTextBoxFlag xmlns:ma14="http://schemas.microsoft.com/office/mac/drawingml/2011/main" xmlns="" val="0"/>
+              <ma14:wrappingTextBoxFlag xmlns:ma14="http://schemas.microsoft.com/office/mac/drawingml/2011/main" val="0"/>
             </a:ext>
           </a:extLst>
         </p:spPr>
@@ -3315,7 +3439,7 @@
           <a:p>
             <a:pPr algn="r"/>
             <a:fld id="{F7021451-1387-4CA6-816F-3879F97B5CBC}" type="slidenum">
-              <a:rPr lang="en-US" b="0"/>
+              <a:rPr b="0" lang="en-US"/>
               <a:t>10</a:t>
             </a:fld>
             <a:endParaRPr lang="en-US"/>
@@ -3350,11 +3474,9 @@
       <p:sp>
         <p:nvSpPr>
           <p:cNvPr id="2" name="Text 0"/>
-          <p:cNvSpPr>
-            <a:spLocks noGrp="1"/>
-          </p:cNvSpPr>
+          <p:cNvSpPr/>
           <p:nvPr>
-            <p:ph type="title" idx="100" hasCustomPrompt="1"/>
+            <p:ph idx="100" type="title" hasCustomPrompt="1"/>
           </p:nvPr>
         </p:nvSpPr>
         <p:spPr>
@@ -3372,7 +3494,7 @@
           <a:bodyPr wrap="square" lIns="0" tIns="0" rIns="0" bIns="0" rtlCol="0" anchor="ctr"/>
           <a:lstStyle/>
           <a:p>
-            <a:pPr marL="0" indent="0" algn="l">
+            <a:pPr algn="l" indent="0" marL="0">
               <a:buNone/>
             </a:pPr>
             <a:r>
@@ -3389,22 +3511,22 @@
       </p:sp>
       <p:pic>
         <p:nvPicPr>
-          <p:cNvPr id="3" name="Wokwi screenshot" descr="Wokwi simulation: Arduino Mega with six HC-SR04 sensors placed around it as on the robot, IMU, E-stop, buzzer, battery knob, motor LEDs"/>
+          <p:cNvPr id="3" name="Wokwi screenshot" descr="Wokwi simulation: Arduino Mega with six HC-SR04 sensors placed around it as on the robot, IMU, E-stop, buzzer, battery knob, motor LEDs and a wire colour legend">    </p:cNvPr>
           <p:cNvPicPr>
             <a:picLocks noChangeAspect="1"/>
           </p:cNvPicPr>
           <p:nvPr/>
         </p:nvPicPr>
         <p:blipFill>
-          <a:blip r:embed="rId3"/>
+          <a:blip r:embed="rId1"/>
           <a:stretch>
             <a:fillRect/>
           </a:stretch>
         </p:blipFill>
         <p:spPr>
           <a:xfrm>
-            <a:off x="457200" y="960120"/>
-            <a:ext cx="4965192" cy="3474720"/>
+            <a:off x="457200" y="914400"/>
+            <a:ext cx="4535424" cy="3611880"/>
           </a:xfrm>
           <a:prstGeom prst="rect">
             <a:avLst/>
@@ -3419,8 +3541,8 @@
         </p:nvSpPr>
         <p:spPr>
           <a:xfrm>
-            <a:off x="457200" y="960120"/>
-            <a:ext cx="4965192" cy="3474720"/>
+            <a:off x="457200" y="914400"/>
+            <a:ext cx="4535424" cy="3611880"/>
           </a:xfrm>
           <a:prstGeom prst="rect">
             <a:avLst/>
@@ -3441,8 +3563,8 @@
         </p:nvSpPr>
         <p:spPr>
           <a:xfrm>
-            <a:off x="5715000" y="960120"/>
-            <a:ext cx="2971800" cy="320040"/>
+            <a:off x="5303520" y="914400"/>
+            <a:ext cx="3383280" cy="320040"/>
           </a:xfrm>
           <a:prstGeom prst="rect">
             <a:avLst/>
@@ -3454,7 +3576,7 @@
           <a:bodyPr wrap="square" lIns="0" tIns="0" rIns="0" bIns="0" rtlCol="0" anchor="t"/>
           <a:lstStyle/>
           <a:p>
-            <a:pPr marL="0" indent="0">
+            <a:pPr indent="0" marL="0">
               <a:buNone/>
             </a:pPr>
             <a:r>
@@ -3463,7 +3585,7 @@
                   <a:schemeClr val="tx1"/>
                 </a:solidFill>
               </a:rPr>
-              <a:t>What you can try</a:t>
+              <a:t>Press Start: a 46 s tour runs itself</a:t>
             </a:r>
             <a:endParaRPr lang="en-US" sz="1500" dirty="0"/>
           </a:p>
@@ -3477,7 +3599,7 @@
         </p:nvSpPr>
         <p:spPr>
           <a:xfrm>
-            <a:off x="5715000" y="1444752"/>
+            <a:off x="5303520" y="1399032"/>
             <a:ext cx="274320" cy="274320"/>
           </a:xfrm>
           <a:prstGeom prst="ellipse">
@@ -3502,7 +3624,7 @@
         </p:nvSpPr>
         <p:spPr>
           <a:xfrm>
-            <a:off x="5715000" y="1444752"/>
+            <a:off x="5303520" y="1399032"/>
             <a:ext cx="274320" cy="274320"/>
           </a:xfrm>
           <a:prstGeom prst="rect">
@@ -3515,7 +3637,7 @@
           <a:bodyPr wrap="square" lIns="0" tIns="0" rIns="0" bIns="0" rtlCol="0" anchor="ctr"/>
           <a:lstStyle/>
           <a:p>
-            <a:pPr marL="0" indent="0" algn="ctr">
+            <a:pPr algn="ctr" indent="0" marL="0">
               <a:buNone/>
             </a:pPr>
             <a:r>
@@ -3538,8 +3660,8 @@
         </p:nvSpPr>
         <p:spPr>
           <a:xfrm>
-            <a:off x="6126480" y="1417320"/>
-            <a:ext cx="2560320" cy="237744"/>
+            <a:off x="5715000" y="1371600"/>
+            <a:ext cx="2971800" cy="237744"/>
           </a:xfrm>
           <a:prstGeom prst="rect">
             <a:avLst/>
@@ -3551,7 +3673,7 @@
           <a:bodyPr wrap="square" lIns="0" tIns="0" rIns="0" bIns="0" rtlCol="0" anchor="t"/>
           <a:lstStyle/>
           <a:p>
-            <a:pPr marL="0" indent="0">
+            <a:pPr indent="0" marL="0">
               <a:buNone/>
             </a:pPr>
             <a:r>
@@ -3560,7 +3682,7 @@
                   <a:schemeClr val="tx1"/>
                 </a:solidFill>
               </a:rPr>
-              <a:t>Type D</a:t>
+              <a:t>Drive forward</a:t>
             </a:r>
             <a:endParaRPr lang="en-US" sz="1300" dirty="0"/>
           </a:p>
@@ -3574,8 +3696,8 @@
         </p:nvSpPr>
         <p:spPr>
           <a:xfrm>
-            <a:off x="6126480" y="1664208"/>
-            <a:ext cx="2560320" cy="237744"/>
+            <a:off x="5715000" y="1618488"/>
+            <a:ext cx="2971800" cy="237744"/>
           </a:xfrm>
           <a:prstGeom prst="rect">
             <a:avLst/>
@@ -3587,7 +3709,7 @@
           <a:bodyPr wrap="square" lIns="0" tIns="0" rIns="0" bIns="0" rtlCol="0" anchor="t"/>
           <a:lstStyle/>
           <a:p>
-            <a:pPr marL="0" indent="0">
+            <a:pPr indent="0" marL="0">
               <a:buNone/>
             </a:pPr>
             <a:r>
@@ -3596,7 +3718,7 @@
                   <a:schemeClr val="accent5"/>
                 </a:solidFill>
               </a:rPr>
-              <a:t>motor LEDs light up</a:t>
+              <a:t>green motor LEDs light up</a:t>
             </a:r>
             <a:endParaRPr lang="en-US" sz="1200" dirty="0"/>
           </a:p>
@@ -3610,7 +3732,7 @@
         </p:nvSpPr>
         <p:spPr>
           <a:xfrm>
-            <a:off x="5715000" y="2011680"/>
+            <a:off x="5303520" y="1947672"/>
             <a:ext cx="274320" cy="274320"/>
           </a:xfrm>
           <a:prstGeom prst="ellipse">
@@ -3635,7 +3757,7 @@
         </p:nvSpPr>
         <p:spPr>
           <a:xfrm>
-            <a:off x="5715000" y="2011680"/>
+            <a:off x="5303520" y="1947672"/>
             <a:ext cx="274320" cy="274320"/>
           </a:xfrm>
           <a:prstGeom prst="rect">
@@ -3648,7 +3770,7 @@
           <a:bodyPr wrap="square" lIns="0" tIns="0" rIns="0" bIns="0" rtlCol="0" anchor="ctr"/>
           <a:lstStyle/>
           <a:p>
-            <a:pPr marL="0" indent="0" algn="ctr">
+            <a:pPr algn="ctr" indent="0" marL="0">
               <a:buNone/>
             </a:pPr>
             <a:r>
@@ -3671,8 +3793,8 @@
         </p:nvSpPr>
         <p:spPr>
           <a:xfrm>
-            <a:off x="6126480" y="1984248"/>
-            <a:ext cx="2560320" cy="237744"/>
+            <a:off x="5715000" y="1920240"/>
+            <a:ext cx="2971800" cy="237744"/>
           </a:xfrm>
           <a:prstGeom prst="rect">
             <a:avLst/>
@@ -3684,7 +3806,7 @@
           <a:bodyPr wrap="square" lIns="0" tIns="0" rIns="0" bIns="0" rtlCol="0" anchor="t"/>
           <a:lstStyle/>
           <a:p>
-            <a:pPr marL="0" indent="0">
+            <a:pPr indent="0" marL="0">
               <a:buNone/>
             </a:pPr>
             <a:r>
@@ -3693,7 +3815,7 @@
                   <a:schemeClr val="tx1"/>
                 </a:solidFill>
               </a:rPr>
-              <a:t>Front sensor to 60 cm</a:t>
+              <a:t>A person walks in front</a:t>
             </a:r>
             <a:endParaRPr lang="en-US" sz="1300" dirty="0"/>
           </a:p>
@@ -3707,8 +3829,8 @@
         </p:nvSpPr>
         <p:spPr>
           <a:xfrm>
-            <a:off x="6126480" y="2231136"/>
-            <a:ext cx="2560320" cy="237744"/>
+            <a:off x="5715000" y="2167128"/>
+            <a:ext cx="2971800" cy="237744"/>
           </a:xfrm>
           <a:prstGeom prst="rect">
             <a:avLst/>
@@ -3720,7 +3842,7 @@
           <a:bodyPr wrap="square" lIns="0" tIns="0" rIns="0" bIns="0" rtlCol="0" anchor="t"/>
           <a:lstStyle/>
           <a:p>
-            <a:pPr marL="0" indent="0">
+            <a:pPr indent="0" marL="0">
               <a:buNone/>
             </a:pPr>
             <a:r>
@@ -3729,7 +3851,7 @@
                   <a:schemeClr val="accent5"/>
                 </a:solidFill>
               </a:rPr>
-              <a:t>robot slows down</a:t>
+              <a:t>slows at 0.9 m, stops at 0.3 m</a:t>
             </a:r>
             <a:endParaRPr lang="en-US" sz="1200" dirty="0"/>
           </a:p>
@@ -3743,7 +3865,7 @@
         </p:nvSpPr>
         <p:spPr>
           <a:xfrm>
-            <a:off x="5715000" y="2578608"/>
+            <a:off x="5303520" y="2496312"/>
             <a:ext cx="274320" cy="274320"/>
           </a:xfrm>
           <a:prstGeom prst="ellipse">
@@ -3768,7 +3890,7 @@
         </p:nvSpPr>
         <p:spPr>
           <a:xfrm>
-            <a:off x="5715000" y="2578608"/>
+            <a:off x="5303520" y="2496312"/>
             <a:ext cx="274320" cy="274320"/>
           </a:xfrm>
           <a:prstGeom prst="rect">
@@ -3781,7 +3903,7 @@
           <a:bodyPr wrap="square" lIns="0" tIns="0" rIns="0" bIns="0" rtlCol="0" anchor="ctr"/>
           <a:lstStyle/>
           <a:p>
-            <a:pPr marL="0" indent="0" algn="ctr">
+            <a:pPr algn="ctr" indent="0" marL="0">
               <a:buNone/>
             </a:pPr>
             <a:r>
@@ -3804,8 +3926,8 @@
         </p:nvSpPr>
         <p:spPr>
           <a:xfrm>
-            <a:off x="6126480" y="2551176"/>
-            <a:ext cx="2560320" cy="237744"/>
+            <a:off x="5715000" y="2468880"/>
+            <a:ext cx="2971800" cy="237744"/>
           </a:xfrm>
           <a:prstGeom prst="rect">
             <a:avLst/>
@@ -3817,7 +3939,7 @@
           <a:bodyPr wrap="square" lIns="0" tIns="0" rIns="0" bIns="0" rtlCol="0" anchor="t"/>
           <a:lstStyle/>
           <a:p>
-            <a:pPr marL="0" indent="0">
+            <a:pPr indent="0" marL="0">
               <a:buNone/>
             </a:pPr>
             <a:r>
@@ -3826,7 +3948,7 @@
                   <a:schemeClr val="tx1"/>
                 </a:solidFill>
               </a:rPr>
-              <a:t>Front sensor to 20 cm</a:t>
+              <a:t>Laptop freezes</a:t>
             </a:r>
             <a:endParaRPr lang="en-US" sz="1300" dirty="0"/>
           </a:p>
@@ -3840,8 +3962,8 @@
         </p:nvSpPr>
         <p:spPr>
           <a:xfrm>
-            <a:off x="6126480" y="2798064"/>
-            <a:ext cx="2560320" cy="237744"/>
+            <a:off x="5715000" y="2715768"/>
+            <a:ext cx="2971800" cy="237744"/>
           </a:xfrm>
           <a:prstGeom prst="rect">
             <a:avLst/>
@@ -3853,7 +3975,7 @@
           <a:bodyPr wrap="square" lIns="0" tIns="0" rIns="0" bIns="0" rtlCol="0" anchor="t"/>
           <a:lstStyle/>
           <a:p>
-            <a:pPr marL="0" indent="0">
+            <a:pPr indent="0" marL="0">
               <a:buNone/>
             </a:pPr>
             <a:r>
@@ -3862,7 +3984,7 @@
                   <a:schemeClr val="accent5"/>
                 </a:solidFill>
               </a:rPr>
-              <a:t>robot stops, buzzer</a:t>
+              <a:t>watchdog stops it in 0.5 s</a:t>
             </a:r>
             <a:endParaRPr lang="en-US" sz="1200" dirty="0"/>
           </a:p>
@@ -3876,7 +3998,7 @@
         </p:nvSpPr>
         <p:spPr>
           <a:xfrm>
-            <a:off x="5715000" y="3145536"/>
+            <a:off x="5303520" y="3044952"/>
             <a:ext cx="274320" cy="274320"/>
           </a:xfrm>
           <a:prstGeom prst="ellipse">
@@ -3901,7 +4023,7 @@
         </p:nvSpPr>
         <p:spPr>
           <a:xfrm>
-            <a:off x="5715000" y="3145536"/>
+            <a:off x="5303520" y="3044952"/>
             <a:ext cx="274320" cy="274320"/>
           </a:xfrm>
           <a:prstGeom prst="rect">
@@ -3914,7 +4036,7 @@
           <a:bodyPr wrap="square" lIns="0" tIns="0" rIns="0" bIns="0" rtlCol="0" anchor="ctr"/>
           <a:lstStyle/>
           <a:p>
-            <a:pPr marL="0" indent="0" algn="ctr">
+            <a:pPr algn="ctr" indent="0" marL="0">
               <a:buNone/>
             </a:pPr>
             <a:r>
@@ -3937,8 +4059,8 @@
         </p:nvSpPr>
         <p:spPr>
           <a:xfrm>
-            <a:off x="6126480" y="3118104"/>
-            <a:ext cx="2560320" cy="237744"/>
+            <a:off x="5715000" y="3017520"/>
+            <a:ext cx="2971800" cy="237744"/>
           </a:xfrm>
           <a:prstGeom prst="rect">
             <a:avLst/>
@@ -3950,7 +4072,7 @@
           <a:bodyPr wrap="square" lIns="0" tIns="0" rIns="0" bIns="0" rtlCol="0" anchor="t"/>
           <a:lstStyle/>
           <a:p>
-            <a:pPr marL="0" indent="0">
+            <a:pPr indent="0" marL="0">
               <a:buNone/>
             </a:pPr>
             <a:r>
@@ -3959,7 +4081,7 @@
                   <a:schemeClr val="tx1"/>
                 </a:solidFill>
               </a:rPr>
-              <a:t>Press E-STOP</a:t>
+              <a:t>Battery low, then empty</a:t>
             </a:r>
             <a:endParaRPr lang="en-US" sz="1300" dirty="0"/>
           </a:p>
@@ -3973,8 +4095,8 @@
         </p:nvSpPr>
         <p:spPr>
           <a:xfrm>
-            <a:off x="6126480" y="3364992"/>
-            <a:ext cx="2560320" cy="237744"/>
+            <a:off x="5715000" y="3264408"/>
+            <a:ext cx="2971800" cy="237744"/>
           </a:xfrm>
           <a:prstGeom prst="rect">
             <a:avLst/>
@@ -3986,7 +4108,7 @@
           <a:bodyPr wrap="square" lIns="0" tIns="0" rIns="0" bIns="0" rtlCol="0" anchor="t"/>
           <a:lstStyle/>
           <a:p>
-            <a:pPr marL="0" indent="0">
+            <a:pPr indent="0" marL="0">
               <a:buNone/>
             </a:pPr>
             <a:r>
@@ -3995,7 +4117,7 @@
                   <a:schemeClr val="accent5"/>
                 </a:solidFill>
               </a:rPr>
-              <a:t>instant stop, stays latched</a:t>
+              <a:t>half speed, then motors off</a:t>
             </a:r>
             <a:endParaRPr lang="en-US" sz="1200" dirty="0"/>
           </a:p>
@@ -4009,7 +4131,7 @@
         </p:nvSpPr>
         <p:spPr>
           <a:xfrm>
-            <a:off x="5715000" y="3712464"/>
+            <a:off x="5303520" y="3593592"/>
             <a:ext cx="274320" cy="274320"/>
           </a:xfrm>
           <a:prstGeom prst="ellipse">
@@ -4034,7 +4156,7 @@
         </p:nvSpPr>
         <p:spPr>
           <a:xfrm>
-            <a:off x="5715000" y="3712464"/>
+            <a:off x="5303520" y="3593592"/>
             <a:ext cx="274320" cy="274320"/>
           </a:xfrm>
           <a:prstGeom prst="rect">
@@ -4047,7 +4169,7 @@
           <a:bodyPr wrap="square" lIns="0" tIns="0" rIns="0" bIns="0" rtlCol="0" anchor="ctr"/>
           <a:lstStyle/>
           <a:p>
-            <a:pPr marL="0" indent="0" algn="ctr">
+            <a:pPr algn="ctr" indent="0" marL="0">
               <a:buNone/>
             </a:pPr>
             <a:r>
@@ -4070,8 +4192,8 @@
         </p:nvSpPr>
         <p:spPr>
           <a:xfrm>
-            <a:off x="6126480" y="3685032"/>
-            <a:ext cx="2560320" cy="237744"/>
+            <a:off x="5715000" y="3566160"/>
+            <a:ext cx="2971800" cy="237744"/>
           </a:xfrm>
           <a:prstGeom prst="rect">
             <a:avLst/>
@@ -4083,7 +4205,7 @@
           <a:bodyPr wrap="square" lIns="0" tIns="0" rIns="0" bIns="0" rtlCol="0" anchor="t"/>
           <a:lstStyle/>
           <a:p>
-            <a:pPr marL="0" indent="0">
+            <a:pPr indent="0" marL="0">
               <a:buNone/>
             </a:pPr>
             <a:r>
@@ -4092,7 +4214,7 @@
                   <a:schemeClr val="tx1"/>
                 </a:solidFill>
               </a:rPr>
-              <a:t>Turn the battery knob</a:t>
+              <a:t>E-STOP pressed</a:t>
             </a:r>
             <a:endParaRPr lang="en-US" sz="1300" dirty="0"/>
           </a:p>
@@ -4106,8 +4228,8 @@
         </p:nvSpPr>
         <p:spPr>
           <a:xfrm>
-            <a:off x="6126480" y="3931920"/>
-            <a:ext cx="2560320" cy="237744"/>
+            <a:off x="5715000" y="3813048"/>
+            <a:ext cx="2971800" cy="237744"/>
           </a:xfrm>
           <a:prstGeom prst="rect">
             <a:avLst/>
@@ -4119,7 +4241,7 @@
           <a:bodyPr wrap="square" lIns="0" tIns="0" rIns="0" bIns="0" rtlCol="0" anchor="t"/>
           <a:lstStyle/>
           <a:p>
-            <a:pPr marL="0" indent="0">
+            <a:pPr indent="0" marL="0">
               <a:buNone/>
             </a:pPr>
             <a:r>
@@ -4128,7 +4250,7 @@
                   <a:schemeClr val="accent5"/>
                 </a:solidFill>
               </a:rPr>
-              <a:t>half speed, then stop</a:t>
+              <a:t>instant stop until reset</a:t>
             </a:r>
             <a:endParaRPr lang="en-US" sz="1200" dirty="0"/>
           </a:p>
@@ -4142,8 +4264,8 @@
         </p:nvSpPr>
         <p:spPr>
           <a:xfrm>
-            <a:off x="5715000" y="4206240"/>
-            <a:ext cx="2971800" cy="228600"/>
+            <a:off x="5303520" y="4114800"/>
+            <a:ext cx="3383280" cy="411480"/>
           </a:xfrm>
           <a:prstGeom prst="rect">
             <a:avLst/>
@@ -4155,7 +4277,7 @@
           <a:bodyPr wrap="square" lIns="0" tIns="0" rIns="0" bIns="0" rtlCol="0" anchor="t"/>
           <a:lstStyle/>
           <a:p>
-            <a:pPr marL="0" indent="0">
+            <a:pPr indent="0" marL="0">
               <a:buNone/>
             </a:pPr>
             <a:r>
@@ -4164,7 +4286,7 @@
                   <a:schemeClr val="accent5"/>
                 </a:solidFill>
               </a:rPr>
-              <a:t>Firmware and diagram.json: hardware/firmware/vistara_mega</a:t>
+              <a:t>Each step is explained in the serial monitor. Sliders, knob and button also work by hand.</a:t>
             </a:r>
             <a:endParaRPr lang="en-US" sz="1000" dirty="0"/>
           </a:p>
@@ -4172,7 +4294,7 @@
       </p:sp>
       <p:sp>
         <p:nvSpPr>
-          <p:cNvPr id="27" name="Slide Number Placeholder 0"/>
+          <p:cNvPr id="25" name="Slide Number Placeholder 0"/>
           <p:cNvSpPr>
             <a:spLocks noGrp="1"/>
           </p:cNvSpPr>
@@ -4190,7 +4312,7 @@
           </a:prstGeom>
           <a:extLst>
             <a:ext uri="{C572A759-6A51-4108-AA02-DFA0A04FC94B}">
-              <ma14:wrappingTextBoxFlag xmlns:ma14="http://schemas.microsoft.com/office/mac/drawingml/2011/main" xmlns="" val="0"/>
+              <ma14:wrappingTextBoxFlag xmlns:ma14="http://schemas.microsoft.com/office/mac/drawingml/2011/main" val="0"/>
             </a:ext>
           </a:extLst>
         </p:spPr>
@@ -4208,7 +4330,7 @@
           <a:p>
             <a:pPr algn="r"/>
             <a:fld id="{F7021451-1387-4CA6-816F-3879F97B5CBC}" type="slidenum">
-              <a:rPr lang="en-US" b="0"/>
+              <a:rPr b="0" lang="en-US"/>
               <a:t>11</a:t>
             </a:fld>
             <a:endParaRPr lang="en-US"/>
@@ -4243,11 +4365,9 @@
       <p:sp>
         <p:nvSpPr>
           <p:cNvPr id="2" name="Text 0"/>
-          <p:cNvSpPr>
-            <a:spLocks noGrp="1"/>
-          </p:cNvSpPr>
+          <p:cNvSpPr/>
           <p:nvPr>
-            <p:ph type="title" idx="100" hasCustomPrompt="1"/>
+            <p:ph idx="100" type="title" hasCustomPrompt="1"/>
           </p:nvPr>
         </p:nvSpPr>
         <p:spPr>
@@ -4265,7 +4385,7 @@
           <a:bodyPr wrap="square" lIns="0" tIns="0" rIns="0" bIns="0" rtlCol="0" anchor="ctr"/>
           <a:lstStyle/>
           <a:p>
-            <a:pPr marL="0" indent="0" algn="l">
+            <a:pPr algn="l" indent="0" marL="0">
               <a:buNone/>
             </a:pPr>
             <a:r>
@@ -4282,7 +4402,7 @@
       </p:sp>
       <p:graphicFrame>
         <p:nvGraphicFramePr>
-          <p:cNvPr id="3" name="Chart 0"/>
+          <p:cNvPr id="3" name="Chart 0" descr=""/>
           <p:cNvGraphicFramePr/>
           <p:nvPr/>
         </p:nvGraphicFramePr>
@@ -4290,9 +4410,9 @@
           <a:off x="365760" y="914400"/>
           <a:ext cx="4572000" cy="3474720"/>
         </p:xfrm>
-        <a:graphic>
+        <a:graphic xmlns:a="http://schemas.openxmlformats.org/drawingml/2006/main">
           <a:graphicData uri="http://schemas.openxmlformats.org/drawingml/2006/chart">
-            <c:chart xmlns:c="http://schemas.openxmlformats.org/drawingml/2006/chart" xmlns:r="http://schemas.openxmlformats.org/officeDocument/2006/relationships" r:id="rId3"/>
+            <c:chart xmlns:c="http://schemas.openxmlformats.org/drawingml/2006/chart" r:id="rId1"/>
           </a:graphicData>
         </a:graphic>
       </p:graphicFrame>
@@ -4317,7 +4437,7 @@
           <a:bodyPr wrap="square" lIns="0" tIns="0" rIns="0" bIns="0" rtlCol="0" anchor="t"/>
           <a:lstStyle/>
           <a:p>
-            <a:pPr marL="0" indent="0">
+            <a:pPr indent="0" marL="0">
               <a:buNone/>
             </a:pPr>
             <a:r>
@@ -4353,7 +4473,7 @@
           <a:bodyPr wrap="square" lIns="0" tIns="0" rIns="0" bIns="0" rtlCol="0" anchor="t"/>
           <a:lstStyle/>
           <a:p>
-            <a:pPr marL="0" indent="0">
+            <a:pPr indent="0" marL="0">
               <a:buNone/>
             </a:pPr>
             <a:r>
@@ -4389,7 +4509,7 @@
           <a:bodyPr wrap="square" lIns="0" tIns="0" rIns="0" bIns="0" rtlCol="0" anchor="t"/>
           <a:lstStyle/>
           <a:p>
-            <a:pPr marL="0" indent="0">
+            <a:pPr indent="0" marL="0">
               <a:buNone/>
             </a:pPr>
             <a:r>
@@ -4425,7 +4545,7 @@
           <a:bodyPr wrap="square" lIns="0" tIns="0" rIns="0" bIns="0" rtlCol="0" anchor="t"/>
           <a:lstStyle/>
           <a:p>
-            <a:pPr marL="0" indent="0">
+            <a:pPr indent="0" marL="0">
               <a:buNone/>
             </a:pPr>
             <a:r>
@@ -4461,7 +4581,7 @@
           <a:bodyPr wrap="square" lIns="0" tIns="0" rIns="0" bIns="0" rtlCol="0" anchor="t"/>
           <a:lstStyle/>
           <a:p>
-            <a:pPr marL="0" indent="0">
+            <a:pPr indent="0" marL="0">
               <a:buNone/>
             </a:pPr>
             <a:r>
@@ -4497,7 +4617,7 @@
           <a:bodyPr wrap="square" lIns="0" tIns="0" rIns="0" bIns="0" rtlCol="0" anchor="t"/>
           <a:lstStyle/>
           <a:p>
-            <a:pPr marL="0" indent="0">
+            <a:pPr indent="0" marL="0">
               <a:buNone/>
             </a:pPr>
             <a:r>
@@ -4533,7 +4653,7 @@
           <a:bodyPr wrap="square" lIns="0" tIns="0" rIns="0" bIns="0" rtlCol="0" anchor="t"/>
           <a:lstStyle/>
           <a:p>
-            <a:pPr marL="0" indent="0">
+            <a:pPr indent="0" marL="0">
               <a:buNone/>
             </a:pPr>
             <a:r>
@@ -4568,7 +4688,7 @@
           </a:prstGeom>
           <a:extLst>
             <a:ext uri="{C572A759-6A51-4108-AA02-DFA0A04FC94B}">
-              <ma14:wrappingTextBoxFlag xmlns:ma14="http://schemas.microsoft.com/office/mac/drawingml/2011/main" xmlns="" val="0"/>
+              <ma14:wrappingTextBoxFlag xmlns:ma14="http://schemas.microsoft.com/office/mac/drawingml/2011/main" val="0"/>
             </a:ext>
           </a:extLst>
         </p:spPr>
@@ -4586,7 +4706,7 @@
           <a:p>
             <a:pPr algn="r"/>
             <a:fld id="{F7021451-1387-4CA6-816F-3879F97B5CBC}" type="slidenum">
-              <a:rPr lang="en-US" b="0"/>
+              <a:rPr b="0" lang="en-US"/>
               <a:t>12</a:t>
             </a:fld>
             <a:endParaRPr lang="en-US"/>
@@ -4621,11 +4741,9 @@
       <p:sp>
         <p:nvSpPr>
           <p:cNvPr id="2" name="Text 0"/>
-          <p:cNvSpPr>
-            <a:spLocks noGrp="1"/>
-          </p:cNvSpPr>
+          <p:cNvSpPr/>
           <p:nvPr>
-            <p:ph type="title" idx="100" hasCustomPrompt="1"/>
+            <p:ph idx="100" type="title" hasCustomPrompt="1"/>
           </p:nvPr>
         </p:nvSpPr>
         <p:spPr>
@@ -4643,7 +4761,7 @@
           <a:bodyPr wrap="square" lIns="0" tIns="0" rIns="0" bIns="0" rtlCol="0" anchor="ctr"/>
           <a:lstStyle/>
           <a:p>
-            <a:pPr marL="0" indent="0" algn="l">
+            <a:pPr algn="l" indent="0" marL="0">
               <a:buNone/>
             </a:pPr>
             <a:r>
@@ -4727,7 +4845,7 @@
           <a:bodyPr wrap="square" lIns="0" tIns="0" rIns="0" bIns="0" rtlCol="0" anchor="t"/>
           <a:lstStyle/>
           <a:p>
-            <a:pPr marL="0" indent="0" algn="ctr">
+            <a:pPr algn="ctr" indent="0" marL="0">
               <a:buNone/>
             </a:pPr>
             <a:r>
@@ -4763,7 +4881,7 @@
           <a:bodyPr wrap="square" lIns="0" tIns="0" rIns="0" bIns="0" rtlCol="0" anchor="t"/>
           <a:lstStyle/>
           <a:p>
-            <a:pPr marL="0" indent="0" algn="ctr">
+            <a:pPr algn="ctr" indent="0" marL="0">
               <a:buNone/>
             </a:pPr>
             <a:r>
@@ -4799,7 +4917,7 @@
           <a:bodyPr wrap="square" lIns="0" tIns="0" rIns="0" bIns="0" rtlCol="0" anchor="t"/>
           <a:lstStyle/>
           <a:p>
-            <a:pPr marL="0" indent="0" algn="ctr">
+            <a:pPr algn="ctr" indent="0" marL="0">
               <a:buNone/>
             </a:pPr>
             <a:r>
@@ -4860,7 +4978,7 @@
           <a:bodyPr wrap="square" lIns="0" tIns="0" rIns="0" bIns="0" rtlCol="0" anchor="t"/>
           <a:lstStyle/>
           <a:p>
-            <a:pPr marL="0" indent="0" algn="ctr">
+            <a:pPr algn="ctr" indent="0" marL="0">
               <a:buNone/>
             </a:pPr>
             <a:r>
@@ -4896,7 +5014,7 @@
           <a:bodyPr wrap="square" lIns="0" tIns="0" rIns="0" bIns="0" rtlCol="0" anchor="t"/>
           <a:lstStyle/>
           <a:p>
-            <a:pPr marL="0" indent="0" algn="ctr">
+            <a:pPr algn="ctr" indent="0" marL="0">
               <a:buNone/>
             </a:pPr>
             <a:r>
@@ -4932,7 +5050,7 @@
           <a:bodyPr wrap="square" lIns="0" tIns="0" rIns="0" bIns="0" rtlCol="0" anchor="t"/>
           <a:lstStyle/>
           <a:p>
-            <a:pPr marL="0" indent="0" algn="ctr">
+            <a:pPr algn="ctr" indent="0" marL="0">
               <a:buNone/>
             </a:pPr>
             <a:r>
@@ -4993,7 +5111,7 @@
           <a:bodyPr wrap="square" lIns="0" tIns="0" rIns="0" bIns="0" rtlCol="0" anchor="t"/>
           <a:lstStyle/>
           <a:p>
-            <a:pPr marL="0" indent="0" algn="ctr">
+            <a:pPr algn="ctr" indent="0" marL="0">
               <a:buNone/>
             </a:pPr>
             <a:r>
@@ -5029,7 +5147,7 @@
           <a:bodyPr wrap="square" lIns="0" tIns="0" rIns="0" bIns="0" rtlCol="0" anchor="t"/>
           <a:lstStyle/>
           <a:p>
-            <a:pPr marL="0" indent="0" algn="ctr">
+            <a:pPr algn="ctr" indent="0" marL="0">
               <a:buNone/>
             </a:pPr>
             <a:r>
@@ -5065,7 +5183,7 @@
           <a:bodyPr wrap="square" lIns="0" tIns="0" rIns="0" bIns="0" rtlCol="0" anchor="t"/>
           <a:lstStyle/>
           <a:p>
-            <a:pPr marL="0" indent="0" algn="ctr">
+            <a:pPr algn="ctr" indent="0" marL="0">
               <a:buNone/>
             </a:pPr>
             <a:r>
@@ -5126,7 +5244,7 @@
           <a:bodyPr wrap="square" lIns="0" tIns="0" rIns="0" bIns="0" rtlCol="0" anchor="t"/>
           <a:lstStyle/>
           <a:p>
-            <a:pPr marL="0" indent="0" algn="ctr">
+            <a:pPr algn="ctr" indent="0" marL="0">
               <a:buNone/>
             </a:pPr>
             <a:r>
@@ -5162,7 +5280,7 @@
           <a:bodyPr wrap="square" lIns="0" tIns="0" rIns="0" bIns="0" rtlCol="0" anchor="t"/>
           <a:lstStyle/>
           <a:p>
-            <a:pPr marL="0" indent="0" algn="ctr">
+            <a:pPr algn="ctr" indent="0" marL="0">
               <a:buNone/>
             </a:pPr>
             <a:r>
@@ -5198,7 +5316,7 @@
           <a:bodyPr wrap="square" lIns="0" tIns="0" rIns="0" bIns="0" rtlCol="0" anchor="t"/>
           <a:lstStyle/>
           <a:p>
-            <a:pPr marL="0" indent="0" algn="ctr">
+            <a:pPr algn="ctr" indent="0" marL="0">
               <a:buNone/>
             </a:pPr>
             <a:r>
@@ -5259,7 +5377,7 @@
           <a:bodyPr wrap="square" lIns="0" tIns="0" rIns="0" bIns="0" rtlCol="0" anchor="t"/>
           <a:lstStyle/>
           <a:p>
-            <a:pPr marL="0" indent="0" algn="ctr">
+            <a:pPr algn="ctr" indent="0" marL="0">
               <a:buNone/>
             </a:pPr>
             <a:r>
@@ -5295,7 +5413,7 @@
           <a:bodyPr wrap="square" lIns="0" tIns="0" rIns="0" bIns="0" rtlCol="0" anchor="t"/>
           <a:lstStyle/>
           <a:p>
-            <a:pPr marL="0" indent="0" algn="ctr">
+            <a:pPr algn="ctr" indent="0" marL="0">
               <a:buNone/>
             </a:pPr>
             <a:r>
@@ -5331,7 +5449,7 @@
           <a:bodyPr wrap="square" lIns="0" tIns="0" rIns="0" bIns="0" rtlCol="0" anchor="t"/>
           <a:lstStyle/>
           <a:p>
-            <a:pPr marL="0" indent="0" algn="ctr">
+            <a:pPr algn="ctr" indent="0" marL="0">
               <a:buNone/>
             </a:pPr>
             <a:r>
@@ -5392,7 +5510,7 @@
           <a:bodyPr wrap="square" lIns="0" tIns="0" rIns="0" bIns="0" rtlCol="0" anchor="t"/>
           <a:lstStyle/>
           <a:p>
-            <a:pPr marL="0" indent="0" algn="ctr">
+            <a:pPr algn="ctr" indent="0" marL="0">
               <a:buNone/>
             </a:pPr>
             <a:r>
@@ -5428,7 +5546,7 @@
           <a:bodyPr wrap="square" lIns="0" tIns="0" rIns="0" bIns="0" rtlCol="0" anchor="t"/>
           <a:lstStyle/>
           <a:p>
-            <a:pPr marL="0" indent="0" algn="ctr">
+            <a:pPr algn="ctr" indent="0" marL="0">
               <a:buNone/>
             </a:pPr>
             <a:r>
@@ -5464,7 +5582,7 @@
           <a:bodyPr wrap="square" lIns="0" tIns="0" rIns="0" bIns="0" rtlCol="0" anchor="t"/>
           <a:lstStyle/>
           <a:p>
-            <a:pPr marL="0" indent="0" algn="ctr">
+            <a:pPr algn="ctr" indent="0" marL="0">
               <a:buNone/>
             </a:pPr>
             <a:r>
@@ -5520,7 +5638,7 @@
           <a:bodyPr wrap="square" lIns="0" tIns="0" rIns="0" bIns="0" rtlCol="0" anchor="t"/>
           <a:lstStyle/>
           <a:p>
-            <a:pPr marL="0" indent="0">
+            <a:pPr indent="0" marL="0">
               <a:buNone/>
             </a:pPr>
             <a:r>
@@ -5534,7 +5652,7 @@
             <a:endParaRPr lang="en-US" sz="1200" dirty="0"/>
           </a:p>
           <a:p>
-            <a:pPr marL="0" indent="0">
+            <a:pPr indent="0" marL="0">
               <a:buNone/>
             </a:pPr>
             <a:r>
@@ -5590,7 +5708,7 @@
           <a:bodyPr wrap="square" lIns="0" tIns="0" rIns="0" bIns="0" rtlCol="0" anchor="t"/>
           <a:lstStyle/>
           <a:p>
-            <a:pPr marL="0" indent="0">
+            <a:pPr indent="0" marL="0">
               <a:buNone/>
             </a:pPr>
             <a:r>
@@ -5604,7 +5722,7 @@
             <a:endParaRPr lang="en-US" sz="1200" dirty="0"/>
           </a:p>
           <a:p>
-            <a:pPr marL="0" indent="0">
+            <a:pPr indent="0" marL="0">
               <a:buNone/>
             </a:pPr>
             <a:r>
@@ -5621,7 +5739,7 @@
       </p:sp>
       <p:sp>
         <p:nvSpPr>
-          <p:cNvPr id="32" name="Slide Number Placeholder 0"/>
+          <p:cNvPr id="25" name="Slide Number Placeholder 0"/>
           <p:cNvSpPr>
             <a:spLocks noGrp="1"/>
           </p:cNvSpPr>
@@ -5639,7 +5757,7 @@
           </a:prstGeom>
           <a:extLst>
             <a:ext uri="{C572A759-6A51-4108-AA02-DFA0A04FC94B}">
-              <ma14:wrappingTextBoxFlag xmlns:ma14="http://schemas.microsoft.com/office/mac/drawingml/2011/main" xmlns="" val="0"/>
+              <ma14:wrappingTextBoxFlag xmlns:ma14="http://schemas.microsoft.com/office/mac/drawingml/2011/main" val="0"/>
             </a:ext>
           </a:extLst>
         </p:spPr>
@@ -5657,7 +5775,7 @@
           <a:p>
             <a:pPr algn="r"/>
             <a:fld id="{F7021451-1387-4CA6-816F-3879F97B5CBC}" type="slidenum">
-              <a:rPr lang="en-US" b="0"/>
+              <a:rPr b="0" lang="en-US"/>
               <a:t>13</a:t>
             </a:fld>
             <a:endParaRPr lang="en-US"/>
@@ -5710,7 +5828,7 @@
           <a:bodyPr wrap="square" lIns="0" tIns="0" rIns="0" bIns="0" rtlCol="0" anchor="t"/>
           <a:lstStyle/>
           <a:p>
-            <a:pPr marL="0" indent="0">
+            <a:pPr indent="0" marL="0">
               <a:buNone/>
             </a:pPr>
             <a:r>
@@ -5746,7 +5864,7 @@
           <a:bodyPr wrap="square" lIns="0" tIns="0" rIns="0" bIns="0" rtlCol="0" anchor="t"/>
           <a:lstStyle/>
           <a:p>
-            <a:pPr marL="0" indent="0">
+            <a:pPr indent="0" marL="0">
               <a:buNone/>
             </a:pPr>
             <a:r>
@@ -5782,7 +5900,7 @@
           <a:bodyPr wrap="square" lIns="0" tIns="0" rIns="0" bIns="0" rtlCol="0" anchor="t"/>
           <a:lstStyle/>
           <a:p>
-            <a:pPr marL="0" indent="0">
+            <a:pPr indent="0" marL="0">
               <a:buNone/>
             </a:pPr>
             <a:r>
@@ -5790,7 +5908,7 @@
                 <a:solidFill>
                   <a:schemeClr val="accent1"/>
                 </a:solidFill>
-                <a:hlinkClick r:id="rId3">
+                <a:hlinkClick r:id="rId1" invalidUrl="" action="" tgtFrame="" tooltip="" history="1" highlightClick="0" endSnd="0">
                   <a:extLst>
                     <a:ext uri="{A12FA001-AC4F-418D-AE19-62706E023703}">
                       <ahyp:hlinkClr xmlns:ahyp="http://schemas.microsoft.com/office/drawing/2018/hyperlinkcolor" val="tx"/>
@@ -5825,7 +5943,7 @@
           <a:bodyPr wrap="square" lIns="0" tIns="0" rIns="0" bIns="0" rtlCol="0" anchor="t"/>
           <a:lstStyle/>
           <a:p>
-            <a:pPr marL="0" indent="0">
+            <a:pPr indent="0" marL="0">
               <a:buNone/>
             </a:pPr>
             <a:r>
@@ -5837,6 +5955,66 @@
               <a:t>Team Hack01  |  Ritesh Kumar, Kainat Afrazi</a:t>
             </a:r>
             <a:endParaRPr lang="en-US" sz="1200" dirty="0"/>
+          </a:p>
+        </p:txBody>
+      </p:sp>
+      <p:pic>
+        <p:nvPicPr>
+          <p:cNvPr id="6" name="GitHub QR code" descr="QR code linking to the VISTARA-X GitHub repository">    </p:cNvPr>
+          <p:cNvPicPr>
+            <a:picLocks noChangeAspect="1"/>
+          </p:cNvPicPr>
+          <p:nvPr/>
+        </p:nvPicPr>
+        <p:blipFill>
+          <a:blip r:embed="rId2"/>
+          <a:stretch>
+            <a:fillRect/>
+          </a:stretch>
+        </p:blipFill>
+        <p:spPr>
+          <a:xfrm>
+            <a:off x="6309360" y="1188720"/>
+            <a:ext cx="2011680" cy="2011680"/>
+          </a:xfrm>
+          <a:prstGeom prst="rect">
+            <a:avLst/>
+          </a:prstGeom>
+        </p:spPr>
+      </p:pic>
+      <p:sp>
+        <p:nvSpPr>
+          <p:cNvPr id="7" name="Text 4"/>
+          <p:cNvSpPr txBox="1"/>
+          <p:nvPr/>
+        </p:nvSpPr>
+        <p:spPr>
+          <a:xfrm>
+            <a:off x="6309360" y="3291840"/>
+            <a:ext cx="2011680" cy="274320"/>
+          </a:xfrm>
+          <a:prstGeom prst="rect">
+            <a:avLst/>
+          </a:prstGeom>
+          <a:noFill/>
+          <a:ln/>
+        </p:spPr>
+        <p:txBody>
+          <a:bodyPr wrap="square" lIns="0" tIns="0" rIns="0" bIns="0" rtlCol="0" anchor="t"/>
+          <a:lstStyle/>
+          <a:p>
+            <a:pPr algn="ctr" indent="0" marL="0">
+              <a:buNone/>
+            </a:pPr>
+            <a:r>
+              <a:rPr lang="en-US" sz="1100" dirty="0">
+                <a:solidFill>
+                  <a:schemeClr val="accent5"/>
+                </a:solidFill>
+              </a:rPr>
+              <a:t>Scan for the repository</a:t>
+            </a:r>
+            <a:endParaRPr lang="en-US" sz="1100" dirty="0"/>
           </a:p>
         </p:txBody>
       </p:sp>
@@ -5868,11 +6046,9 @@
       <p:sp>
         <p:nvSpPr>
           <p:cNvPr id="2" name="Text 0"/>
-          <p:cNvSpPr>
-            <a:spLocks noGrp="1"/>
-          </p:cNvSpPr>
+          <p:cNvSpPr/>
           <p:nvPr>
-            <p:ph type="title" idx="100" hasCustomPrompt="1"/>
+            <p:ph idx="100" type="title" hasCustomPrompt="1"/>
           </p:nvPr>
         </p:nvSpPr>
         <p:spPr>
@@ -5890,7 +6066,7 @@
           <a:bodyPr wrap="square" lIns="0" tIns="0" rIns="0" bIns="0" rtlCol="0" anchor="ctr"/>
           <a:lstStyle/>
           <a:p>
-            <a:pPr marL="0" indent="0" algn="l">
+            <a:pPr algn="l" indent="0" marL="0">
               <a:buNone/>
             </a:pPr>
             <a:r>
@@ -5907,14 +6083,14 @@
       </p:sp>
       <p:pic>
         <p:nvPicPr>
-          <p:cNvPr id="3" name="Reactive vs predictive" descr="A typical robot stops at 0.3 m and a crossing person walks into it: 2 collisions in 9 runs. VISTARA-X predicts the path 2.8 s ahead and slows early: 0 collisions in 9 runs."/>
+          <p:cNvPr id="3" name="Reactive vs predictive" descr="A typical robot stops at 0.3 m and a crossing person walks into it: 2 collisions in 9 runs. VISTARA-X predicts the path 2.8 s ahead and slows early: 0 collisions in 9 runs.">    </p:cNvPr>
           <p:cNvPicPr>
             <a:picLocks noChangeAspect="1"/>
           </p:cNvPicPr>
           <p:nvPr/>
         </p:nvPicPr>
         <p:blipFill>
-          <a:blip r:embed="rId3"/>
+          <a:blip r:embed="rId1"/>
           <a:stretch>
             <a:fillRect/>
           </a:stretch>
@@ -5950,7 +6126,7 @@
           <a:bodyPr wrap="square" lIns="0" tIns="0" rIns="0" bIns="0" rtlCol="0" anchor="t"/>
           <a:lstStyle/>
           <a:p>
-            <a:pPr marL="0" indent="0">
+            <a:pPr indent="0" marL="0">
               <a:buNone/>
             </a:pPr>
             <a:r>
@@ -5985,7 +6161,7 @@
           </a:prstGeom>
           <a:extLst>
             <a:ext uri="{C572A759-6A51-4108-AA02-DFA0A04FC94B}">
-              <ma14:wrappingTextBoxFlag xmlns:ma14="http://schemas.microsoft.com/office/mac/drawingml/2011/main" xmlns="" val="0"/>
+              <ma14:wrappingTextBoxFlag xmlns:ma14="http://schemas.microsoft.com/office/mac/drawingml/2011/main" val="0"/>
             </a:ext>
           </a:extLst>
         </p:spPr>
@@ -6003,7 +6179,7 @@
           <a:p>
             <a:pPr algn="r"/>
             <a:fld id="{F7021451-1387-4CA6-816F-3879F97B5CBC}" type="slidenum">
-              <a:rPr lang="en-US" b="0"/>
+              <a:rPr b="0" lang="en-US"/>
               <a:t>2</a:t>
             </a:fld>
             <a:endParaRPr lang="en-US"/>
@@ -6038,11 +6214,9 @@
       <p:sp>
         <p:nvSpPr>
           <p:cNvPr id="2" name="Text 0"/>
-          <p:cNvSpPr>
-            <a:spLocks noGrp="1"/>
-          </p:cNvSpPr>
+          <p:cNvSpPr/>
           <p:nvPr>
-            <p:ph type="title" idx="100" hasCustomPrompt="1"/>
+            <p:ph idx="100" type="title" hasCustomPrompt="1"/>
           </p:nvPr>
         </p:nvSpPr>
         <p:spPr>
@@ -6060,7 +6234,7 @@
           <a:bodyPr wrap="square" lIns="0" tIns="0" rIns="0" bIns="0" rtlCol="0" anchor="ctr"/>
           <a:lstStyle/>
           <a:p>
-            <a:pPr marL="0" indent="0" algn="l">
+            <a:pPr algn="l" indent="0" marL="0">
               <a:buNone/>
             </a:pPr>
             <a:r>
@@ -6077,14 +6251,14 @@
       </p:sp>
       <p:pic>
         <p:nvPicPr>
-          <p:cNvPr id="3" name="Mission workflow" descr="Five steps of a hospital delivery: ask in Hinglish, confirm, plan, drive safely while predicting a crossing person, deliver with a PIN"/>
+          <p:cNvPr id="3" name="Mission workflow" descr="Five steps of a hospital delivery: ask in Hinglish, confirm, plan, drive safely while predicting a crossing person, deliver with a PIN">    </p:cNvPr>
           <p:cNvPicPr>
             <a:picLocks noChangeAspect="1"/>
           </p:cNvPicPr>
           <p:nvPr/>
         </p:nvPicPr>
         <p:blipFill>
-          <a:blip r:embed="rId3"/>
+          <a:blip r:embed="rId1"/>
           <a:stretch>
             <a:fillRect/>
           </a:stretch>
@@ -6119,7 +6293,7 @@
           </a:prstGeom>
           <a:extLst>
             <a:ext uri="{C572A759-6A51-4108-AA02-DFA0A04FC94B}">
-              <ma14:wrappingTextBoxFlag xmlns:ma14="http://schemas.microsoft.com/office/mac/drawingml/2011/main" xmlns="" val="0"/>
+              <ma14:wrappingTextBoxFlag xmlns:ma14="http://schemas.microsoft.com/office/mac/drawingml/2011/main" val="0"/>
             </a:ext>
           </a:extLst>
         </p:spPr>
@@ -6137,7 +6311,7 @@
           <a:p>
             <a:pPr algn="r"/>
             <a:fld id="{F7021451-1387-4CA6-816F-3879F97B5CBC}" type="slidenum">
-              <a:rPr lang="en-US" b="0"/>
+              <a:rPr b="0" lang="en-US"/>
               <a:t>3</a:t>
             </a:fld>
             <a:endParaRPr lang="en-US"/>
@@ -6172,11 +6346,9 @@
       <p:sp>
         <p:nvSpPr>
           <p:cNvPr id="2" name="Text 0"/>
-          <p:cNvSpPr>
-            <a:spLocks noGrp="1"/>
-          </p:cNvSpPr>
+          <p:cNvSpPr/>
           <p:nvPr>
-            <p:ph type="title" idx="100" hasCustomPrompt="1"/>
+            <p:ph idx="100" type="title" hasCustomPrompt="1"/>
           </p:nvPr>
         </p:nvSpPr>
         <p:spPr>
@@ -6194,7 +6366,7 @@
           <a:bodyPr wrap="square" lIns="0" tIns="0" rIns="0" bIns="0" rtlCol="0" anchor="ctr"/>
           <a:lstStyle/>
           <a:p>
-            <a:pPr marL="0" indent="0" algn="l">
+            <a:pPr algn="l" indent="0" marL="0">
               <a:buNone/>
             </a:pPr>
             <a:r>
@@ -6211,14 +6383,14 @@
       </p:sp>
       <p:pic>
         <p:nvPicPr>
-          <p:cNvPr id="3" name="System architecture" descr="User, laptop backend modules, Arduino Mega safety layer, motors"/>
+          <p:cNvPr id="3" name="System architecture" descr="User, laptop backend modules, Arduino Mega safety layer, motors">    </p:cNvPr>
           <p:cNvPicPr>
             <a:picLocks noChangeAspect="1"/>
           </p:cNvPicPr>
           <p:nvPr/>
         </p:nvPicPr>
         <p:blipFill>
-          <a:blip r:embed="rId3"/>
+          <a:blip r:embed="rId1"/>
           <a:stretch>
             <a:fillRect/>
           </a:stretch>
@@ -6253,7 +6425,7 @@
           </a:prstGeom>
           <a:extLst>
             <a:ext uri="{C572A759-6A51-4108-AA02-DFA0A04FC94B}">
-              <ma14:wrappingTextBoxFlag xmlns:ma14="http://schemas.microsoft.com/office/mac/drawingml/2011/main" xmlns="" val="0"/>
+              <ma14:wrappingTextBoxFlag xmlns:ma14="http://schemas.microsoft.com/office/mac/drawingml/2011/main" val="0"/>
             </a:ext>
           </a:extLst>
         </p:spPr>
@@ -6271,7 +6443,7 @@
           <a:p>
             <a:pPr algn="r"/>
             <a:fld id="{F7021451-1387-4CA6-816F-3879F97B5CBC}" type="slidenum">
-              <a:rPr lang="en-US" b="0"/>
+              <a:rPr b="0" lang="en-US"/>
               <a:t>4</a:t>
             </a:fld>
             <a:endParaRPr lang="en-US"/>
@@ -6306,11 +6478,9 @@
       <p:sp>
         <p:nvSpPr>
           <p:cNvPr id="2" name="Text 0"/>
-          <p:cNvSpPr>
-            <a:spLocks noGrp="1"/>
-          </p:cNvSpPr>
+          <p:cNvSpPr/>
           <p:nvPr>
-            <p:ph type="title" idx="100" hasCustomPrompt="1"/>
+            <p:ph idx="100" type="title" hasCustomPrompt="1"/>
           </p:nvPr>
         </p:nvSpPr>
         <p:spPr>
@@ -6328,7 +6498,7 @@
           <a:bodyPr wrap="square" lIns="0" tIns="0" rIns="0" bIns="0" rtlCol="0" anchor="ctr"/>
           <a:lstStyle/>
           <a:p>
-            <a:pPr marL="0" indent="0" algn="l">
+            <a:pPr algn="l" indent="0" marL="0">
               <a:buNone/>
             </a:pPr>
             <a:r>
@@ -6345,14 +6515,14 @@
       </p:sp>
       <p:pic>
         <p:nvPicPr>
-          <p:cNvPr id="3" name="Prediction panel screenshot" descr="Prediction panel: pipeline strip, predicted positions of person T1 from 0.5 to 3 s, radar, decision timeline"/>
+          <p:cNvPr id="3" name="Prediction panel screenshot" descr="Prediction panel: pipeline strip, predicted positions of person T1 from 0.5 to 3 s, radar, decision timeline">    </p:cNvPr>
           <p:cNvPicPr>
             <a:picLocks noChangeAspect="1"/>
           </p:cNvPicPr>
           <p:nvPr/>
         </p:nvPicPr>
         <p:blipFill>
-          <a:blip r:embed="rId3"/>
+          <a:blip r:embed="rId1"/>
           <a:stretch>
             <a:fillRect/>
           </a:stretch>
@@ -6435,7 +6605,7 @@
           <a:bodyPr wrap="square" lIns="0" tIns="0" rIns="0" bIns="0" rtlCol="0" anchor="ctr"/>
           <a:lstStyle/>
           <a:p>
-            <a:pPr marL="0" indent="0" algn="ctr">
+            <a:pPr algn="ctr" indent="0" marL="0">
               <a:buNone/>
             </a:pPr>
             <a:r>
@@ -6496,7 +6666,7 @@
           <a:bodyPr wrap="square" lIns="0" tIns="0" rIns="0" bIns="0" rtlCol="0" anchor="ctr"/>
           <a:lstStyle/>
           <a:p>
-            <a:pPr marL="0" indent="0" algn="ctr">
+            <a:pPr algn="ctr" indent="0" marL="0">
               <a:buNone/>
             </a:pPr>
             <a:r>
@@ -6557,7 +6727,7 @@
           <a:bodyPr wrap="square" lIns="0" tIns="0" rIns="0" bIns="0" rtlCol="0" anchor="ctr"/>
           <a:lstStyle/>
           <a:p>
-            <a:pPr marL="0" indent="0" algn="ctr">
+            <a:pPr algn="ctr" indent="0" marL="0">
               <a:buNone/>
             </a:pPr>
             <a:r>
@@ -6618,7 +6788,7 @@
           <a:bodyPr wrap="square" lIns="0" tIns="0" rIns="0" bIns="0" rtlCol="0" anchor="ctr"/>
           <a:lstStyle/>
           <a:p>
-            <a:pPr marL="0" indent="0" algn="ctr">
+            <a:pPr algn="ctr" indent="0" marL="0">
               <a:buNone/>
             </a:pPr>
             <a:r>
@@ -6679,7 +6849,7 @@
           <a:bodyPr wrap="square" lIns="0" tIns="0" rIns="0" bIns="0" rtlCol="0" anchor="ctr"/>
           <a:lstStyle/>
           <a:p>
-            <a:pPr marL="0" indent="0" algn="ctr">
+            <a:pPr algn="ctr" indent="0" marL="0">
               <a:buNone/>
             </a:pPr>
             <a:r>
@@ -6715,7 +6885,7 @@
           <a:bodyPr wrap="square" lIns="0" tIns="0" rIns="0" bIns="0" rtlCol="0" anchor="t"/>
           <a:lstStyle/>
           <a:p>
-            <a:pPr marL="0" indent="0">
+            <a:pPr indent="0" marL="0">
               <a:buNone/>
             </a:pPr>
             <a:r>
@@ -6751,7 +6921,7 @@
           <a:bodyPr wrap="square" lIns="0" tIns="0" rIns="0" bIns="0" rtlCol="0" anchor="t"/>
           <a:lstStyle/>
           <a:p>
-            <a:pPr marL="0" indent="0">
+            <a:pPr indent="0" marL="0">
               <a:buNone/>
             </a:pPr>
             <a:r>
@@ -6812,7 +6982,7 @@
           <a:bodyPr wrap="square" lIns="0" tIns="0" rIns="0" bIns="0" rtlCol="0" anchor="ctr"/>
           <a:lstStyle/>
           <a:p>
-            <a:pPr marL="0" indent="0" algn="ctr">
+            <a:pPr algn="ctr" indent="0" marL="0">
               <a:buNone/>
             </a:pPr>
             <a:r>
@@ -6848,7 +7018,7 @@
           <a:bodyPr wrap="square" lIns="0" tIns="0" rIns="0" bIns="0" rtlCol="0" anchor="t"/>
           <a:lstStyle/>
           <a:p>
-            <a:pPr marL="0" indent="0">
+            <a:pPr indent="0" marL="0">
               <a:buNone/>
             </a:pPr>
             <a:r>
@@ -6884,7 +7054,7 @@
           <a:bodyPr wrap="square" lIns="0" tIns="0" rIns="0" bIns="0" rtlCol="0" anchor="t"/>
           <a:lstStyle/>
           <a:p>
-            <a:pPr marL="0" indent="0">
+            <a:pPr indent="0" marL="0">
               <a:buNone/>
             </a:pPr>
             <a:r>
@@ -6945,7 +7115,7 @@
           <a:bodyPr wrap="square" lIns="0" tIns="0" rIns="0" bIns="0" rtlCol="0" anchor="ctr"/>
           <a:lstStyle/>
           <a:p>
-            <a:pPr marL="0" indent="0" algn="ctr">
+            <a:pPr algn="ctr" indent="0" marL="0">
               <a:buNone/>
             </a:pPr>
             <a:r>
@@ -6981,7 +7151,7 @@
           <a:bodyPr wrap="square" lIns="0" tIns="0" rIns="0" bIns="0" rtlCol="0" anchor="t"/>
           <a:lstStyle/>
           <a:p>
-            <a:pPr marL="0" indent="0">
+            <a:pPr indent="0" marL="0">
               <a:buNone/>
             </a:pPr>
             <a:r>
@@ -7017,7 +7187,7 @@
           <a:bodyPr wrap="square" lIns="0" tIns="0" rIns="0" bIns="0" rtlCol="0" anchor="t"/>
           <a:lstStyle/>
           <a:p>
-            <a:pPr marL="0" indent="0">
+            <a:pPr indent="0" marL="0">
               <a:buNone/>
             </a:pPr>
             <a:r>
@@ -7078,7 +7248,7 @@
           <a:bodyPr wrap="square" lIns="0" tIns="0" rIns="0" bIns="0" rtlCol="0" anchor="ctr"/>
           <a:lstStyle/>
           <a:p>
-            <a:pPr marL="0" indent="0" algn="ctr">
+            <a:pPr algn="ctr" indent="0" marL="0">
               <a:buNone/>
             </a:pPr>
             <a:r>
@@ -7114,7 +7284,7 @@
           <a:bodyPr wrap="square" lIns="0" tIns="0" rIns="0" bIns="0" rtlCol="0" anchor="t"/>
           <a:lstStyle/>
           <a:p>
-            <a:pPr marL="0" indent="0">
+            <a:pPr indent="0" marL="0">
               <a:buNone/>
             </a:pPr>
             <a:r>
@@ -7150,7 +7320,7 @@
           <a:bodyPr wrap="square" lIns="0" tIns="0" rIns="0" bIns="0" rtlCol="0" anchor="t"/>
           <a:lstStyle/>
           <a:p>
-            <a:pPr marL="0" indent="0">
+            <a:pPr indent="0" marL="0">
               <a:buNone/>
             </a:pPr>
             <a:r>
@@ -7186,7 +7356,7 @@
           <a:bodyPr wrap="square" lIns="0" tIns="0" rIns="0" bIns="0" rtlCol="0" anchor="t"/>
           <a:lstStyle/>
           <a:p>
-            <a:pPr marL="0" indent="0">
+            <a:pPr indent="0" marL="0">
               <a:buNone/>
             </a:pPr>
             <a:r>
@@ -7203,7 +7373,7 @@
       </p:sp>
       <p:sp>
         <p:nvSpPr>
-          <p:cNvPr id="30" name="Slide Number Placeholder 0"/>
+          <p:cNvPr id="25" name="Slide Number Placeholder 0"/>
           <p:cNvSpPr>
             <a:spLocks noGrp="1"/>
           </p:cNvSpPr>
@@ -7221,7 +7391,7 @@
           </a:prstGeom>
           <a:extLst>
             <a:ext uri="{C572A759-6A51-4108-AA02-DFA0A04FC94B}">
-              <ma14:wrappingTextBoxFlag xmlns:ma14="http://schemas.microsoft.com/office/mac/drawingml/2011/main" xmlns="" val="0"/>
+              <ma14:wrappingTextBoxFlag xmlns:ma14="http://schemas.microsoft.com/office/mac/drawingml/2011/main" val="0"/>
             </a:ext>
           </a:extLst>
         </p:spPr>
@@ -7239,7 +7409,7 @@
           <a:p>
             <a:pPr algn="r"/>
             <a:fld id="{F7021451-1387-4CA6-816F-3879F97B5CBC}" type="slidenum">
-              <a:rPr lang="en-US" b="0"/>
+              <a:rPr b="0" lang="en-US"/>
               <a:t>5</a:t>
             </a:fld>
             <a:endParaRPr lang="en-US"/>
@@ -7274,11 +7444,9 @@
       <p:sp>
         <p:nvSpPr>
           <p:cNvPr id="2" name="Text 0"/>
-          <p:cNvSpPr>
-            <a:spLocks noGrp="1"/>
-          </p:cNvSpPr>
+          <p:cNvSpPr/>
           <p:nvPr>
-            <p:ph type="title" idx="100" hasCustomPrompt="1"/>
+            <p:ph idx="100" type="title" hasCustomPrompt="1"/>
           </p:nvPr>
         </p:nvSpPr>
         <p:spPr>
@@ -7296,7 +7464,7 @@
           <a:bodyPr wrap="square" lIns="0" tIns="0" rIns="0" bIns="0" rtlCol="0" anchor="ctr"/>
           <a:lstStyle/>
           <a:p>
-            <a:pPr marL="0" indent="0" algn="l">
+            <a:pPr algn="l" indent="0" marL="0">
               <a:buNone/>
             </a:pPr>
             <a:r>
@@ -7313,14 +7481,14 @@
       </p:sp>
       <p:pic>
         <p:nvPicPr>
-          <p:cNvPr id="3" name="Live mission screenshot" descr="3D crossing corridor with a person and a cart, and the judge demo checklist ticked from telemetry"/>
+          <p:cNvPr id="3" name="Live mission screenshot" descr="3D crossing corridor with a person and a cart, and the judge demo checklist ticked from telemetry">    </p:cNvPr>
           <p:cNvPicPr>
             <a:picLocks noChangeAspect="1"/>
           </p:cNvPicPr>
           <p:nvPr/>
         </p:nvPicPr>
         <p:blipFill>
-          <a:blip r:embed="rId3"/>
+          <a:blip r:embed="rId1"/>
           <a:stretch>
             <a:fillRect/>
           </a:stretch>
@@ -7400,7 +7568,7 @@
           <a:bodyPr wrap="square" lIns="0" tIns="0" rIns="0" bIns="0" rtlCol="0" anchor="ctr"/>
           <a:lstStyle/>
           <a:p>
-            <a:pPr marL="0" indent="0" algn="ctr">
+            <a:pPr algn="ctr" indent="0" marL="0">
               <a:buNone/>
             </a:pPr>
             <a:r>
@@ -7482,7 +7650,7 @@
           <a:bodyPr wrap="square" lIns="0" tIns="0" rIns="0" bIns="0" rtlCol="0" anchor="ctr"/>
           <a:lstStyle/>
           <a:p>
-            <a:pPr marL="0" indent="0" algn="ctr">
+            <a:pPr algn="ctr" indent="0" marL="0">
               <a:buNone/>
             </a:pPr>
             <a:r>
@@ -7564,7 +7732,7 @@
           <a:bodyPr wrap="square" lIns="0" tIns="0" rIns="0" bIns="0" rtlCol="0" anchor="ctr"/>
           <a:lstStyle/>
           <a:p>
-            <a:pPr marL="0" indent="0" algn="ctr">
+            <a:pPr algn="ctr" indent="0" marL="0">
               <a:buNone/>
             </a:pPr>
             <a:r>
@@ -7646,7 +7814,7 @@
           <a:bodyPr wrap="square" lIns="0" tIns="0" rIns="0" bIns="0" rtlCol="0" anchor="ctr"/>
           <a:lstStyle/>
           <a:p>
-            <a:pPr marL="0" indent="0" algn="ctr">
+            <a:pPr algn="ctr" indent="0" marL="0">
               <a:buNone/>
             </a:pPr>
             <a:r>
@@ -7728,7 +7896,7 @@
           <a:bodyPr wrap="square" lIns="0" tIns="0" rIns="0" bIns="0" rtlCol="0" anchor="ctr"/>
           <a:lstStyle/>
           <a:p>
-            <a:pPr marL="0" indent="0" algn="ctr">
+            <a:pPr algn="ctr" indent="0" marL="0">
               <a:buNone/>
             </a:pPr>
             <a:r>
@@ -7763,7 +7931,7 @@
           </a:prstGeom>
           <a:extLst>
             <a:ext uri="{C572A759-6A51-4108-AA02-DFA0A04FC94B}">
-              <ma14:wrappingTextBoxFlag xmlns:ma14="http://schemas.microsoft.com/office/mac/drawingml/2011/main" xmlns="" val="0"/>
+              <ma14:wrappingTextBoxFlag xmlns:ma14="http://schemas.microsoft.com/office/mac/drawingml/2011/main" val="0"/>
             </a:ext>
           </a:extLst>
         </p:spPr>
@@ -7781,7 +7949,7 @@
           <a:p>
             <a:pPr algn="r"/>
             <a:fld id="{F7021451-1387-4CA6-816F-3879F97B5CBC}" type="slidenum">
-              <a:rPr lang="en-US" b="0"/>
+              <a:rPr b="0" lang="en-US"/>
               <a:t>6</a:t>
             </a:fld>
             <a:endParaRPr lang="en-US"/>
@@ -7816,11 +7984,9 @@
       <p:sp>
         <p:nvSpPr>
           <p:cNvPr id="2" name="Text 0"/>
-          <p:cNvSpPr>
-            <a:spLocks noGrp="1"/>
-          </p:cNvSpPr>
+          <p:cNvSpPr/>
           <p:nvPr>
-            <p:ph type="title" idx="100" hasCustomPrompt="1"/>
+            <p:ph idx="100" type="title" hasCustomPrompt="1"/>
           </p:nvPr>
         </p:nvSpPr>
         <p:spPr>
@@ -7838,7 +8004,7 @@
           <a:bodyPr wrap="square" lIns="0" tIns="0" rIns="0" bIns="0" rtlCol="0" anchor="ctr"/>
           <a:lstStyle/>
           <a:p>
-            <a:pPr marL="0" indent="0" algn="l">
+            <a:pPr algn="l" indent="0" marL="0">
               <a:buNone/>
             </a:pPr>
             <a:r>
@@ -7855,7 +8021,7 @@
       </p:sp>
       <p:graphicFrame>
         <p:nvGraphicFramePr>
-          <p:cNvPr id="3" name="Chart 0"/>
+          <p:cNvPr id="3" name="Chart 0" descr=""/>
           <p:cNvGraphicFramePr/>
           <p:nvPr/>
         </p:nvGraphicFramePr>
@@ -7863,9 +8029,9 @@
           <a:off x="457200" y="960120"/>
           <a:ext cx="4937760" cy="3383280"/>
         </p:xfrm>
-        <a:graphic>
+        <a:graphic xmlns:a="http://schemas.openxmlformats.org/drawingml/2006/main">
           <a:graphicData uri="http://schemas.openxmlformats.org/drawingml/2006/chart">
-            <c:chart xmlns:c="http://schemas.openxmlformats.org/drawingml/2006/chart" xmlns:r="http://schemas.openxmlformats.org/officeDocument/2006/relationships" r:id="rId3"/>
+            <c:chart xmlns:c="http://schemas.openxmlformats.org/drawingml/2006/chart" r:id="rId1"/>
           </a:graphicData>
         </a:graphic>
       </p:graphicFrame>
@@ -7890,7 +8056,7 @@
           <a:bodyPr wrap="square" lIns="0" tIns="0" rIns="0" bIns="0" rtlCol="0" anchor="t"/>
           <a:lstStyle/>
           <a:p>
-            <a:pPr marL="0" indent="0">
+            <a:pPr indent="0" marL="0">
               <a:buNone/>
             </a:pPr>
             <a:r>
@@ -7926,7 +8092,7 @@
           <a:bodyPr wrap="square" lIns="0" tIns="0" rIns="0" bIns="0" rtlCol="0" anchor="t"/>
           <a:lstStyle/>
           <a:p>
-            <a:pPr marL="0" indent="0">
+            <a:pPr indent="0" marL="0">
               <a:buNone/>
             </a:pPr>
             <a:r>
@@ -7962,7 +8128,7 @@
           <a:bodyPr wrap="square" lIns="0" tIns="0" rIns="0" bIns="0" rtlCol="0" anchor="t"/>
           <a:lstStyle/>
           <a:p>
-            <a:pPr marL="0" indent="0">
+            <a:pPr indent="0" marL="0">
               <a:buNone/>
             </a:pPr>
             <a:r>
@@ -7998,7 +8164,7 @@
           <a:bodyPr wrap="square" lIns="0" tIns="0" rIns="0" bIns="0" rtlCol="0" anchor="t"/>
           <a:lstStyle/>
           <a:p>
-            <a:pPr marL="0" indent="0">
+            <a:pPr indent="0" marL="0">
               <a:buNone/>
             </a:pPr>
             <a:r>
@@ -8034,7 +8200,7 @@
           <a:bodyPr wrap="square" lIns="0" tIns="0" rIns="0" bIns="0" rtlCol="0" anchor="t"/>
           <a:lstStyle/>
           <a:p>
-            <a:pPr marL="0" indent="0">
+            <a:pPr indent="0" marL="0">
               <a:buNone/>
             </a:pPr>
             <a:r>
@@ -8070,7 +8236,7 @@
           <a:bodyPr wrap="square" lIns="0" tIns="0" rIns="0" bIns="0" rtlCol="0" anchor="t"/>
           <a:lstStyle/>
           <a:p>
-            <a:pPr marL="0" indent="0">
+            <a:pPr indent="0" marL="0">
               <a:buNone/>
             </a:pPr>
             <a:r>
@@ -8106,7 +8272,7 @@
           <a:bodyPr wrap="square" lIns="0" tIns="0" rIns="0" bIns="0" rtlCol="0" anchor="t"/>
           <a:lstStyle/>
           <a:p>
-            <a:pPr marL="0" indent="0">
+            <a:pPr indent="0" marL="0">
               <a:buNone/>
             </a:pPr>
             <a:r>
@@ -8142,7 +8308,7 @@
           <a:bodyPr wrap="square" lIns="0" tIns="0" rIns="0" bIns="0" rtlCol="0" anchor="t"/>
           <a:lstStyle/>
           <a:p>
-            <a:pPr marL="0" indent="0">
+            <a:pPr indent="0" marL="0">
               <a:buNone/>
             </a:pPr>
             <a:r>
@@ -8178,7 +8344,7 @@
           <a:bodyPr wrap="square" lIns="0" tIns="0" rIns="0" bIns="0" rtlCol="0" anchor="t"/>
           <a:lstStyle/>
           <a:p>
-            <a:pPr marL="0" indent="0">
+            <a:pPr indent="0" marL="0">
               <a:buNone/>
             </a:pPr>
             <a:r>
@@ -8214,7 +8380,7 @@
           <a:bodyPr wrap="square" lIns="0" tIns="0" rIns="0" bIns="0" rtlCol="0" anchor="t"/>
           <a:lstStyle/>
           <a:p>
-            <a:pPr marL="0" indent="0">
+            <a:pPr indent="0" marL="0">
               <a:buNone/>
             </a:pPr>
             <a:r>
@@ -8249,7 +8415,7 @@
           </a:prstGeom>
           <a:extLst>
             <a:ext uri="{C572A759-6A51-4108-AA02-DFA0A04FC94B}">
-              <ma14:wrappingTextBoxFlag xmlns:ma14="http://schemas.microsoft.com/office/mac/drawingml/2011/main" xmlns="" val="0"/>
+              <ma14:wrappingTextBoxFlag xmlns:ma14="http://schemas.microsoft.com/office/mac/drawingml/2011/main" val="0"/>
             </a:ext>
           </a:extLst>
         </p:spPr>
@@ -8267,7 +8433,7 @@
           <a:p>
             <a:pPr algn="r"/>
             <a:fld id="{F7021451-1387-4CA6-816F-3879F97B5CBC}" type="slidenum">
-              <a:rPr lang="en-US" b="0"/>
+              <a:rPr b="0" lang="en-US"/>
               <a:t>7</a:t>
             </a:fld>
             <a:endParaRPr lang="en-US"/>
@@ -8302,11 +8468,9 @@
       <p:sp>
         <p:nvSpPr>
           <p:cNvPr id="2" name="Text 0"/>
-          <p:cNvSpPr>
-            <a:spLocks noGrp="1"/>
-          </p:cNvSpPr>
+          <p:cNvSpPr/>
           <p:nvPr>
-            <p:ph type="title" idx="100" hasCustomPrompt="1"/>
+            <p:ph idx="100" type="title" hasCustomPrompt="1"/>
           </p:nvPr>
         </p:nvSpPr>
         <p:spPr>
@@ -8324,7 +8488,7 @@
           <a:bodyPr wrap="square" lIns="0" tIns="0" rIns="0" bIns="0" rtlCol="0" anchor="ctr"/>
           <a:lstStyle/>
           <a:p>
-            <a:pPr marL="0" indent="0" algn="l">
+            <a:pPr algn="l" indent="0" marL="0">
               <a:buNone/>
             </a:pPr>
             <a:r>
@@ -8360,7 +8524,7 @@
           <a:bodyPr wrap="square" lIns="0" tIns="0" rIns="0" bIns="0" rtlCol="0" anchor="t"/>
           <a:lstStyle/>
           <a:p>
-            <a:pPr marL="0" indent="0">
+            <a:pPr indent="0" marL="0">
               <a:buNone/>
             </a:pPr>
             <a:r>
@@ -8377,7 +8541,199 @@
       </p:sp>
       <p:pic>
         <p:nvPicPr>
-          <p:cNvPr id="4" name="Arduino Mega 2560" descr="Arduino Mega 2560"/>
+          <p:cNvPr id="4" name="Arduino Mega 2560" descr="Arduino Mega 2560">    </p:cNvPr>
+          <p:cNvPicPr>
+            <a:picLocks noChangeAspect="1"/>
+          </p:cNvPicPr>
+          <p:nvPr/>
+        </p:nvPicPr>
+        <p:blipFill>
+          <a:blip r:embed="rId1"/>
+          <a:stretch>
+            <a:fillRect/>
+          </a:stretch>
+        </p:blipFill>
+        <p:spPr>
+          <a:xfrm>
+            <a:off x="457200" y="1280160"/>
+            <a:ext cx="2651760" cy="1307592"/>
+          </a:xfrm>
+          <a:prstGeom prst="rect">
+            <a:avLst/>
+          </a:prstGeom>
+        </p:spPr>
+      </p:pic>
+      <p:sp>
+        <p:nvSpPr>
+          <p:cNvPr id="5" name="Text 2"/>
+          <p:cNvSpPr txBox="1"/>
+          <p:nvPr/>
+        </p:nvSpPr>
+        <p:spPr>
+          <a:xfrm>
+            <a:off x="457200" y="2660904"/>
+            <a:ext cx="2651760" cy="201168"/>
+          </a:xfrm>
+          <a:prstGeom prst="rect">
+            <a:avLst/>
+          </a:prstGeom>
+          <a:noFill/>
+          <a:ln/>
+        </p:spPr>
+        <p:txBody>
+          <a:bodyPr wrap="square" lIns="0" tIns="0" rIns="0" bIns="0" rtlCol="0" anchor="t"/>
+          <a:lstStyle/>
+          <a:p>
+            <a:pPr indent="0" marL="0">
+              <a:buNone/>
+            </a:pPr>
+            <a:r>
+              <a:rPr lang="en-US" sz="1100" b="1" dirty="0">
+                <a:solidFill>
+                  <a:schemeClr val="tx1"/>
+                </a:solidFill>
+              </a:rPr>
+              <a:t>Arduino Mega 2560</a:t>
+            </a:r>
+            <a:endParaRPr lang="en-US" sz="1100" dirty="0"/>
+          </a:p>
+        </p:txBody>
+      </p:sp>
+      <p:sp>
+        <p:nvSpPr>
+          <p:cNvPr id="6" name="Text 3"/>
+          <p:cNvSpPr txBox="1"/>
+          <p:nvPr/>
+        </p:nvSpPr>
+        <p:spPr>
+          <a:xfrm>
+            <a:off x="457200" y="2862072"/>
+            <a:ext cx="2651760" cy="201168"/>
+          </a:xfrm>
+          <a:prstGeom prst="rect">
+            <a:avLst/>
+          </a:prstGeom>
+          <a:noFill/>
+          <a:ln/>
+        </p:spPr>
+        <p:txBody>
+          <a:bodyPr wrap="square" lIns="0" tIns="0" rIns="0" bIns="0" rtlCol="0" anchor="t"/>
+          <a:lstStyle/>
+          <a:p>
+            <a:pPr indent="0" marL="0">
+              <a:buNone/>
+            </a:pPr>
+            <a:r>
+              <a:rPr lang="en-US" sz="1000" dirty="0">
+                <a:solidFill>
+                  <a:schemeClr val="accent5"/>
+                </a:solidFill>
+              </a:rPr>
+              <a:t>controller and safety</a:t>
+            </a:r>
+            <a:endParaRPr lang="en-US" sz="1000" dirty="0"/>
+          </a:p>
+        </p:txBody>
+      </p:sp>
+      <p:pic>
+        <p:nvPicPr>
+          <p:cNvPr id="7" name="HC-SR04 × 6" descr="HC-SR04 × 6">    </p:cNvPr>
+          <p:cNvPicPr>
+            <a:picLocks noChangeAspect="1"/>
+          </p:cNvPicPr>
+          <p:nvPr/>
+        </p:nvPicPr>
+        <p:blipFill>
+          <a:blip r:embed="rId2"/>
+          <a:stretch>
+            <a:fillRect/>
+          </a:stretch>
+        </p:blipFill>
+        <p:spPr>
+          <a:xfrm>
+            <a:off x="3337560" y="1325880"/>
+            <a:ext cx="1417320" cy="786384"/>
+          </a:xfrm>
+          <a:prstGeom prst="rect">
+            <a:avLst/>
+          </a:prstGeom>
+        </p:spPr>
+      </p:pic>
+      <p:sp>
+        <p:nvSpPr>
+          <p:cNvPr id="8" name="Text 4"/>
+          <p:cNvSpPr txBox="1"/>
+          <p:nvPr/>
+        </p:nvSpPr>
+        <p:spPr>
+          <a:xfrm>
+            <a:off x="3337560" y="2185416"/>
+            <a:ext cx="1417320" cy="201168"/>
+          </a:xfrm>
+          <a:prstGeom prst="rect">
+            <a:avLst/>
+          </a:prstGeom>
+          <a:noFill/>
+          <a:ln/>
+        </p:spPr>
+        <p:txBody>
+          <a:bodyPr wrap="square" lIns="0" tIns="0" rIns="0" bIns="0" rtlCol="0" anchor="t"/>
+          <a:lstStyle/>
+          <a:p>
+            <a:pPr indent="0" marL="0">
+              <a:buNone/>
+            </a:pPr>
+            <a:r>
+              <a:rPr lang="en-US" sz="1100" b="1" dirty="0">
+                <a:solidFill>
+                  <a:schemeClr val="tx1"/>
+                </a:solidFill>
+              </a:rPr>
+              <a:t>HC-SR04 × 6</a:t>
+            </a:r>
+            <a:endParaRPr lang="en-US" sz="1100" dirty="0"/>
+          </a:p>
+        </p:txBody>
+      </p:sp>
+      <p:sp>
+        <p:nvSpPr>
+          <p:cNvPr id="9" name="Text 5"/>
+          <p:cNvSpPr txBox="1"/>
+          <p:nvPr/>
+        </p:nvSpPr>
+        <p:spPr>
+          <a:xfrm>
+            <a:off x="3337560" y="2386584"/>
+            <a:ext cx="1417320" cy="201168"/>
+          </a:xfrm>
+          <a:prstGeom prst="rect">
+            <a:avLst/>
+          </a:prstGeom>
+          <a:noFill/>
+          <a:ln/>
+        </p:spPr>
+        <p:txBody>
+          <a:bodyPr wrap="square" lIns="0" tIns="0" rIns="0" bIns="0" rtlCol="0" anchor="t"/>
+          <a:lstStyle/>
+          <a:p>
+            <a:pPr indent="0" marL="0">
+              <a:buNone/>
+            </a:pPr>
+            <a:r>
+              <a:rPr lang="en-US" sz="1000" dirty="0">
+                <a:solidFill>
+                  <a:schemeClr val="accent5"/>
+                </a:solidFill>
+              </a:rPr>
+              <a:t>distance all around</a:t>
+            </a:r>
+            <a:endParaRPr lang="en-US" sz="1000" dirty="0"/>
+          </a:p>
+        </p:txBody>
+      </p:sp>
+      <p:pic>
+        <p:nvPicPr>
+          <p:cNvPr id="10" name="MPU6050" descr="MPU6050">    </p:cNvPr>
           <p:cNvPicPr>
             <a:picLocks noChangeAspect="1"/>
           </p:cNvPicPr>
@@ -8391,8 +8747,8 @@
         </p:blipFill>
         <p:spPr>
           <a:xfrm>
-            <a:off x="457200" y="1280160"/>
-            <a:ext cx="2651760" cy="1307592"/>
+            <a:off x="457200" y="3154680"/>
+            <a:ext cx="822960" cy="612648"/>
           </a:xfrm>
           <a:prstGeom prst="rect">
             <a:avLst/>
@@ -8401,14 +8757,14 @@
       </p:pic>
       <p:sp>
         <p:nvSpPr>
-          <p:cNvPr id="5" name="Text 2"/>
+          <p:cNvPr id="11" name="Text 6"/>
           <p:cNvSpPr txBox="1"/>
           <p:nvPr/>
         </p:nvSpPr>
         <p:spPr>
           <a:xfrm>
-            <a:off x="457200" y="2660904"/>
-            <a:ext cx="2651760" cy="201168"/>
+            <a:off x="457200" y="3840480"/>
+            <a:ext cx="1097280" cy="201168"/>
           </a:xfrm>
           <a:prstGeom prst="rect">
             <a:avLst/>
@@ -8420,7 +8776,7 @@
           <a:bodyPr wrap="square" lIns="0" tIns="0" rIns="0" bIns="0" rtlCol="0" anchor="t"/>
           <a:lstStyle/>
           <a:p>
-            <a:pPr marL="0" indent="0">
+            <a:pPr indent="0" marL="0">
               <a:buNone/>
             </a:pPr>
             <a:r>
@@ -8429,7 +8785,7 @@
                   <a:schemeClr val="tx1"/>
                 </a:solidFill>
               </a:rPr>
-              <a:t>Arduino Mega 2560</a:t>
+              <a:t>MPU6050</a:t>
             </a:r>
             <a:endParaRPr lang="en-US" sz="1100" dirty="0"/>
           </a:p>
@@ -8437,14 +8793,14 @@
       </p:sp>
       <p:sp>
         <p:nvSpPr>
-          <p:cNvPr id="6" name="Text 3"/>
+          <p:cNvPr id="12" name="Text 7"/>
           <p:cNvSpPr txBox="1"/>
           <p:nvPr/>
         </p:nvSpPr>
         <p:spPr>
           <a:xfrm>
-            <a:off x="457200" y="2862072"/>
-            <a:ext cx="2651760" cy="201168"/>
+            <a:off x="457200" y="4041648"/>
+            <a:ext cx="1097280" cy="201168"/>
           </a:xfrm>
           <a:prstGeom prst="rect">
             <a:avLst/>
@@ -8456,7 +8812,7 @@
           <a:bodyPr wrap="square" lIns="0" tIns="0" rIns="0" bIns="0" rtlCol="0" anchor="t"/>
           <a:lstStyle/>
           <a:p>
-            <a:pPr marL="0" indent="0">
+            <a:pPr indent="0" marL="0">
               <a:buNone/>
             </a:pPr>
             <a:r>
@@ -8465,7 +8821,7 @@
                   <a:schemeClr val="accent5"/>
                 </a:solidFill>
               </a:rPr>
-              <a:t>controller and safety</a:t>
+              <a:t>IMU, turning rate</a:t>
             </a:r>
             <a:endParaRPr lang="en-US" sz="1000" dirty="0"/>
           </a:p>
@@ -8473,7 +8829,7 @@
       </p:sp>
       <p:pic>
         <p:nvPicPr>
-          <p:cNvPr id="7" name="HC-SR04 × 6" descr="HC-SR04 × 6"/>
+          <p:cNvPr id="13" name="E-stop" descr="E-stop">    </p:cNvPr>
           <p:cNvPicPr>
             <a:picLocks noChangeAspect="1"/>
           </p:cNvPicPr>
@@ -8487,8 +8843,8 @@
         </p:blipFill>
         <p:spPr>
           <a:xfrm>
-            <a:off x="3337560" y="1325880"/>
-            <a:ext cx="1417320" cy="786384"/>
+            <a:off x="1600200" y="3200400"/>
+            <a:ext cx="749808" cy="502920"/>
           </a:xfrm>
           <a:prstGeom prst="rect">
             <a:avLst/>
@@ -8497,14 +8853,14 @@
       </p:pic>
       <p:sp>
         <p:nvSpPr>
-          <p:cNvPr id="8" name="Text 4"/>
+          <p:cNvPr id="14" name="Text 8"/>
           <p:cNvSpPr txBox="1"/>
           <p:nvPr/>
         </p:nvSpPr>
         <p:spPr>
           <a:xfrm>
-            <a:off x="3337560" y="2185416"/>
-            <a:ext cx="1417320" cy="201168"/>
+            <a:off x="1600200" y="3840480"/>
+            <a:ext cx="1097280" cy="201168"/>
           </a:xfrm>
           <a:prstGeom prst="rect">
             <a:avLst/>
@@ -8516,7 +8872,7 @@
           <a:bodyPr wrap="square" lIns="0" tIns="0" rIns="0" bIns="0" rtlCol="0" anchor="t"/>
           <a:lstStyle/>
           <a:p>
-            <a:pPr marL="0" indent="0">
+            <a:pPr indent="0" marL="0">
               <a:buNone/>
             </a:pPr>
             <a:r>
@@ -8525,7 +8881,7 @@
                   <a:schemeClr val="tx1"/>
                 </a:solidFill>
               </a:rPr>
-              <a:t>HC-SR04 × 6</a:t>
+              <a:t>E-stop</a:t>
             </a:r>
             <a:endParaRPr lang="en-US" sz="1100" dirty="0"/>
           </a:p>
@@ -8533,14 +8889,14 @@
       </p:sp>
       <p:sp>
         <p:nvSpPr>
-          <p:cNvPr id="9" name="Text 5"/>
+          <p:cNvPr id="15" name="Text 9"/>
           <p:cNvSpPr txBox="1"/>
           <p:nvPr/>
         </p:nvSpPr>
         <p:spPr>
           <a:xfrm>
-            <a:off x="3337560" y="2386584"/>
-            <a:ext cx="1417320" cy="201168"/>
+            <a:off x="1600200" y="4041648"/>
+            <a:ext cx="1097280" cy="201168"/>
           </a:xfrm>
           <a:prstGeom prst="rect">
             <a:avLst/>
@@ -8552,7 +8908,7 @@
           <a:bodyPr wrap="square" lIns="0" tIns="0" rIns="0" bIns="0" rtlCol="0" anchor="t"/>
           <a:lstStyle/>
           <a:p>
-            <a:pPr marL="0" indent="0">
+            <a:pPr indent="0" marL="0">
               <a:buNone/>
             </a:pPr>
             <a:r>
@@ -8561,7 +8917,7 @@
                   <a:schemeClr val="accent5"/>
                 </a:solidFill>
               </a:rPr>
-              <a:t>distance all around</a:t>
+              <a:t>cuts motor power</a:t>
             </a:r>
             <a:endParaRPr lang="en-US" sz="1000" dirty="0"/>
           </a:p>
@@ -8569,7 +8925,7 @@
       </p:sp>
       <p:pic>
         <p:nvPicPr>
-          <p:cNvPr id="10" name="MPU6050" descr="MPU6050"/>
+          <p:cNvPr id="16" name="Buzzer" descr="Buzzer">    </p:cNvPr>
           <p:cNvPicPr>
             <a:picLocks noChangeAspect="1"/>
           </p:cNvPicPr>
@@ -8583,8 +8939,8 @@
         </p:blipFill>
         <p:spPr>
           <a:xfrm>
-            <a:off x="457200" y="3154680"/>
-            <a:ext cx="822960" cy="612648"/>
+            <a:off x="2697480" y="3108960"/>
+            <a:ext cx="548640" cy="649224"/>
           </a:xfrm>
           <a:prstGeom prst="rect">
             <a:avLst/>
@@ -8593,13 +8949,13 @@
       </p:pic>
       <p:sp>
         <p:nvSpPr>
-          <p:cNvPr id="11" name="Text 6"/>
+          <p:cNvPr id="17" name="Text 10"/>
           <p:cNvSpPr txBox="1"/>
           <p:nvPr/>
         </p:nvSpPr>
         <p:spPr>
           <a:xfrm>
-            <a:off x="457200" y="3840480"/>
+            <a:off x="2697480" y="3840480"/>
             <a:ext cx="1097280" cy="201168"/>
           </a:xfrm>
           <a:prstGeom prst="rect">
@@ -8612,7 +8968,7 @@
           <a:bodyPr wrap="square" lIns="0" tIns="0" rIns="0" bIns="0" rtlCol="0" anchor="t"/>
           <a:lstStyle/>
           <a:p>
-            <a:pPr marL="0" indent="0">
+            <a:pPr indent="0" marL="0">
               <a:buNone/>
             </a:pPr>
             <a:r>
@@ -8621,7 +8977,7 @@
                   <a:schemeClr val="tx1"/>
                 </a:solidFill>
               </a:rPr>
-              <a:t>MPU6050</a:t>
+              <a:t>Buzzer</a:t>
             </a:r>
             <a:endParaRPr lang="en-US" sz="1100" dirty="0"/>
           </a:p>
@@ -8629,13 +8985,13 @@
       </p:sp>
       <p:sp>
         <p:nvSpPr>
-          <p:cNvPr id="12" name="Text 7"/>
+          <p:cNvPr id="18" name="Text 11"/>
           <p:cNvSpPr txBox="1"/>
           <p:nvPr/>
         </p:nvSpPr>
         <p:spPr>
           <a:xfrm>
-            <a:off x="457200" y="4041648"/>
+            <a:off x="2697480" y="4041648"/>
             <a:ext cx="1097280" cy="201168"/>
           </a:xfrm>
           <a:prstGeom prst="rect">
@@ -8648,7 +9004,7 @@
           <a:bodyPr wrap="square" lIns="0" tIns="0" rIns="0" bIns="0" rtlCol="0" anchor="t"/>
           <a:lstStyle/>
           <a:p>
-            <a:pPr marL="0" indent="0">
+            <a:pPr indent="0" marL="0">
               <a:buNone/>
             </a:pPr>
             <a:r>
@@ -8657,7 +9013,7 @@
                   <a:schemeClr val="accent5"/>
                 </a:solidFill>
               </a:rPr>
-              <a:t>IMU, turning rate</a:t>
+              <a:t>danger alarm</a:t>
             </a:r>
             <a:endParaRPr lang="en-US" sz="1000" dirty="0"/>
           </a:p>
@@ -8665,7 +9021,7 @@
       </p:sp>
       <p:pic>
         <p:nvPicPr>
-          <p:cNvPr id="13" name="E-stop" descr="E-stop"/>
+          <p:cNvPr id="19" name="Battery sense" descr="Battery sense">    </p:cNvPr>
           <p:cNvPicPr>
             <a:picLocks noChangeAspect="1"/>
           </p:cNvPicPr>
@@ -8679,198 +9035,6 @@
         </p:blipFill>
         <p:spPr>
           <a:xfrm>
-            <a:off x="1600200" y="3200400"/>
-            <a:ext cx="749808" cy="502920"/>
-          </a:xfrm>
-          <a:prstGeom prst="rect">
-            <a:avLst/>
-          </a:prstGeom>
-        </p:spPr>
-      </p:pic>
-      <p:sp>
-        <p:nvSpPr>
-          <p:cNvPr id="14" name="Text 8"/>
-          <p:cNvSpPr txBox="1"/>
-          <p:nvPr/>
-        </p:nvSpPr>
-        <p:spPr>
-          <a:xfrm>
-            <a:off x="1600200" y="3840480"/>
-            <a:ext cx="1097280" cy="201168"/>
-          </a:xfrm>
-          <a:prstGeom prst="rect">
-            <a:avLst/>
-          </a:prstGeom>
-          <a:noFill/>
-          <a:ln/>
-        </p:spPr>
-        <p:txBody>
-          <a:bodyPr wrap="square" lIns="0" tIns="0" rIns="0" bIns="0" rtlCol="0" anchor="t"/>
-          <a:lstStyle/>
-          <a:p>
-            <a:pPr marL="0" indent="0">
-              <a:buNone/>
-            </a:pPr>
-            <a:r>
-              <a:rPr lang="en-US" sz="1100" b="1" dirty="0">
-                <a:solidFill>
-                  <a:schemeClr val="tx1"/>
-                </a:solidFill>
-              </a:rPr>
-              <a:t>E-stop</a:t>
-            </a:r>
-            <a:endParaRPr lang="en-US" sz="1100" dirty="0"/>
-          </a:p>
-        </p:txBody>
-      </p:sp>
-      <p:sp>
-        <p:nvSpPr>
-          <p:cNvPr id="15" name="Text 9"/>
-          <p:cNvSpPr txBox="1"/>
-          <p:nvPr/>
-        </p:nvSpPr>
-        <p:spPr>
-          <a:xfrm>
-            <a:off x="1600200" y="4041648"/>
-            <a:ext cx="1097280" cy="201168"/>
-          </a:xfrm>
-          <a:prstGeom prst="rect">
-            <a:avLst/>
-          </a:prstGeom>
-          <a:noFill/>
-          <a:ln/>
-        </p:spPr>
-        <p:txBody>
-          <a:bodyPr wrap="square" lIns="0" tIns="0" rIns="0" bIns="0" rtlCol="0" anchor="t"/>
-          <a:lstStyle/>
-          <a:p>
-            <a:pPr marL="0" indent="0">
-              <a:buNone/>
-            </a:pPr>
-            <a:r>
-              <a:rPr lang="en-US" sz="1000" dirty="0">
-                <a:solidFill>
-                  <a:schemeClr val="accent5"/>
-                </a:solidFill>
-              </a:rPr>
-              <a:t>cuts motor power</a:t>
-            </a:r>
-            <a:endParaRPr lang="en-US" sz="1000" dirty="0"/>
-          </a:p>
-        </p:txBody>
-      </p:sp>
-      <p:pic>
-        <p:nvPicPr>
-          <p:cNvPr id="16" name="Buzzer" descr="Buzzer"/>
-          <p:cNvPicPr>
-            <a:picLocks noChangeAspect="1"/>
-          </p:cNvPicPr>
-          <p:nvPr/>
-        </p:nvPicPr>
-        <p:blipFill>
-          <a:blip r:embed="rId7"/>
-          <a:stretch>
-            <a:fillRect/>
-          </a:stretch>
-        </p:blipFill>
-        <p:spPr>
-          <a:xfrm>
-            <a:off x="2697480" y="3108960"/>
-            <a:ext cx="548640" cy="649224"/>
-          </a:xfrm>
-          <a:prstGeom prst="rect">
-            <a:avLst/>
-          </a:prstGeom>
-        </p:spPr>
-      </p:pic>
-      <p:sp>
-        <p:nvSpPr>
-          <p:cNvPr id="17" name="Text 10"/>
-          <p:cNvSpPr txBox="1"/>
-          <p:nvPr/>
-        </p:nvSpPr>
-        <p:spPr>
-          <a:xfrm>
-            <a:off x="2697480" y="3840480"/>
-            <a:ext cx="1097280" cy="201168"/>
-          </a:xfrm>
-          <a:prstGeom prst="rect">
-            <a:avLst/>
-          </a:prstGeom>
-          <a:noFill/>
-          <a:ln/>
-        </p:spPr>
-        <p:txBody>
-          <a:bodyPr wrap="square" lIns="0" tIns="0" rIns="0" bIns="0" rtlCol="0" anchor="t"/>
-          <a:lstStyle/>
-          <a:p>
-            <a:pPr marL="0" indent="0">
-              <a:buNone/>
-            </a:pPr>
-            <a:r>
-              <a:rPr lang="en-US" sz="1100" b="1" dirty="0">
-                <a:solidFill>
-                  <a:schemeClr val="tx1"/>
-                </a:solidFill>
-              </a:rPr>
-              <a:t>Buzzer</a:t>
-            </a:r>
-            <a:endParaRPr lang="en-US" sz="1100" dirty="0"/>
-          </a:p>
-        </p:txBody>
-      </p:sp>
-      <p:sp>
-        <p:nvSpPr>
-          <p:cNvPr id="18" name="Text 11"/>
-          <p:cNvSpPr txBox="1"/>
-          <p:nvPr/>
-        </p:nvSpPr>
-        <p:spPr>
-          <a:xfrm>
-            <a:off x="2697480" y="4041648"/>
-            <a:ext cx="1097280" cy="201168"/>
-          </a:xfrm>
-          <a:prstGeom prst="rect">
-            <a:avLst/>
-          </a:prstGeom>
-          <a:noFill/>
-          <a:ln/>
-        </p:spPr>
-        <p:txBody>
-          <a:bodyPr wrap="square" lIns="0" tIns="0" rIns="0" bIns="0" rtlCol="0" anchor="t"/>
-          <a:lstStyle/>
-          <a:p>
-            <a:pPr marL="0" indent="0">
-              <a:buNone/>
-            </a:pPr>
-            <a:r>
-              <a:rPr lang="en-US" sz="1000" dirty="0">
-                <a:solidFill>
-                  <a:schemeClr val="accent5"/>
-                </a:solidFill>
-              </a:rPr>
-              <a:t>danger alarm</a:t>
-            </a:r>
-            <a:endParaRPr lang="en-US" sz="1000" dirty="0"/>
-          </a:p>
-        </p:txBody>
-      </p:sp>
-      <p:pic>
-        <p:nvPicPr>
-          <p:cNvPr id="19" name="Battery sense" descr="Battery sense"/>
-          <p:cNvPicPr>
-            <a:picLocks noChangeAspect="1"/>
-          </p:cNvPicPr>
-          <p:nvPr/>
-        </p:nvPicPr>
-        <p:blipFill>
-          <a:blip r:embed="rId8"/>
-          <a:stretch>
-            <a:fillRect/>
-          </a:stretch>
-        </p:blipFill>
-        <p:spPr>
-          <a:xfrm>
             <a:off x="3611880" y="3127248"/>
             <a:ext cx="621792" cy="621792"/>
           </a:xfrm>
@@ -8900,7 +9064,7 @@
           <a:bodyPr wrap="square" lIns="0" tIns="0" rIns="0" bIns="0" rtlCol="0" anchor="t"/>
           <a:lstStyle/>
           <a:p>
-            <a:pPr marL="0" indent="0">
+            <a:pPr indent="0" marL="0">
               <a:buNone/>
             </a:pPr>
             <a:r>
@@ -8936,7 +9100,7 @@
           <a:bodyPr wrap="square" lIns="0" tIns="0" rIns="0" bIns="0" rtlCol="0" anchor="t"/>
           <a:lstStyle/>
           <a:p>
-            <a:pPr marL="0" indent="0">
+            <a:pPr indent="0" marL="0">
               <a:buNone/>
             </a:pPr>
             <a:r>
@@ -8972,7 +9136,7 @@
           <a:bodyPr wrap="square" lIns="0" tIns="0" rIns="0" bIns="0" rtlCol="0" anchor="t"/>
           <a:lstStyle/>
           <a:p>
-            <a:pPr marL="0" indent="0">
+            <a:pPr indent="0" marL="0">
               <a:buNone/>
             </a:pPr>
             <a:r>
@@ -8989,7 +9153,7 @@
       </p:sp>
       <p:graphicFrame>
         <p:nvGraphicFramePr>
-          <p:cNvPr id="23" name="Table 0"/>
+          <p:cNvPr id="9" name="Table 0"/>
           <p:cNvGraphicFramePr>
             <a:graphicFrameLocks noGrp="1"/>
           </p:cNvGraphicFramePr>
@@ -9003,34 +9167,16 @@
         </p:nvGraphicFramePr>
         <p:xfrm>
           <a:off x="5120640" y="1234440"/>
-          <a:ext cx="3566160" cy="2743200"/>
+          <a:ext cx="3566160" cy="914400"/>
         </p:xfrm>
         <a:graphic>
           <a:graphicData uri="http://schemas.openxmlformats.org/drawingml/2006/table">
             <a:tbl>
               <a:tblPr/>
               <a:tblGrid>
-                <a:gridCol w="1691640">
-                  <a:extLst>
-                    <a:ext uri="{9D8B030D-6E8A-4147-A177-3AD203B41FA5}">
-                      <a16:colId xmlns:a16="http://schemas.microsoft.com/office/drawing/2014/main" val="20000"/>
-                    </a:ext>
-                  </a:extLst>
-                </a:gridCol>
-                <a:gridCol w="1188720">
-                  <a:extLst>
-                    <a:ext uri="{9D8B030D-6E8A-4147-A177-3AD203B41FA5}">
-                      <a16:colId xmlns:a16="http://schemas.microsoft.com/office/drawing/2014/main" val="20001"/>
-                    </a:ext>
-                  </a:extLst>
-                </a:gridCol>
-                <a:gridCol w="685800">
-                  <a:extLst>
-                    <a:ext uri="{9D8B030D-6E8A-4147-A177-3AD203B41FA5}">
-                      <a16:colId xmlns:a16="http://schemas.microsoft.com/office/drawing/2014/main" val="20002"/>
-                    </a:ext>
-                  </a:extLst>
-                </a:gridCol>
+                <a:gridCol w="1691640"/>
+                <a:gridCol w="1188720"/>
+                <a:gridCol w="685800"/>
               </a:tblGrid>
               <a:tr h="274320">
                 <a:tc>
@@ -9038,7 +9184,7 @@
                     <a:bodyPr/>
                     <a:lstStyle/>
                     <a:p>
-                      <a:pPr marL="0" indent="0">
+                      <a:pPr indent="0" marL="0">
                         <a:buNone/>
                       </a:pPr>
                       <a:r>
@@ -9106,7 +9252,7 @@
                     <a:bodyPr/>
                     <a:lstStyle/>
                     <a:p>
-                      <a:pPr marL="0" indent="0">
+                      <a:pPr indent="0" marL="0">
                         <a:buNone/>
                       </a:pPr>
                       <a:r>
@@ -9174,7 +9320,7 @@
                     <a:bodyPr/>
                     <a:lstStyle/>
                     <a:p>
-                      <a:pPr marL="0" indent="0" algn="r">
+                      <a:pPr algn="r" indent="0" marL="0">
                         <a:buNone/>
                       </a:pPr>
                       <a:r>
@@ -9237,11 +9383,6 @@
                     </a:solidFill>
                   </a:tcPr>
                 </a:tc>
-                <a:extLst>
-                  <a:ext uri="{0D108BD9-81ED-4DB2-BD59-A6C34878D82A}">
-                    <a16:rowId xmlns:a16="http://schemas.microsoft.com/office/drawing/2014/main" val="10000"/>
-                  </a:ext>
-                </a:extLst>
               </a:tr>
               <a:tr h="274320">
                 <a:tc>
@@ -9249,7 +9390,7 @@
                     <a:bodyPr/>
                     <a:lstStyle/>
                     <a:p>
-                      <a:pPr marL="0" indent="0">
+                      <a:pPr indent="0" marL="0">
                         <a:buNone/>
                       </a:pPr>
                       <a:r>
@@ -9314,7 +9455,7 @@
                     <a:bodyPr/>
                     <a:lstStyle/>
                     <a:p>
-                      <a:pPr marL="0" indent="0">
+                      <a:pPr indent="0" marL="0">
                         <a:buNone/>
                       </a:pPr>
                       <a:r>
@@ -9379,7 +9520,7 @@
                     <a:bodyPr/>
                     <a:lstStyle/>
                     <a:p>
-                      <a:pPr marL="0" indent="0" algn="r">
+                      <a:pPr algn="r" indent="0" marL="0">
                         <a:buNone/>
                       </a:pPr>
                       <a:r>
@@ -9439,11 +9580,6 @@
                     </a:lnB>
                   </a:tcPr>
                 </a:tc>
-                <a:extLst>
-                  <a:ext uri="{0D108BD9-81ED-4DB2-BD59-A6C34878D82A}">
-                    <a16:rowId xmlns:a16="http://schemas.microsoft.com/office/drawing/2014/main" val="10001"/>
-                  </a:ext>
-                </a:extLst>
               </a:tr>
               <a:tr h="274320">
                 <a:tc>
@@ -9451,7 +9587,7 @@
                     <a:bodyPr/>
                     <a:lstStyle/>
                     <a:p>
-                      <a:pPr marL="0" indent="0">
+                      <a:pPr indent="0" marL="0">
                         <a:buNone/>
                       </a:pPr>
                       <a:r>
@@ -9516,7 +9652,7 @@
                     <a:bodyPr/>
                     <a:lstStyle/>
                     <a:p>
-                      <a:pPr marL="0" indent="0">
+                      <a:pPr indent="0" marL="0">
                         <a:buNone/>
                       </a:pPr>
                       <a:r>
@@ -9581,7 +9717,7 @@
                     <a:bodyPr/>
                     <a:lstStyle/>
                     <a:p>
-                      <a:pPr marL="0" indent="0" algn="r">
+                      <a:pPr algn="r" indent="0" marL="0">
                         <a:buNone/>
                       </a:pPr>
                       <a:r>
@@ -9641,11 +9777,6 @@
                     </a:lnB>
                   </a:tcPr>
                 </a:tc>
-                <a:extLst>
-                  <a:ext uri="{0D108BD9-81ED-4DB2-BD59-A6C34878D82A}">
-                    <a16:rowId xmlns:a16="http://schemas.microsoft.com/office/drawing/2014/main" val="10002"/>
-                  </a:ext>
-                </a:extLst>
               </a:tr>
               <a:tr h="274320">
                 <a:tc>
@@ -9653,7 +9784,7 @@
                     <a:bodyPr/>
                     <a:lstStyle/>
                     <a:p>
-                      <a:pPr marL="0" indent="0">
+                      <a:pPr indent="0" marL="0">
                         <a:buNone/>
                       </a:pPr>
                       <a:r>
@@ -9718,7 +9849,7 @@
                     <a:bodyPr/>
                     <a:lstStyle/>
                     <a:p>
-                      <a:pPr marL="0" indent="0">
+                      <a:pPr indent="0" marL="0">
                         <a:buNone/>
                       </a:pPr>
                       <a:r>
@@ -9783,7 +9914,7 @@
                     <a:bodyPr/>
                     <a:lstStyle/>
                     <a:p>
-                      <a:pPr marL="0" indent="0" algn="r">
+                      <a:pPr algn="r" indent="0" marL="0">
                         <a:buNone/>
                       </a:pPr>
                       <a:r>
@@ -9843,11 +9974,6 @@
                     </a:lnB>
                   </a:tcPr>
                 </a:tc>
-                <a:extLst>
-                  <a:ext uri="{0D108BD9-81ED-4DB2-BD59-A6C34878D82A}">
-                    <a16:rowId xmlns:a16="http://schemas.microsoft.com/office/drawing/2014/main" val="10003"/>
-                  </a:ext>
-                </a:extLst>
               </a:tr>
               <a:tr h="274320">
                 <a:tc>
@@ -9855,7 +9981,7 @@
                     <a:bodyPr/>
                     <a:lstStyle/>
                     <a:p>
-                      <a:pPr marL="0" indent="0">
+                      <a:pPr indent="0" marL="0">
                         <a:buNone/>
                       </a:pPr>
                       <a:r>
@@ -9920,7 +10046,7 @@
                     <a:bodyPr/>
                     <a:lstStyle/>
                     <a:p>
-                      <a:pPr marL="0" indent="0">
+                      <a:pPr indent="0" marL="0">
                         <a:buNone/>
                       </a:pPr>
                       <a:r>
@@ -9985,7 +10111,7 @@
                     <a:bodyPr/>
                     <a:lstStyle/>
                     <a:p>
-                      <a:pPr marL="0" indent="0" algn="r">
+                      <a:pPr algn="r" indent="0" marL="0">
                         <a:buNone/>
                       </a:pPr>
                       <a:r>
@@ -10045,11 +10171,6 @@
                     </a:lnB>
                   </a:tcPr>
                 </a:tc>
-                <a:extLst>
-                  <a:ext uri="{0D108BD9-81ED-4DB2-BD59-A6C34878D82A}">
-                    <a16:rowId xmlns:a16="http://schemas.microsoft.com/office/drawing/2014/main" val="10004"/>
-                  </a:ext>
-                </a:extLst>
               </a:tr>
               <a:tr h="274320">
                 <a:tc>
@@ -10057,7 +10178,7 @@
                     <a:bodyPr/>
                     <a:lstStyle/>
                     <a:p>
-                      <a:pPr marL="0" indent="0">
+                      <a:pPr indent="0" marL="0">
                         <a:buNone/>
                       </a:pPr>
                       <a:r>
@@ -10122,7 +10243,7 @@
                     <a:bodyPr/>
                     <a:lstStyle/>
                     <a:p>
-                      <a:pPr marL="0" indent="0">
+                      <a:pPr indent="0" marL="0">
                         <a:buNone/>
                       </a:pPr>
                       <a:r>
@@ -10187,7 +10308,7 @@
                     <a:bodyPr/>
                     <a:lstStyle/>
                     <a:p>
-                      <a:pPr marL="0" indent="0" algn="r">
+                      <a:pPr algn="r" indent="0" marL="0">
                         <a:buNone/>
                       </a:pPr>
                       <a:r>
@@ -10247,11 +10368,6 @@
                     </a:lnB>
                   </a:tcPr>
                 </a:tc>
-                <a:extLst>
-                  <a:ext uri="{0D108BD9-81ED-4DB2-BD59-A6C34878D82A}">
-                    <a16:rowId xmlns:a16="http://schemas.microsoft.com/office/drawing/2014/main" val="10005"/>
-                  </a:ext>
-                </a:extLst>
               </a:tr>
               <a:tr h="274320">
                 <a:tc>
@@ -10259,7 +10375,7 @@
                     <a:bodyPr/>
                     <a:lstStyle/>
                     <a:p>
-                      <a:pPr marL="0" indent="0">
+                      <a:pPr indent="0" marL="0">
                         <a:buNone/>
                       </a:pPr>
                       <a:r>
@@ -10324,7 +10440,7 @@
                     <a:bodyPr/>
                     <a:lstStyle/>
                     <a:p>
-                      <a:pPr marL="0" indent="0">
+                      <a:pPr indent="0" marL="0">
                         <a:buNone/>
                       </a:pPr>
                       <a:r>
@@ -10389,7 +10505,7 @@
                     <a:bodyPr/>
                     <a:lstStyle/>
                     <a:p>
-                      <a:pPr marL="0" indent="0" algn="r">
+                      <a:pPr algn="r" indent="0" marL="0">
                         <a:buNone/>
                       </a:pPr>
                       <a:r>
@@ -10449,11 +10565,6 @@
                     </a:lnB>
                   </a:tcPr>
                 </a:tc>
-                <a:extLst>
-                  <a:ext uri="{0D108BD9-81ED-4DB2-BD59-A6C34878D82A}">
-                    <a16:rowId xmlns:a16="http://schemas.microsoft.com/office/drawing/2014/main" val="10006"/>
-                  </a:ext>
-                </a:extLst>
               </a:tr>
               <a:tr h="274320">
                 <a:tc>
@@ -10461,7 +10572,7 @@
                     <a:bodyPr/>
                     <a:lstStyle/>
                     <a:p>
-                      <a:pPr marL="0" indent="0">
+                      <a:pPr indent="0" marL="0">
                         <a:buNone/>
                       </a:pPr>
                       <a:r>
@@ -10526,7 +10637,7 @@
                     <a:bodyPr/>
                     <a:lstStyle/>
                     <a:p>
-                      <a:pPr marL="0" indent="0">
+                      <a:pPr indent="0" marL="0">
                         <a:buNone/>
                       </a:pPr>
                       <a:r>
@@ -10591,7 +10702,7 @@
                     <a:bodyPr/>
                     <a:lstStyle/>
                     <a:p>
-                      <a:pPr marL="0" indent="0" algn="r">
+                      <a:pPr algn="r" indent="0" marL="0">
                         <a:buNone/>
                       </a:pPr>
                       <a:r>
@@ -10651,11 +10762,6 @@
                     </a:lnB>
                   </a:tcPr>
                 </a:tc>
-                <a:extLst>
-                  <a:ext uri="{0D108BD9-81ED-4DB2-BD59-A6C34878D82A}">
-                    <a16:rowId xmlns:a16="http://schemas.microsoft.com/office/drawing/2014/main" val="10007"/>
-                  </a:ext>
-                </a:extLst>
               </a:tr>
               <a:tr h="274320">
                 <a:tc>
@@ -10663,7 +10769,7 @@
                     <a:bodyPr/>
                     <a:lstStyle/>
                     <a:p>
-                      <a:pPr marL="0" indent="0">
+                      <a:pPr indent="0" marL="0">
                         <a:buNone/>
                       </a:pPr>
                       <a:r>
@@ -10728,7 +10834,7 @@
                     <a:bodyPr/>
                     <a:lstStyle/>
                     <a:p>
-                      <a:pPr marL="0" indent="0">
+                      <a:pPr indent="0" marL="0">
                         <a:buNone/>
                       </a:pPr>
                       <a:endParaRPr lang="en-US" sz="1050" dirty="0">
@@ -10782,7 +10888,7 @@
                     <a:bodyPr/>
                     <a:lstStyle/>
                     <a:p>
-                      <a:pPr marL="0" indent="0" algn="r">
+                      <a:pPr algn="r" indent="0" marL="0">
                         <a:buNone/>
                       </a:pPr>
                       <a:r>
@@ -10842,11 +10948,6 @@
                     </a:lnB>
                   </a:tcPr>
                 </a:tc>
-                <a:extLst>
-                  <a:ext uri="{0D108BD9-81ED-4DB2-BD59-A6C34878D82A}">
-                    <a16:rowId xmlns:a16="http://schemas.microsoft.com/office/drawing/2014/main" val="10008"/>
-                  </a:ext>
-                </a:extLst>
               </a:tr>
               <a:tr h="274320">
                 <a:tc>
@@ -10854,7 +10955,7 @@
                     <a:bodyPr/>
                     <a:lstStyle/>
                     <a:p>
-                      <a:pPr marL="0" indent="0">
+                      <a:pPr indent="0" marL="0">
                         <a:buNone/>
                       </a:pPr>
                       <a:r>
@@ -10919,7 +11020,7 @@
                     <a:bodyPr/>
                     <a:lstStyle/>
                     <a:p>
-                      <a:pPr marL="0" indent="0">
+                      <a:pPr indent="0" marL="0">
                         <a:buNone/>
                       </a:pPr>
                       <a:endParaRPr lang="en-US" sz="1050" dirty="0">
@@ -10973,7 +11074,7 @@
                     <a:bodyPr/>
                     <a:lstStyle/>
                     <a:p>
-                      <a:pPr marL="0" indent="0" algn="r">
+                      <a:pPr algn="r" indent="0" marL="0">
                         <a:buNone/>
                       </a:pPr>
                       <a:r>
@@ -11033,11 +11134,6 @@
                     </a:lnB>
                   </a:tcPr>
                 </a:tc>
-                <a:extLst>
-                  <a:ext uri="{0D108BD9-81ED-4DB2-BD59-A6C34878D82A}">
-                    <a16:rowId xmlns:a16="http://schemas.microsoft.com/office/drawing/2014/main" val="10009"/>
-                  </a:ext>
-                </a:extLst>
               </a:tr>
             </a:tbl>
           </a:graphicData>
@@ -11064,7 +11160,7 @@
           <a:bodyPr wrap="square" lIns="0" tIns="0" rIns="0" bIns="0" rtlCol="0" anchor="t"/>
           <a:lstStyle/>
           <a:p>
-            <a:pPr marL="0" indent="0">
+            <a:pPr indent="0" marL="0">
               <a:buNone/>
             </a:pPr>
             <a:r>
@@ -11099,7 +11195,7 @@
           </a:prstGeom>
           <a:extLst>
             <a:ext uri="{C572A759-6A51-4108-AA02-DFA0A04FC94B}">
-              <ma14:wrappingTextBoxFlag xmlns:ma14="http://schemas.microsoft.com/office/mac/drawingml/2011/main" xmlns="" val="0"/>
+              <ma14:wrappingTextBoxFlag xmlns:ma14="http://schemas.microsoft.com/office/mac/drawingml/2011/main" val="0"/>
             </a:ext>
           </a:extLst>
         </p:spPr>
@@ -11117,7 +11213,7 @@
           <a:p>
             <a:pPr algn="r"/>
             <a:fld id="{F7021451-1387-4CA6-816F-3879F97B5CBC}" type="slidenum">
-              <a:rPr lang="en-US" b="0"/>
+              <a:rPr b="0" lang="en-US"/>
               <a:t>8</a:t>
             </a:fld>
             <a:endParaRPr lang="en-US"/>
@@ -11152,11 +11248,9 @@
       <p:sp>
         <p:nvSpPr>
           <p:cNvPr id="2" name="Text 0"/>
-          <p:cNvSpPr>
-            <a:spLocks noGrp="1"/>
-          </p:cNvSpPr>
+          <p:cNvSpPr/>
           <p:nvPr>
-            <p:ph type="title" idx="100" hasCustomPrompt="1"/>
+            <p:ph idx="100" type="title" hasCustomPrompt="1"/>
           </p:nvPr>
         </p:nvSpPr>
         <p:spPr>
@@ -11174,7 +11268,7 @@
           <a:bodyPr wrap="square" lIns="0" tIns="0" rIns="0" bIns="0" rtlCol="0" anchor="ctr"/>
           <a:lstStyle/>
           <a:p>
-            <a:pPr marL="0" indent="0" algn="l">
+            <a:pPr algn="l" indent="0" marL="0">
               <a:buNone/>
             </a:pPr>
             <a:r>
@@ -11191,14 +11285,14 @@
       </p:sp>
       <p:pic>
         <p:nvPicPr>
-          <p:cNvPr id="3" name="How the circuit works" descr="Sense, think, act: sensors into the Arduino, laptop sends speed commands, Arduino drives motors, buzzer and LED; separate power path through the E-stop"/>
+          <p:cNvPr id="3" name="How the circuit works" descr="Sense, think, act: sensors into the Arduino, laptop sends speed commands, Arduino drives motors, buzzer and LED; separate power path through the E-stop">    </p:cNvPr>
           <p:cNvPicPr>
             <a:picLocks noChangeAspect="1"/>
           </p:cNvPicPr>
           <p:nvPr/>
         </p:nvPicPr>
         <p:blipFill>
-          <a:blip r:embed="rId3"/>
+          <a:blip r:embed="rId1"/>
           <a:stretch>
             <a:fillRect/>
           </a:stretch>
@@ -11233,7 +11327,7 @@
           </a:prstGeom>
           <a:extLst>
             <a:ext uri="{C572A759-6A51-4108-AA02-DFA0A04FC94B}">
-              <ma14:wrappingTextBoxFlag xmlns:ma14="http://schemas.microsoft.com/office/mac/drawingml/2011/main" xmlns="" val="0"/>
+              <ma14:wrappingTextBoxFlag xmlns:ma14="http://schemas.microsoft.com/office/mac/drawingml/2011/main" val="0"/>
             </a:ext>
           </a:extLst>
         </p:spPr>
@@ -11251,7 +11345,7 @@
           <a:p>
             <a:pPr algn="r"/>
             <a:fld id="{F7021451-1387-4CA6-816F-3879F97B5CBC}" type="slidenum">
-              <a:rPr lang="en-US" b="0"/>
+              <a:rPr b="0" lang="en-US"/>
               <a:t>9</a:t>
             </a:fld>
             <a:endParaRPr lang="en-US"/>
@@ -11559,299 +11653,4 @@
     </a:ext>
   </a:extLst>
 </a:theme>
-</file>
-
-<file path=ppt/theme/theme2.xml><?xml version="1.0" encoding="utf-8"?>
-<a:theme xmlns:a="http://schemas.openxmlformats.org/drawingml/2006/main" name="Office Theme">
-  <a:themeElements>
-    <a:clrScheme name="Office">
-      <a:dk1>
-        <a:sysClr val="windowText" lastClr="000000"/>
-      </a:dk1>
-      <a:lt1>
-        <a:sysClr val="window" lastClr="FFFFFF"/>
-      </a:lt1>
-      <a:dk2>
-        <a:srgbClr val="44546A"/>
-      </a:dk2>
-      <a:lt2>
-        <a:srgbClr val="E7E6E6"/>
-      </a:lt2>
-      <a:accent1>
-        <a:srgbClr val="4472C4"/>
-      </a:accent1>
-      <a:accent2>
-        <a:srgbClr val="ED7D31"/>
-      </a:accent2>
-      <a:accent3>
-        <a:srgbClr val="A5A5A5"/>
-      </a:accent3>
-      <a:accent4>
-        <a:srgbClr val="FFC000"/>
-      </a:accent4>
-      <a:accent5>
-        <a:srgbClr val="5B9BD5"/>
-      </a:accent5>
-      <a:accent6>
-        <a:srgbClr val="70AD47"/>
-      </a:accent6>
-      <a:hlink>
-        <a:srgbClr val="0563C1"/>
-      </a:hlink>
-      <a:folHlink>
-        <a:srgbClr val="954F72"/>
-      </a:folHlink>
-    </a:clrScheme>
-    <a:fontScheme name="Office">
-      <a:majorFont>
-        <a:latin typeface="Calibri Light" panose="020F0302020204030204"/>
-        <a:ea typeface=""/>
-        <a:cs typeface=""/>
-        <a:font script="Jpan" typeface="游ゴシック Light"/>
-        <a:font script="Hang" typeface="맑은 고딕"/>
-        <a:font script="Hans" typeface="等线 Light"/>
-        <a:font script="Hant" typeface="新細明體"/>
-        <a:font script="Arab" typeface="Times New Roman"/>
-        <a:font script="Hebr" typeface="Times New Roman"/>
-        <a:font script="Thai" typeface="Angsana New"/>
-        <a:font script="Ethi" typeface="Nyala"/>
-        <a:font script="Beng" typeface="Vrinda"/>
-        <a:font script="Gujr" typeface="Shruti"/>
-        <a:font script="Khmr" typeface="MoolBoran"/>
-        <a:font script="Knda" typeface="Tunga"/>
-        <a:font script="Guru" typeface="Raavi"/>
-        <a:font script="Cans" typeface="Euphemia"/>
-        <a:font script="Cher" typeface="Plantagenet Cherokee"/>
-        <a:font script="Yiii" typeface="Microsoft Yi Baiti"/>
-        <a:font script="Tibt" typeface="Microsoft Himalaya"/>
-        <a:font script="Thaa" typeface="MV Boli"/>
-        <a:font script="Deva" typeface="Mangal"/>
-        <a:font script="Telu" typeface="Gautami"/>
-        <a:font script="Taml" typeface="Latha"/>
-        <a:font script="Syrc" typeface="Estrangelo Edessa"/>
-        <a:font script="Orya" typeface="Kalinga"/>
-        <a:font script="Mlym" typeface="Kartika"/>
-        <a:font script="Laoo" typeface="DokChampa"/>
-        <a:font script="Sinh" typeface="Iskoola Pota"/>
-        <a:font script="Mong" typeface="Mongolian Baiti"/>
-        <a:font script="Viet" typeface="Times New Roman"/>
-        <a:font script="Uigh" typeface="Microsoft Uighur"/>
-        <a:font script="Geor" typeface="Sylfaen"/>
-        <a:font script="Armn" typeface="Arial"/>
-        <a:font script="Bugi" typeface="Leelawadee UI"/>
-        <a:font script="Bopo" typeface="Microsoft JhengHei"/>
-        <a:font script="Java" typeface="Javanese Text"/>
-        <a:font script="Lisu" typeface="Segoe UI"/>
-        <a:font script="Mymr" typeface="Myanmar Text"/>
-        <a:font script="Nkoo" typeface="Ebrima"/>
-        <a:font script="Olck" typeface="Nirmala UI"/>
-        <a:font script="Osma" typeface="Ebrima"/>
-        <a:font script="Phag" typeface="Phagspa"/>
-        <a:font script="Syrn" typeface="Estrangelo Edessa"/>
-        <a:font script="Syrj" typeface="Estrangelo Edessa"/>
-        <a:font script="Syre" typeface="Estrangelo Edessa"/>
-        <a:font script="Sora" typeface="Nirmala UI"/>
-        <a:font script="Tale" typeface="Microsoft Tai Le"/>
-        <a:font script="Talu" typeface="Microsoft New Tai Lue"/>
-        <a:font script="Tfng" typeface="Ebrima"/>
-      </a:majorFont>
-      <a:minorFont>
-        <a:latin typeface="Calibri" panose="020F0502020204030204"/>
-        <a:ea typeface=""/>
-        <a:cs typeface=""/>
-        <a:font script="Jpan" typeface="游ゴシック"/>
-        <a:font script="Hang" typeface="맑은 고딕"/>
-        <a:font script="Hans" typeface="等线"/>
-        <a:font script="Hant" typeface="新細明體"/>
-        <a:font script="Arab" typeface="Arial"/>
-        <a:font script="Hebr" typeface="Arial"/>
-        <a:font script="Thai" typeface="Cordia New"/>
-        <a:font script="Ethi" typeface="Nyala"/>
-        <a:font script="Beng" typeface="Vrinda"/>
-        <a:font script="Gujr" typeface="Shruti"/>
-        <a:font script="Khmr" typeface="DaunPenh"/>
-        <a:font script="Knda" typeface="Tunga"/>
-        <a:font script="Guru" typeface="Raavi"/>
-        <a:font script="Cans" typeface="Euphemia"/>
-        <a:font script="Cher" typeface="Plantagenet Cherokee"/>
-        <a:font script="Yiii" typeface="Microsoft Yi Baiti"/>
-        <a:font script="Tibt" typeface="Microsoft Himalaya"/>
-        <a:font script="Thaa" typeface="MV Boli"/>
-        <a:font script="Deva" typeface="Mangal"/>
-        <a:font script="Telu" typeface="Gautami"/>
-        <a:font script="Taml" typeface="Latha"/>
-        <a:font script="Syrc" typeface="Estrangelo Edessa"/>
-        <a:font script="Orya" typeface="Kalinga"/>
-        <a:font script="Mlym" typeface="Kartika"/>
-        <a:font script="Laoo" typeface="DokChampa"/>
-        <a:font script="Sinh" typeface="Iskoola Pota"/>
-        <a:font script="Mong" typeface="Mongolian Baiti"/>
-        <a:font script="Viet" typeface="Arial"/>
-        <a:font script="Uigh" typeface="Microsoft Uighur"/>
-        <a:font script="Geor" typeface="Sylfaen"/>
-        <a:font script="Armn" typeface="Arial"/>
-        <a:font script="Bugi" typeface="Leelawadee UI"/>
-        <a:font script="Bopo" typeface="Microsoft JhengHei"/>
-        <a:font script="Java" typeface="Javanese Text"/>
-        <a:font script="Lisu" typeface="Segoe UI"/>
-        <a:font script="Mymr" typeface="Myanmar Text"/>
-        <a:font script="Nkoo" typeface="Ebrima"/>
-        <a:font script="Olck" typeface="Nirmala UI"/>
-        <a:font script="Osma" typeface="Ebrima"/>
-        <a:font script="Phag" typeface="Phagspa"/>
-        <a:font script="Syrn" typeface="Estrangelo Edessa"/>
-        <a:font script="Syrj" typeface="Estrangelo Edessa"/>
-        <a:font script="Syre" typeface="Estrangelo Edessa"/>
-        <a:font script="Sora" typeface="Nirmala UI"/>
-        <a:font script="Tale" typeface="Microsoft Tai Le"/>
-        <a:font script="Talu" typeface="Microsoft New Tai Lue"/>
-        <a:font script="Tfng" typeface="Ebrima"/>
-      </a:minorFont>
-    </a:fontScheme>
-    <a:fmtScheme name="Office">
-      <a:fillStyleLst>
-        <a:solidFill>
-          <a:schemeClr val="phClr"/>
-        </a:solidFill>
-        <a:gradFill rotWithShape="1">
-          <a:gsLst>
-            <a:gs pos="0">
-              <a:schemeClr val="phClr">
-                <a:lumMod val="110000"/>
-                <a:satMod val="105000"/>
-                <a:tint val="67000"/>
-              </a:schemeClr>
-            </a:gs>
-            <a:gs pos="50000">
-              <a:schemeClr val="phClr">
-                <a:lumMod val="105000"/>
-                <a:satMod val="103000"/>
-                <a:tint val="73000"/>
-              </a:schemeClr>
-            </a:gs>
-            <a:gs pos="100000">
-              <a:schemeClr val="phClr">
-                <a:lumMod val="105000"/>
-                <a:satMod val="109000"/>
-                <a:tint val="81000"/>
-              </a:schemeClr>
-            </a:gs>
-          </a:gsLst>
-          <a:lin ang="5400000" scaled="0"/>
-        </a:gradFill>
-        <a:gradFill rotWithShape="1">
-          <a:gsLst>
-            <a:gs pos="0">
-              <a:schemeClr val="phClr">
-                <a:satMod val="103000"/>
-                <a:lumMod val="102000"/>
-                <a:tint val="94000"/>
-              </a:schemeClr>
-            </a:gs>
-            <a:gs pos="50000">
-              <a:schemeClr val="phClr">
-                <a:satMod val="110000"/>
-                <a:lumMod val="100000"/>
-                <a:shade val="100000"/>
-              </a:schemeClr>
-            </a:gs>
-            <a:gs pos="100000">
-              <a:schemeClr val="phClr">
-                <a:lumMod val="99000"/>
-                <a:satMod val="120000"/>
-                <a:shade val="78000"/>
-              </a:schemeClr>
-            </a:gs>
-          </a:gsLst>
-          <a:lin ang="5400000" scaled="0"/>
-        </a:gradFill>
-      </a:fillStyleLst>
-      <a:lnStyleLst>
-        <a:ln w="6350" cap="flat" cmpd="sng" algn="ctr">
-          <a:solidFill>
-            <a:schemeClr val="phClr"/>
-          </a:solidFill>
-          <a:prstDash val="solid"/>
-          <a:miter lim="800000"/>
-        </a:ln>
-        <a:ln w="12700" cap="flat" cmpd="sng" algn="ctr">
-          <a:solidFill>
-            <a:schemeClr val="phClr"/>
-          </a:solidFill>
-          <a:prstDash val="solid"/>
-          <a:miter lim="800000"/>
-        </a:ln>
-        <a:ln w="19050" cap="flat" cmpd="sng" algn="ctr">
-          <a:solidFill>
-            <a:schemeClr val="phClr"/>
-          </a:solidFill>
-          <a:prstDash val="solid"/>
-          <a:miter lim="800000"/>
-        </a:ln>
-      </a:lnStyleLst>
-      <a:effectStyleLst>
-        <a:effectStyle>
-          <a:effectLst/>
-        </a:effectStyle>
-        <a:effectStyle>
-          <a:effectLst/>
-        </a:effectStyle>
-        <a:effectStyle>
-          <a:effectLst>
-            <a:outerShdw blurRad="57150" dist="19050" dir="5400000" algn="ctr" rotWithShape="0">
-              <a:srgbClr val="000000">
-                <a:alpha val="63000"/>
-              </a:srgbClr>
-            </a:outerShdw>
-          </a:effectLst>
-        </a:effectStyle>
-      </a:effectStyleLst>
-      <a:bgFillStyleLst>
-        <a:solidFill>
-          <a:schemeClr val="phClr"/>
-        </a:solidFill>
-        <a:solidFill>
-          <a:schemeClr val="phClr">
-            <a:tint val="95000"/>
-            <a:satMod val="170000"/>
-          </a:schemeClr>
-        </a:solidFill>
-        <a:gradFill rotWithShape="1">
-          <a:gsLst>
-            <a:gs pos="0">
-              <a:schemeClr val="phClr">
-                <a:tint val="93000"/>
-                <a:satMod val="150000"/>
-                <a:shade val="98000"/>
-                <a:lumMod val="102000"/>
-              </a:schemeClr>
-            </a:gs>
-            <a:gs pos="50000">
-              <a:schemeClr val="phClr">
-                <a:tint val="98000"/>
-                <a:satMod val="130000"/>
-                <a:shade val="90000"/>
-                <a:lumMod val="103000"/>
-              </a:schemeClr>
-            </a:gs>
-            <a:gs pos="100000">
-              <a:schemeClr val="phClr">
-                <a:shade val="63000"/>
-                <a:satMod val="120000"/>
-              </a:schemeClr>
-            </a:gs>
-          </a:gsLst>
-          <a:lin ang="5400000" scaled="0"/>
-        </a:gradFill>
-      </a:bgFillStyleLst>
-    </a:fmtScheme>
-  </a:themeElements>
-  <a:objectDefaults/>
-  <a:extraClrSchemeLst/>
-  <a:extLst>
-    <a:ext uri="{05A4C25C-085E-4340-85A3-A5531E510DB2}">
-      <thm15:themeFamily xmlns:thm15="http://schemas.microsoft.com/office/thememl/2012/main" name="Office Theme" id="{62F939B6-93AF-4DB8-9C6B-D6C7DFDC589F}" vid="{4A3C46E8-61CC-4603-A589-7422A47A8E4A}"/>
-    </a:ext>
-  </a:extLst>
-</a:theme>
 </file>
</xml_diff>

<commit_message>
feat: add live demo link
</commit_message>
<xml_diff>
--- a/presentation/VISTARA-X_Hack01.pptx
+++ b/presentation/VISTARA-X_Hack01.pptx
@@ -15,13 +15,9 @@
     <p:sldId id="263" r:id="rId9"/>
     <p:sldId id="264" r:id="rId10"/>
     <p:sldId id="265" r:id="rId11"/>
-    <p:sldId id="266" r:id="rId12"/>
-    <p:sldId id="267" r:id="rId13"/>
-    <p:sldId id="268" r:id="rId14"/>
-    <p:sldId id="269" r:id="rId15"/>
   </p:sldIdLst>
   <p:notesMasterIdLst>
-    <p:notesMasterId r:id="rId16"/>
+    <p:notesMasterId r:id="rId12"/>
   </p:notesMasterIdLst>
   <p:sldSz cx="9144000" cy="5143500"/>
   <p:notesSz cx="5143500" cy="9144000"/>
@@ -120,38 +116,30 @@
   <p:extLst>
     <p:ext uri="{521415D9-36F7-43E2-AB2F-B90AF26B5E84}">
       <p14:sectionLst xmlns:p14="http://schemas.microsoft.com/office/powerpoint/2010/main">
-        <p14:section name="Introduction" id="{29315915-2352-50e9-2b8b-815d178b03be}">
+        <p14:section name="Introduction" id="{c2ea0573-1fac-77d8-49b8-702ce9fd8db1}">
           <p14:sldIdLst>
             <p14:sldId id="256"/>
             <p14:sldId id="257"/>
           </p14:sldIdLst>
         </p14:section>
-        <p14:section name="How it works" id="{b8f7344c-76e4-1068-f626-9dd08d87cc3b}">
+        <p14:section name="How it works" id="{fcbeefe5-5414-90c0-385e-b943d2568940}">
           <p14:sldIdLst>
             <p14:sldId id="258"/>
             <p14:sldId id="259"/>
             <p14:sldId id="260"/>
+          </p14:sldIdLst>
+        </p14:section>
+        <p14:section name="Results" id="{902c956e-a3ac-bfed-488e-539d5edb1d71}">
+          <p14:sldIdLst>
             <p14:sldId id="261"/>
           </p14:sldIdLst>
         </p14:section>
-        <p14:section name="Results" id="{b57b9541-9b5c-d7a3-b96c-e67712941c78}">
+        <p14:section name="Hardware" id="{ad2d01f6-1db4-b1c1-589a-c017f642aab6}">
           <p14:sldIdLst>
             <p14:sldId id="262"/>
-          </p14:sldIdLst>
-        </p14:section>
-        <p14:section name="Hardware" id="{41f527a4-3ef8-2018-1f18-0ef4c3985925}">
-          <p14:sldIdLst>
             <p14:sldId id="263"/>
             <p14:sldId id="264"/>
             <p14:sldId id="265"/>
-            <p14:sldId id="266"/>
-            <p14:sldId id="267"/>
-            <p14:sldId id="268"/>
-          </p14:sldIdLst>
-        </p14:section>
-        <p14:section name="Close" id="{6050c5d8-91ca-c544-a3fa-eaab1494907b}">
-          <p14:sldIdLst>
-            <p14:sldId id="269"/>
           </p14:sldIdLst>
         </p14:section>
       </p14:sectionLst>
@@ -496,406 +484,6 @@
 </c:chartSpace>
 </file>
 
-<file path=ppt/charts/chart2.xml><?xml version="1.0" encoding="utf-8"?>
-<c:chartSpace xmlns:c="http://schemas.openxmlformats.org/drawingml/2006/chart" xmlns:a="http://schemas.openxmlformats.org/drawingml/2006/main" xmlns:r="http://schemas.openxmlformats.org/officeDocument/2006/relationships">
-  <c:date1904 val="0"/>
-  <c:roundedCorners val="1"/>
-  <c:chart>
-    <c:title>
-      <c:tx>
-        <c:rich>
-          <a:bodyPr/>
-          <a:lstStyle/>
-          <a:p>
-            <a:pPr>
-              <a:defRPr sz="1200" b="0" i="0" u="none" strike="noStrike">
-                <a:solidFill>
-                  <a:srgbClr val="4B5866"/>
-                </a:solidFill>
-                <a:latin typeface="+mn-lt"/>
-              </a:defRPr>
-            </a:pPr>
-            <a:r>
-              <a:rPr sz="1200" b="0" i="0" u="none" strike="noStrike">
-                <a:solidFill>
-                  <a:srgbClr val="4B5866"/>
-                </a:solidFill>
-                <a:latin typeface="+mn-lt"/>
-              </a:rPr>
-              <a:t>₹ thousand</a:t>
-            </a:r>
-          </a:p>
-        </c:rich>
-      </c:tx>
-      <c:layout/>
-      <c:overlay val="0"/>
-    </c:title>
-    <c:autoTitleDeleted val="0"/>
-    <c:plotArea>
-      <c:layout/>
-      <c:doughnutChart>
-        <c:varyColors val="1"/>
-        <c:ser>
-          <c:idx val="0"/>
-          <c:order val="0"/>
-          <c:tx>
-            <c:strRef>
-              <c:f>Sheet1!$B$1</c:f>
-              <c:strCache>
-                <c:ptCount val="1"/>
-                <c:pt idx="0">
-                  <c:v>Cost (₹ thousand)</c:v>
-                </c:pt>
-              </c:strCache>
-            </c:strRef>
-          </c:tx>
-          <c:spPr>
-            <a:solidFill>
-              <a:schemeClr val="accent1"/>
-            </a:solidFill>
-            <a:ln w="9525" cap="flat">
-              <a:solidFill>
-                <a:srgbClr val="F9F9F9"/>
-              </a:solidFill>
-              <a:prstDash val="solid"/>
-              <a:round/>
-            </a:ln>
-            <a:effectLst/>
-          </c:spPr>
-          <c:dPt>
-            <c:idx val="0"/>
-            <c:bubble3D val="0"/>
-            <c:spPr>
-              <a:solidFill>
-                <a:srgbClr val="0B7D73"/>
-              </a:solidFill>
-              <a:effectLst/>
-            </c:spPr>
-          </c:dPt>
-          <c:dPt>
-            <c:idx val="1"/>
-            <c:bubble3D val="0"/>
-            <c:spPr>
-              <a:solidFill>
-                <a:srgbClr val="101820"/>
-              </a:solidFill>
-              <a:effectLst/>
-            </c:spPr>
-          </c:dPt>
-          <c:dPt>
-            <c:idx val="2"/>
-            <c:bubble3D val="0"/>
-            <c:spPr>
-              <a:solidFill>
-                <a:srgbClr val="D9A441"/>
-              </a:solidFill>
-              <a:effectLst/>
-            </c:spPr>
-          </c:dPt>
-          <c:dPt>
-            <c:idx val="3"/>
-            <c:bubble3D val="0"/>
-            <c:spPr>
-              <a:solidFill>
-                <a:srgbClr val="8FA3B0"/>
-              </a:solidFill>
-              <a:effectLst/>
-            </c:spPr>
-          </c:dPt>
-          <c:dPt>
-            <c:idx val="4"/>
-            <c:bubble3D val="0"/>
-            <c:spPr>
-              <a:solidFill>
-                <a:srgbClr val="C0352A"/>
-              </a:solidFill>
-              <a:effectLst/>
-            </c:spPr>
-          </c:dPt>
-          <c:dPt>
-            <c:idx val="5"/>
-            <c:bubble3D val="0"/>
-            <c:spPr>
-              <a:solidFill>
-                <a:srgbClr val="7C5CE0"/>
-              </a:solidFill>
-              <a:effectLst/>
-            </c:spPr>
-          </c:dPt>
-          <c:dLbls>
-            <c:dLbl>
-              <c:idx val="0"/>
-              <c:numFmt formatCode="0.0" sourceLinked="0"/>
-              <c:spPr/>
-              <c:txPr>
-                <a:bodyPr/>
-                <a:lstStyle/>
-                <a:p>
-                  <a:pPr>
-                    <a:defRPr sz="1100" b="0" i="0" u="none" strike="noStrike">
-                      <a:solidFill>
-                        <a:srgbClr val="FFFFFF"/>
-                      </a:solidFill>
-                      <a:latin typeface="+mn-lt"/>
-                    </a:defRPr>
-                  </a:pPr>
-                </a:p>
-              </c:txPr>
-              <c:showLegendKey val="0"/>
-              <c:showVal val="1"/>
-              <c:showCatName val="0"/>
-              <c:showSerName val="0"/>
-              <c:showPercent val="0"/>
-              <c:showBubbleSize val="0"/>
-            </c:dLbl>
-            <c:dLbl>
-              <c:idx val="1"/>
-              <c:numFmt formatCode="0.0" sourceLinked="0"/>
-              <c:spPr/>
-              <c:txPr>
-                <a:bodyPr/>
-                <a:lstStyle/>
-                <a:p>
-                  <a:pPr>
-                    <a:defRPr sz="1100" b="0" i="0" u="none" strike="noStrike">
-                      <a:solidFill>
-                        <a:srgbClr val="FFFFFF"/>
-                      </a:solidFill>
-                      <a:latin typeface="+mn-lt"/>
-                    </a:defRPr>
-                  </a:pPr>
-                </a:p>
-              </c:txPr>
-              <c:showLegendKey val="0"/>
-              <c:showVal val="1"/>
-              <c:showCatName val="0"/>
-              <c:showSerName val="0"/>
-              <c:showPercent val="0"/>
-              <c:showBubbleSize val="0"/>
-            </c:dLbl>
-            <c:dLbl>
-              <c:idx val="2"/>
-              <c:numFmt formatCode="0.0" sourceLinked="0"/>
-              <c:spPr/>
-              <c:txPr>
-                <a:bodyPr/>
-                <a:lstStyle/>
-                <a:p>
-                  <a:pPr>
-                    <a:defRPr sz="1100" b="0" i="0" u="none" strike="noStrike">
-                      <a:solidFill>
-                        <a:srgbClr val="FFFFFF"/>
-                      </a:solidFill>
-                      <a:latin typeface="+mn-lt"/>
-                    </a:defRPr>
-                  </a:pPr>
-                </a:p>
-              </c:txPr>
-              <c:showLegendKey val="0"/>
-              <c:showVal val="1"/>
-              <c:showCatName val="0"/>
-              <c:showSerName val="0"/>
-              <c:showPercent val="0"/>
-              <c:showBubbleSize val="0"/>
-            </c:dLbl>
-            <c:dLbl>
-              <c:idx val="3"/>
-              <c:numFmt formatCode="0.0" sourceLinked="0"/>
-              <c:spPr/>
-              <c:txPr>
-                <a:bodyPr/>
-                <a:lstStyle/>
-                <a:p>
-                  <a:pPr>
-                    <a:defRPr sz="1100" b="0" i="0" u="none" strike="noStrike">
-                      <a:solidFill>
-                        <a:srgbClr val="FFFFFF"/>
-                      </a:solidFill>
-                      <a:latin typeface="+mn-lt"/>
-                    </a:defRPr>
-                  </a:pPr>
-                </a:p>
-              </c:txPr>
-              <c:showLegendKey val="0"/>
-              <c:showVal val="1"/>
-              <c:showCatName val="0"/>
-              <c:showSerName val="0"/>
-              <c:showPercent val="0"/>
-              <c:showBubbleSize val="0"/>
-            </c:dLbl>
-            <c:dLbl>
-              <c:idx val="4"/>
-              <c:numFmt formatCode="0.0" sourceLinked="0"/>
-              <c:spPr/>
-              <c:txPr>
-                <a:bodyPr/>
-                <a:lstStyle/>
-                <a:p>
-                  <a:pPr>
-                    <a:defRPr sz="1100" b="0" i="0" u="none" strike="noStrike">
-                      <a:solidFill>
-                        <a:srgbClr val="FFFFFF"/>
-                      </a:solidFill>
-                      <a:latin typeface="+mn-lt"/>
-                    </a:defRPr>
-                  </a:pPr>
-                </a:p>
-              </c:txPr>
-              <c:showLegendKey val="0"/>
-              <c:showVal val="1"/>
-              <c:showCatName val="0"/>
-              <c:showSerName val="0"/>
-              <c:showPercent val="0"/>
-              <c:showBubbleSize val="0"/>
-            </c:dLbl>
-            <c:dLbl>
-              <c:idx val="5"/>
-              <c:numFmt formatCode="0.0" sourceLinked="0"/>
-              <c:spPr/>
-              <c:txPr>
-                <a:bodyPr/>
-                <a:lstStyle/>
-                <a:p>
-                  <a:pPr>
-                    <a:defRPr sz="1100" b="0" i="0" u="none" strike="noStrike">
-                      <a:solidFill>
-                        <a:srgbClr val="FFFFFF"/>
-                      </a:solidFill>
-                      <a:latin typeface="+mn-lt"/>
-                    </a:defRPr>
-                  </a:pPr>
-                </a:p>
-              </c:txPr>
-              <c:showLegendKey val="0"/>
-              <c:showVal val="1"/>
-              <c:showCatName val="0"/>
-              <c:showSerName val="0"/>
-              <c:showPercent val="0"/>
-              <c:showBubbleSize val="0"/>
-            </c:dLbl>
-            <c:numFmt formatCode="0.0" sourceLinked="0"/>
-            <c:txPr>
-              <a:bodyPr/>
-              <a:lstStyle/>
-              <a:p>
-                <a:pPr>
-                  <a:defRPr sz="1800" b="0" i="0" u="none" strike="noStrike">
-                    <a:solidFill>
-                      <a:srgbClr val="000000"/>
-                    </a:solidFill>
-                    <a:latin typeface="Arial"/>
-                  </a:defRPr>
-                </a:pPr>
-              </a:p>
-            </c:txPr>
-            <c:showLegendKey val="0"/>
-            <c:showVal val="0"/>
-            <c:showCatName val="1"/>
-            <c:showSerName val="0"/>
-            <c:showPercent val="1"/>
-            <c:showBubbleSize val="0"/>
-            <c:showLeaderLines val="0"/>
-          </c:dLbls>
-          <c:cat>
-            <c:strRef>
-              <c:f>Sheet1!$A$2:$A$7</c:f>
-              <c:strCache>
-                <c:ptCount val="6"/>
-                <c:pt idx="0">
-                  <c:v>LiDAR</c:v>
-                </c:pt>
-                <c:pt idx="1">
-                  <c:v>Drive + chassis</c:v>
-                </c:pt>
-                <c:pt idx="2">
-                  <c:v>Electronics</c:v>
-                </c:pt>
-                <c:pt idx="3">
-                  <c:v>Cables, misc.</c:v>
-                </c:pt>
-                <c:pt idx="4">
-                  <c:v>Battery</c:v>
-                </c:pt>
-                <c:pt idx="5">
-                  <c:v>Camera</c:v>
-                </c:pt>
-              </c:strCache>
-            </c:strRef>
-          </c:cat>
-          <c:val>
-            <c:numRef>
-              <c:f>Sheet1!$B$2:$B$7</c:f>
-              <c:numCache>
-                <c:ptCount val="6"/>
-                <c:pt idx="0">
-                  <c:v>8.5</c:v>
-                </c:pt>
-                <c:pt idx="1">
-                  <c:v>5.1</c:v>
-                </c:pt>
-                <c:pt idx="2">
-                  <c:v>2.1</c:v>
-                </c:pt>
-                <c:pt idx="3">
-                  <c:v>1.8</c:v>
-                </c:pt>
-                <c:pt idx="4">
-                  <c:v>1.8</c:v>
-                </c:pt>
-                <c:pt idx="5">
-                  <c:v>1.6</c:v>
-                </c:pt>
-              </c:numCache>
-            </c:numRef>
-          </c:val>
-        </c:ser>
-        <c:firstSliceAng val="0"/>
-        <c:holeSize val="55"/>
-      </c:doughnutChart>
-      <c:spPr>
-        <a:noFill/>
-        <a:ln>
-          <a:noFill/>
-        </a:ln>
-        <a:effectLst/>
-      </c:spPr>
-    </c:plotArea>
-    <c:legend>
-      <c:legendPos val="r"/>
-      <c:overlay val="0"/>
-      <c:txPr>
-        <a:bodyPr/>
-        <a:lstStyle/>
-        <a:p>
-          <a:pPr>
-            <a:defRPr sz="1100">
-              <a:solidFill>
-                <a:srgbClr val="4B5866"/>
-              </a:solidFill>
-              <a:latin typeface="+mn-lt"/>
-              <a:cs typeface="+mn-lt"/>
-            </a:defRPr>
-          </a:pPr>
-          <a:endParaRPr lang="en-US"/>
-        </a:p>
-      </c:txPr>
-    </c:legend>
-    <c:plotVisOnly val="1"/>
-    <c:dispBlanksAs val="span"/>
-  </c:chart>
-  <c:spPr>
-    <a:noFill/>
-    <a:ln>
-      <a:noFill/>
-    </a:ln>
-    <a:effectLst/>
-  </c:spPr>
-  <c:externalData r:id="rId1">
-    <c:autoUpdate val="0"/>
-  </c:externalData>
-</c:chartSpace>
-</file>
-
 <file path=ppt/notesMasters/notesMaster1.xml><?xml version="1.0" encoding="utf-8"?>
 <p:notesMaster xmlns:a="http://schemas.openxmlformats.org/drawingml/2006/main" xmlns:r="http://schemas.openxmlformats.org/officeDocument/2006/relationships" xmlns:p="http://schemas.openxmlformats.org/presentationml/2006/main">
   <p:cSld>
@@ -1379,7 +967,7 @@
           <a:p>
             <a:r>
               <a:rPr lang="en-US" dirty="0"/>
-              <a:t>Every connection with its pin: motor driver on 5 to 8, wheel encoders on interrupt pins 2 and 3, the six ultrasonic sensors on 30 to 41, the IMU on I2C, battery on A0, E-stop on 26.</a:t>
+              <a:t>Getting to a real robot takes about ten weeks. Week one is already de-risked because the same Arduino firmware runs in Wokwi today. The navigation code does not change, only the sensor source and the motor output. Thank you.</a:t>
             </a:r>
             <a:endParaRPr lang="en-US" dirty="0"/>
           </a:p>
@@ -1403,358 +991,6 @@
             <a:fld id="{F7021451-1387-4CA6-816F-3879F97B5CBC}" type="slidenum">
               <a:rPr lang="en-US"/>
               <a:t>10</a:t>
-            </a:fld>
-            <a:endParaRPr lang="en-US"/>
-          </a:p>
-        </p:txBody>
-      </p:sp>
-    </p:spTree>
-    <p:extLst>
-      <p:ext uri="{BB962C8B-B14F-4D97-AF65-F5344CB8AC3E}">
-        <p14:creationId xmlns:p14="http://schemas.microsoft.com/office/powerpoint/2010/main" val="1024086991"/>
-      </p:ext>
-    </p:extLst>
-  </p:cSld>
-  <p:clrMapOvr>
-    <a:masterClrMapping/>
-  </p:clrMapOvr>
-</p:notes>
-</file>
-
-<file path=ppt/notesSlides/notesSlide11.xml><?xml version="1.0" encoding="utf-8"?>
-<p:notes xmlns:a="http://schemas.openxmlformats.org/drawingml/2006/main" xmlns:r="http://schemas.openxmlformats.org/officeDocument/2006/relationships" xmlns:p="http://schemas.openxmlformats.org/presentationml/2006/main">
-  <p:cSld>
-    <p:spTree>
-      <p:nvGrpSpPr>
-        <p:cNvPr id="1" name=""/>
-        <p:cNvGrpSpPr/>
-        <p:nvPr/>
-      </p:nvGrpSpPr>
-      <p:grpSpPr>
-        <a:xfrm>
-          <a:off x="0" y="0"/>
-          <a:ext cx="0" cy="0"/>
-          <a:chOff x="0" y="0"/>
-          <a:chExt cx="0" cy="0"/>
-        </a:xfrm>
-      </p:grpSpPr>
-      <p:sp>
-        <p:nvSpPr>
-          <p:cNvPr id="2" name="Slide Image Placeholder 1"/>
-          <p:cNvSpPr>
-            <a:spLocks noGrp="1" noRot="1" noChangeAspect="1"/>
-          </p:cNvSpPr>
-          <p:nvPr>
-            <p:ph type="sldImg"/>
-          </p:nvPr>
-        </p:nvSpPr>
-        <p:spPr/>
-      </p:sp>
-      <p:sp>
-        <p:nvSpPr>
-          <p:cNvPr id="3" name="Notes Placeholder 2"/>
-          <p:cNvSpPr>
-            <a:spLocks noGrp="1"/>
-          </p:cNvSpPr>
-          <p:nvPr>
-            <p:ph type="body" idx="1"/>
-          </p:nvPr>
-        </p:nvSpPr>
-        <p:spPr/>
-        <p:txBody>
-          <a:bodyPr/>
-          <a:lstStyle/>
-          <a:p>
-            <a:r>
-              <a:rPr lang="en-US" dirty="0"/>
-              <a:t>The firmware runs in Wokwi with the same pin map as the real robot. When you press Start, an automatic tour shows every safety rule in about 46 seconds and explains each step in the serial monitor. The robot's front points right, and each ultrasonic sensor sits on the side it faces. The motor LEDs show the PWM; moving a sensor's distance slows or stops the robot, the E-stop cuts everything at once and stays latched, and the battery knob triggers the low-battery rules.</a:t>
-            </a:r>
-            <a:endParaRPr lang="en-US" dirty="0"/>
-          </a:p>
-        </p:txBody>
-      </p:sp>
-      <p:sp>
-        <p:nvSpPr>
-          <p:cNvPr id="4" name="Slide Number Placeholder 3"/>
-          <p:cNvSpPr>
-            <a:spLocks noGrp="1"/>
-          </p:cNvSpPr>
-          <p:nvPr>
-            <p:ph type="sldNum" sz="quarter" idx="10"/>
-          </p:nvPr>
-        </p:nvSpPr>
-        <p:spPr/>
-        <p:txBody>
-          <a:bodyPr/>
-          <a:lstStyle/>
-          <a:p>
-            <a:fld id="{F7021451-1387-4CA6-816F-3879F97B5CBC}" type="slidenum">
-              <a:rPr lang="en-US"/>
-              <a:t>11</a:t>
-            </a:fld>
-            <a:endParaRPr lang="en-US"/>
-          </a:p>
-        </p:txBody>
-      </p:sp>
-    </p:spTree>
-    <p:extLst>
-      <p:ext uri="{BB962C8B-B14F-4D97-AF65-F5344CB8AC3E}">
-        <p14:creationId xmlns:p14="http://schemas.microsoft.com/office/powerpoint/2010/main" val="1024086991"/>
-      </p:ext>
-    </p:extLst>
-  </p:cSld>
-  <p:clrMapOvr>
-    <a:masterClrMapping/>
-  </p:clrMapOvr>
-</p:notes>
-</file>
-
-<file path=ppt/notesSlides/notesSlide12.xml><?xml version="1.0" encoding="utf-8"?>
-<p:notes xmlns:a="http://schemas.openxmlformats.org/drawingml/2006/main" xmlns:r="http://schemas.openxmlformats.org/officeDocument/2006/relationships" xmlns:p="http://schemas.openxmlformats.org/presentationml/2006/main">
-  <p:cSld>
-    <p:spTree>
-      <p:nvGrpSpPr>
-        <p:cNvPr id="1" name=""/>
-        <p:cNvGrpSpPr/>
-        <p:nvPr/>
-      </p:nvGrpSpPr>
-      <p:grpSpPr>
-        <a:xfrm>
-          <a:off x="0" y="0"/>
-          <a:ext cx="0" cy="0"/>
-          <a:chOff x="0" y="0"/>
-          <a:chExt cx="0" cy="0"/>
-        </a:xfrm>
-      </p:grpSpPr>
-      <p:sp>
-        <p:nvSpPr>
-          <p:cNvPr id="2" name="Slide Image Placeholder 1"/>
-          <p:cNvSpPr>
-            <a:spLocks noGrp="1" noRot="1" noChangeAspect="1"/>
-          </p:cNvSpPr>
-          <p:nvPr>
-            <p:ph type="sldImg"/>
-          </p:nvPr>
-        </p:nvSpPr>
-        <p:spPr/>
-      </p:sp>
-      <p:sp>
-        <p:nvSpPr>
-          <p:cNvPr id="3" name="Notes Placeholder 2"/>
-          <p:cNvSpPr>
-            <a:spLocks noGrp="1"/>
-          </p:cNvSpPr>
-          <p:nvPr>
-            <p:ph type="body" idx="1"/>
-          </p:nvPr>
-        </p:nvSpPr>
-        <p:spPr/>
-        <p:txBody>
-          <a:bodyPr/>
-          <a:lstStyle/>
-          <a:p>
-            <a:r>
-              <a:rPr lang="en-US" dirty="0"/>
-              <a:t>Because the laptop does the computing, the robot costs about twenty-one thousand rupees. The LiDAR is the biggest single part. A depth camera is an optional upgrade. It runs about two hours per charge, and the software already sends it back to the dock when the battery is low.</a:t>
-            </a:r>
-            <a:endParaRPr lang="en-US" dirty="0"/>
-          </a:p>
-        </p:txBody>
-      </p:sp>
-      <p:sp>
-        <p:nvSpPr>
-          <p:cNvPr id="4" name="Slide Number Placeholder 3"/>
-          <p:cNvSpPr>
-            <a:spLocks noGrp="1"/>
-          </p:cNvSpPr>
-          <p:nvPr>
-            <p:ph type="sldNum" sz="quarter" idx="10"/>
-          </p:nvPr>
-        </p:nvSpPr>
-        <p:spPr/>
-        <p:txBody>
-          <a:bodyPr/>
-          <a:lstStyle/>
-          <a:p>
-            <a:fld id="{F7021451-1387-4CA6-816F-3879F97B5CBC}" type="slidenum">
-              <a:rPr lang="en-US"/>
-              <a:t>12</a:t>
-            </a:fld>
-            <a:endParaRPr lang="en-US"/>
-          </a:p>
-        </p:txBody>
-      </p:sp>
-    </p:spTree>
-    <p:extLst>
-      <p:ext uri="{BB962C8B-B14F-4D97-AF65-F5344CB8AC3E}">
-        <p14:creationId xmlns:p14="http://schemas.microsoft.com/office/powerpoint/2010/main" val="1024086991"/>
-      </p:ext>
-    </p:extLst>
-  </p:cSld>
-  <p:clrMapOvr>
-    <a:masterClrMapping/>
-  </p:clrMapOvr>
-</p:notes>
-</file>
-
-<file path=ppt/notesSlides/notesSlide13.xml><?xml version="1.0" encoding="utf-8"?>
-<p:notes xmlns:a="http://schemas.openxmlformats.org/drawingml/2006/main" xmlns:r="http://schemas.openxmlformats.org/officeDocument/2006/relationships" xmlns:p="http://schemas.openxmlformats.org/presentationml/2006/main">
-  <p:cSld>
-    <p:spTree>
-      <p:nvGrpSpPr>
-        <p:cNvPr id="1" name=""/>
-        <p:cNvGrpSpPr/>
-        <p:nvPr/>
-      </p:nvGrpSpPr>
-      <p:grpSpPr>
-        <a:xfrm>
-          <a:off x="0" y="0"/>
-          <a:ext cx="0" cy="0"/>
-          <a:chOff x="0" y="0"/>
-          <a:chExt cx="0" cy="0"/>
-        </a:xfrm>
-      </p:grpSpPr>
-      <p:sp>
-        <p:nvSpPr>
-          <p:cNvPr id="2" name="Slide Image Placeholder 1"/>
-          <p:cNvSpPr>
-            <a:spLocks noGrp="1" noRot="1" noChangeAspect="1"/>
-          </p:cNvSpPr>
-          <p:nvPr>
-            <p:ph type="sldImg"/>
-          </p:nvPr>
-        </p:nvSpPr>
-        <p:spPr/>
-      </p:sp>
-      <p:sp>
-        <p:nvSpPr>
-          <p:cNvPr id="3" name="Notes Placeholder 2"/>
-          <p:cNvSpPr>
-            <a:spLocks noGrp="1"/>
-          </p:cNvSpPr>
-          <p:nvPr>
-            <p:ph type="body" idx="1"/>
-          </p:nvPr>
-        </p:nvSpPr>
-        <p:spPr/>
-        <p:txBody>
-          <a:bodyPr/>
-          <a:lstStyle/>
-          <a:p>
-            <a:r>
-              <a:rPr lang="en-US" dirty="0"/>
-              <a:t>Getting to a real robot takes about ten weeks. Week one is already de-risked because the same Arduino firmware runs in Wokwi today. The navigation code does not change, only the sensor source and the motor output.</a:t>
-            </a:r>
-            <a:endParaRPr lang="en-US" dirty="0"/>
-          </a:p>
-        </p:txBody>
-      </p:sp>
-      <p:sp>
-        <p:nvSpPr>
-          <p:cNvPr id="4" name="Slide Number Placeholder 3"/>
-          <p:cNvSpPr>
-            <a:spLocks noGrp="1"/>
-          </p:cNvSpPr>
-          <p:nvPr>
-            <p:ph type="sldNum" sz="quarter" idx="10"/>
-          </p:nvPr>
-        </p:nvSpPr>
-        <p:spPr/>
-        <p:txBody>
-          <a:bodyPr/>
-          <a:lstStyle/>
-          <a:p>
-            <a:fld id="{F7021451-1387-4CA6-816F-3879F97B5CBC}" type="slidenum">
-              <a:rPr lang="en-US"/>
-              <a:t>13</a:t>
-            </a:fld>
-            <a:endParaRPr lang="en-US"/>
-          </a:p>
-        </p:txBody>
-      </p:sp>
-    </p:spTree>
-    <p:extLst>
-      <p:ext uri="{BB962C8B-B14F-4D97-AF65-F5344CB8AC3E}">
-        <p14:creationId xmlns:p14="http://schemas.microsoft.com/office/powerpoint/2010/main" val="1024086991"/>
-      </p:ext>
-    </p:extLst>
-  </p:cSld>
-  <p:clrMapOvr>
-    <a:masterClrMapping/>
-  </p:clrMapOvr>
-</p:notes>
-</file>
-
-<file path=ppt/notesSlides/notesSlide14.xml><?xml version="1.0" encoding="utf-8"?>
-<p:notes xmlns:a="http://schemas.openxmlformats.org/drawingml/2006/main" xmlns:r="http://schemas.openxmlformats.org/officeDocument/2006/relationships" xmlns:p="http://schemas.openxmlformats.org/presentationml/2006/main">
-  <p:cSld>
-    <p:spTree>
-      <p:nvGrpSpPr>
-        <p:cNvPr id="1" name=""/>
-        <p:cNvGrpSpPr/>
-        <p:nvPr/>
-      </p:nvGrpSpPr>
-      <p:grpSpPr>
-        <a:xfrm>
-          <a:off x="0" y="0"/>
-          <a:ext cx="0" cy="0"/>
-          <a:chOff x="0" y="0"/>
-          <a:chExt cx="0" cy="0"/>
-        </a:xfrm>
-      </p:grpSpPr>
-      <p:sp>
-        <p:nvSpPr>
-          <p:cNvPr id="2" name="Slide Image Placeholder 1"/>
-          <p:cNvSpPr>
-            <a:spLocks noGrp="1" noRot="1" noChangeAspect="1"/>
-          </p:cNvSpPr>
-          <p:nvPr>
-            <p:ph type="sldImg"/>
-          </p:nvPr>
-        </p:nvSpPr>
-        <p:spPr/>
-      </p:sp>
-      <p:sp>
-        <p:nvSpPr>
-          <p:cNvPr id="3" name="Notes Placeholder 2"/>
-          <p:cNvSpPr>
-            <a:spLocks noGrp="1"/>
-          </p:cNvSpPr>
-          <p:nvPr>
-            <p:ph type="body" idx="1"/>
-          </p:nvPr>
-        </p:nvSpPr>
-        <p:spPr/>
-        <p:txBody>
-          <a:bodyPr/>
-          <a:lstStyle/>
-          <a:p>
-            <a:r>
-              <a:rPr lang="en-US" dirty="0"/>
-              <a:t>Thank you. Everything is on GitHub: the code, the evaluation, the hardware design and the Wokwi simulation. The QR code opens the repository.</a:t>
-            </a:r>
-            <a:endParaRPr lang="en-US" dirty="0"/>
-          </a:p>
-        </p:txBody>
-      </p:sp>
-      <p:sp>
-        <p:nvSpPr>
-          <p:cNvPr id="4" name="Slide Number Placeholder 3"/>
-          <p:cNvSpPr>
-            <a:spLocks noGrp="1"/>
-          </p:cNvSpPr>
-          <p:nvPr>
-            <p:ph type="sldNum" sz="quarter" idx="10"/>
-          </p:nvPr>
-        </p:nvSpPr>
-        <p:spPr/>
-        <p:txBody>
-          <a:bodyPr/>
-          <a:lstStyle/>
-          <a:p>
-            <a:fld id="{F7021451-1387-4CA6-816F-3879F97B5CBC}" type="slidenum">
-              <a:rPr lang="en-US"/>
-              <a:t>14</a:t>
             </a:fld>
             <a:endParaRPr lang="en-US"/>
           </a:p>
@@ -2171,7 +1407,7 @@
           <a:p>
             <a:r>
               <a:rPr lang="en-US" dirty="0"/>
-              <a:t>This is our judge demo running in the browser. A person crosses without giving way and a cart turns. Each step on the right is ticked only from real telemetry: the pedestrian is tracked, its path predicted, the robot slows to fifty percent, re-routes and reaches the goal with zero collisions.</a:t>
+              <a:t>Our evaluation script runs the same nine crossing variants with prediction on and off. Predictive: nine of nine goals, zero collisions, zero near misses. Reactive: two collisions and three near misses. The cost is about one and a half seconds per mission. These are simulation results.</a:t>
             </a:r>
             <a:endParaRPr lang="en-US" dirty="0"/>
           </a:p>
@@ -2259,7 +1495,7 @@
           <a:p>
             <a:r>
               <a:rPr lang="en-US" dirty="0"/>
-              <a:t>Our evaluation script runs the same nine crossing variants with prediction on and off. Predictive: nine of nine goals, zero collisions, zero near misses. Reactive: two collisions and three near misses. The cost is about one and a half seconds per mission. These are simulation results.</a:t>
+              <a:t>The electronics on the left are exactly the parts in our Wokwi simulation: an Arduino Mega, six ultrasonic sensors, an IMU, the emergency stop, a buzzer and the battery sense. The laptop we already own runs the backend. The rest is off the shelf: a 360-degree LiDAR, a webcam, two encoder gearmotors with a driver, a battery and the chassis, about twenty-one thousand rupees in total. It runs about two hours per charge, limited by the laptop battery.</a:t>
             </a:r>
             <a:endParaRPr lang="en-US" dirty="0"/>
           </a:p>
@@ -2347,7 +1583,7 @@
           <a:p>
             <a:r>
               <a:rPr lang="en-US" dirty="0"/>
-              <a:t>The electronics on the left are exactly the parts in our Wokwi simulation: an Arduino Mega, six ultrasonic sensors, an IMU, the emergency stop, a buzzer and the battery sense. The laptop we already own runs the backend. The rest is off the shelf: a 360-degree LiDAR, a webcam, two encoder gearmotors with a driver, a battery and the chassis, about twenty-one thousand rupees in total.</a:t>
+              <a:t>Read it left to right. Sense: ultrasonic sensors, encoders, IMU, E-stop and battery level go into the Arduino. Think: the laptop sends a speed command and the Arduino checks four safety rules every twenty milliseconds. Act: it drives the motors, the buzzer and the status LED. The power path is separate, so the E-stop cuts only the wheels.</a:t>
             </a:r>
             <a:endParaRPr lang="en-US" dirty="0"/>
           </a:p>
@@ -2435,7 +1671,7 @@
           <a:p>
             <a:r>
               <a:rPr lang="en-US" dirty="0"/>
-              <a:t>Read it left to right. Sense: ultrasonic sensors, encoders, IMU, E-stop and battery level go into the Arduino. Think: the laptop sends a speed command and the Arduino checks four safety rules every twenty milliseconds. Act: it drives the motors, the buzzer and the status LED. The power path is separate, so the E-stop cuts only the wheels.</a:t>
+              <a:t>The firmware runs in Wokwi with the same pin map as the real robot. When you press Start, an automatic tour shows every safety rule in about 46 seconds and explains each step in the serial monitor. The robot's front points right, and each ultrasonic sensor sits on the side it faces. The motor LEDs show the PWM; moving a sensor's distance slows or stops the robot, the E-stop cuts everything at once and stays latched, and the battery knob triggers the low-battery rules.</a:t>
             </a:r>
             <a:endParaRPr lang="en-US" dirty="0"/>
           </a:p>
@@ -3371,1405 +2607,6 @@
                   <a:schemeClr val="tx1"/>
                 </a:solidFill>
               </a:rPr>
-              <a:t>Pin wiring</a:t>
-            </a:r>
-            <a:endParaRPr lang="en-US" sz="2600" dirty="0"/>
-          </a:p>
-        </p:txBody>
-      </p:sp>
-      <p:pic>
-        <p:nvPicPr>
-          <p:cNvPr id="3" name="Circuit diagram" descr="Arduino Mega pin map: motor driver D5-D8, encoders D2/D24 and D3/D25, ultrasonic D30-D41, IMU D20/D21, battery A0, E-stop D26, buzzer D28, LED D13">    </p:cNvPr>
-          <p:cNvPicPr>
-            <a:picLocks noChangeAspect="1"/>
-          </p:cNvPicPr>
-          <p:nvPr/>
-        </p:nvPicPr>
-        <p:blipFill>
-          <a:blip r:embed="rId1"/>
-          <a:stretch>
-            <a:fillRect/>
-          </a:stretch>
-        </p:blipFill>
-        <p:spPr>
-          <a:xfrm>
-            <a:off x="841248" y="960120"/>
-            <a:ext cx="7461504" cy="3566160"/>
-          </a:xfrm>
-          <a:prstGeom prst="rect">
-            <a:avLst/>
-          </a:prstGeom>
-        </p:spPr>
-      </p:pic>
-      <p:sp>
-        <p:nvSpPr>
-          <p:cNvPr id="25" name="Slide Number Placeholder 0"/>
-          <p:cNvSpPr>
-            <a:spLocks noGrp="1"/>
-          </p:cNvSpPr>
-          <p:nvPr>
-            <p:ph type="sldNum" sz="quarter" idx="4294967295"/>
-          </p:nvPr>
-        </p:nvSpPr>
-        <p:spPr>
-          <a:xfrm>
-            <a:off x="8229600" y="4800600"/>
-            <a:ext cx="457200" cy="228600"/>
-          </a:xfrm>
-          <a:prstGeom prst="rect">
-            <a:avLst/>
-          </a:prstGeom>
-          <a:extLst>
-            <a:ext uri="{C572A759-6A51-4108-AA02-DFA0A04FC94B}">
-              <ma14:wrappingTextBoxFlag xmlns:ma14="http://schemas.microsoft.com/office/mac/drawingml/2011/main" val="0"/>
-            </a:ext>
-          </a:extLst>
-        </p:spPr>
-        <p:txBody>
-          <a:bodyPr/>
-          <a:lstStyle>
-            <a:lvl1pPr>
-              <a:defRPr sz="900">
-                <a:solidFill>
-                  <a:schemeClr val="accent5"/>
-                </a:solidFill>
-              </a:defRPr>
-            </a:lvl1pPr>
-          </a:lstStyle>
-          <a:p>
-            <a:pPr algn="r"/>
-            <a:fld id="{F7021451-1387-4CA6-816F-3879F97B5CBC}" type="slidenum">
-              <a:rPr b="0" lang="en-US"/>
-              <a:t>10</a:t>
-            </a:fld>
-            <a:endParaRPr lang="en-US"/>
-          </a:p>
-        </p:txBody>
-      </p:sp>
-    </p:spTree>
-  </p:cSld>
-  <p:clrMapOvr>
-    <a:masterClrMapping/>
-  </p:clrMapOvr>
-</p:sld>
-</file>
-
-<file path=ppt/slides/slide11.xml><?xml version="1.0" encoding="utf-8"?>
-<p:sld xmlns:a="http://schemas.openxmlformats.org/drawingml/2006/main" xmlns:r="http://schemas.openxmlformats.org/officeDocument/2006/relationships" xmlns:p="http://schemas.openxmlformats.org/presentationml/2006/main">
-  <p:cSld name="Slide 11">
-    <p:spTree>
-      <p:nvGrpSpPr>
-        <p:cNvPr id="1" name=""/>
-        <p:cNvGrpSpPr/>
-        <p:nvPr/>
-      </p:nvGrpSpPr>
-      <p:grpSpPr>
-        <a:xfrm>
-          <a:off x="0" y="0"/>
-          <a:ext cx="0" cy="0"/>
-          <a:chOff x="0" y="0"/>
-          <a:chExt cx="0" cy="0"/>
-        </a:xfrm>
-      </p:grpSpPr>
-      <p:sp>
-        <p:nvSpPr>
-          <p:cNvPr id="2" name="Text 0"/>
-          <p:cNvSpPr/>
-          <p:nvPr>
-            <p:ph idx="100" type="title" hasCustomPrompt="1"/>
-          </p:nvPr>
-        </p:nvSpPr>
-        <p:spPr>
-          <a:xfrm>
-            <a:off x="457200" y="274320"/>
-            <a:ext cx="8229600" cy="548640"/>
-          </a:xfrm>
-          <a:prstGeom prst="rect">
-            <a:avLst/>
-          </a:prstGeom>
-          <a:noFill/>
-          <a:ln/>
-        </p:spPr>
-        <p:txBody>
-          <a:bodyPr wrap="square" lIns="0" tIns="0" rIns="0" bIns="0" rtlCol="0" anchor="ctr"/>
-          <a:lstStyle/>
-          <a:p>
-            <a:pPr algn="l" indent="0" marL="0">
-              <a:buNone/>
-            </a:pPr>
-            <a:r>
-              <a:rPr lang="en-US" sz="2600" b="1" dirty="0">
-                <a:solidFill>
-                  <a:schemeClr val="tx1"/>
-                </a:solidFill>
-              </a:rPr>
-              <a:t>Simulated in Wokwi</a:t>
-            </a:r>
-            <a:endParaRPr lang="en-US" sz="2600" dirty="0"/>
-          </a:p>
-        </p:txBody>
-      </p:sp>
-      <p:pic>
-        <p:nvPicPr>
-          <p:cNvPr id="3" name="Wokwi screenshot" descr="Wokwi simulation: Arduino Mega with six HC-SR04 sensors placed around it as on the robot, IMU, E-stop, buzzer, battery knob, motor LEDs and a wire colour legend">    </p:cNvPr>
-          <p:cNvPicPr>
-            <a:picLocks noChangeAspect="1"/>
-          </p:cNvPicPr>
-          <p:nvPr/>
-        </p:nvPicPr>
-        <p:blipFill>
-          <a:blip r:embed="rId1"/>
-          <a:stretch>
-            <a:fillRect/>
-          </a:stretch>
-        </p:blipFill>
-        <p:spPr>
-          <a:xfrm>
-            <a:off x="457200" y="914400"/>
-            <a:ext cx="4535424" cy="3611880"/>
-          </a:xfrm>
-          <a:prstGeom prst="rect">
-            <a:avLst/>
-          </a:prstGeom>
-        </p:spPr>
-      </p:pic>
-      <p:sp>
-        <p:nvSpPr>
-          <p:cNvPr id="4" name="Screenshot frame"/>
-          <p:cNvSpPr/>
-          <p:nvPr/>
-        </p:nvSpPr>
-        <p:spPr>
-          <a:xfrm>
-            <a:off x="457200" y="914400"/>
-            <a:ext cx="4535424" cy="3611880"/>
-          </a:xfrm>
-          <a:prstGeom prst="rect">
-            <a:avLst/>
-          </a:prstGeom>
-          <a:ln w="12700">
-            <a:solidFill>
-              <a:srgbClr val="DFE4E9"/>
-            </a:solidFill>
-            <a:prstDash val="solid"/>
-          </a:ln>
-        </p:spPr>
-      </p:sp>
-      <p:sp>
-        <p:nvSpPr>
-          <p:cNvPr id="5" name="Text 2"/>
-          <p:cNvSpPr txBox="1"/>
-          <p:nvPr/>
-        </p:nvSpPr>
-        <p:spPr>
-          <a:xfrm>
-            <a:off x="5303520" y="914400"/>
-            <a:ext cx="3383280" cy="320040"/>
-          </a:xfrm>
-          <a:prstGeom prst="rect">
-            <a:avLst/>
-          </a:prstGeom>
-          <a:noFill/>
-          <a:ln/>
-        </p:spPr>
-        <p:txBody>
-          <a:bodyPr wrap="square" lIns="0" tIns="0" rIns="0" bIns="0" rtlCol="0" anchor="t"/>
-          <a:lstStyle/>
-          <a:p>
-            <a:pPr indent="0" marL="0">
-              <a:buNone/>
-            </a:pPr>
-            <a:r>
-              <a:rPr lang="en-US" sz="1500" b="1" dirty="0">
-                <a:solidFill>
-                  <a:schemeClr val="tx1"/>
-                </a:solidFill>
-              </a:rPr>
-              <a:t>Press Start: a 46 s tour runs itself</a:t>
-            </a:r>
-            <a:endParaRPr lang="en-US" sz="1500" dirty="0"/>
-          </a:p>
-        </p:txBody>
-      </p:sp>
-      <p:sp>
-        <p:nvSpPr>
-          <p:cNvPr id="6" name="Marker 1"/>
-          <p:cNvSpPr/>
-          <p:nvPr/>
-        </p:nvSpPr>
-        <p:spPr>
-          <a:xfrm>
-            <a:off x="5303520" y="1399032"/>
-            <a:ext cx="274320" cy="274320"/>
-          </a:xfrm>
-          <a:prstGeom prst="ellipse">
-            <a:avLst/>
-          </a:prstGeom>
-          <a:solidFill>
-            <a:srgbClr val="D9A441"/>
-          </a:solidFill>
-          <a:ln w="19050">
-            <a:solidFill>
-              <a:srgbClr val="FFFFFF"/>
-            </a:solidFill>
-            <a:prstDash val="solid"/>
-          </a:ln>
-        </p:spPr>
-      </p:sp>
-      <p:sp>
-        <p:nvSpPr>
-          <p:cNvPr id="7" name="Text 4"/>
-          <p:cNvSpPr txBox="1"/>
-          <p:nvPr/>
-        </p:nvSpPr>
-        <p:spPr>
-          <a:xfrm>
-            <a:off x="5303520" y="1399032"/>
-            <a:ext cx="274320" cy="274320"/>
-          </a:xfrm>
-          <a:prstGeom prst="rect">
-            <a:avLst/>
-          </a:prstGeom>
-          <a:noFill/>
-          <a:ln/>
-        </p:spPr>
-        <p:txBody>
-          <a:bodyPr wrap="square" lIns="0" tIns="0" rIns="0" bIns="0" rtlCol="0" anchor="ctr"/>
-          <a:lstStyle/>
-          <a:p>
-            <a:pPr algn="ctr" indent="0" marL="0">
-              <a:buNone/>
-            </a:pPr>
-            <a:r>
-              <a:rPr lang="en-US" sz="1100" b="1" dirty="0">
-                <a:solidFill>
-                  <a:schemeClr val="tx1"/>
-                </a:solidFill>
-              </a:rPr>
-              <a:t>1</a:t>
-            </a:r>
-            <a:endParaRPr lang="en-US" sz="1100" dirty="0"/>
-          </a:p>
-        </p:txBody>
-      </p:sp>
-      <p:sp>
-        <p:nvSpPr>
-          <p:cNvPr id="8" name="Text 5"/>
-          <p:cNvSpPr txBox="1"/>
-          <p:nvPr/>
-        </p:nvSpPr>
-        <p:spPr>
-          <a:xfrm>
-            <a:off x="5715000" y="1371600"/>
-            <a:ext cx="2971800" cy="237744"/>
-          </a:xfrm>
-          <a:prstGeom prst="rect">
-            <a:avLst/>
-          </a:prstGeom>
-          <a:noFill/>
-          <a:ln/>
-        </p:spPr>
-        <p:txBody>
-          <a:bodyPr wrap="square" lIns="0" tIns="0" rIns="0" bIns="0" rtlCol="0" anchor="t"/>
-          <a:lstStyle/>
-          <a:p>
-            <a:pPr indent="0" marL="0">
-              <a:buNone/>
-            </a:pPr>
-            <a:r>
-              <a:rPr lang="en-US" sz="1300" b="1" dirty="0">
-                <a:solidFill>
-                  <a:schemeClr val="tx1"/>
-                </a:solidFill>
-              </a:rPr>
-              <a:t>Drive forward</a:t>
-            </a:r>
-            <a:endParaRPr lang="en-US" sz="1300" dirty="0"/>
-          </a:p>
-        </p:txBody>
-      </p:sp>
-      <p:sp>
-        <p:nvSpPr>
-          <p:cNvPr id="9" name="Text 6"/>
-          <p:cNvSpPr txBox="1"/>
-          <p:nvPr/>
-        </p:nvSpPr>
-        <p:spPr>
-          <a:xfrm>
-            <a:off x="5715000" y="1618488"/>
-            <a:ext cx="2971800" cy="237744"/>
-          </a:xfrm>
-          <a:prstGeom prst="rect">
-            <a:avLst/>
-          </a:prstGeom>
-          <a:noFill/>
-          <a:ln/>
-        </p:spPr>
-        <p:txBody>
-          <a:bodyPr wrap="square" lIns="0" tIns="0" rIns="0" bIns="0" rtlCol="0" anchor="t"/>
-          <a:lstStyle/>
-          <a:p>
-            <a:pPr indent="0" marL="0">
-              <a:buNone/>
-            </a:pPr>
-            <a:r>
-              <a:rPr lang="en-US" sz="1200" dirty="0">
-                <a:solidFill>
-                  <a:schemeClr val="accent5"/>
-                </a:solidFill>
-              </a:rPr>
-              <a:t>green motor LEDs light up</a:t>
-            </a:r>
-            <a:endParaRPr lang="en-US" sz="1200" dirty="0"/>
-          </a:p>
-        </p:txBody>
-      </p:sp>
-      <p:sp>
-        <p:nvSpPr>
-          <p:cNvPr id="10" name="Marker 2"/>
-          <p:cNvSpPr/>
-          <p:nvPr/>
-        </p:nvSpPr>
-        <p:spPr>
-          <a:xfrm>
-            <a:off x="5303520" y="1947672"/>
-            <a:ext cx="274320" cy="274320"/>
-          </a:xfrm>
-          <a:prstGeom prst="ellipse">
-            <a:avLst/>
-          </a:prstGeom>
-          <a:solidFill>
-            <a:srgbClr val="D9A441"/>
-          </a:solidFill>
-          <a:ln w="19050">
-            <a:solidFill>
-              <a:srgbClr val="FFFFFF"/>
-            </a:solidFill>
-            <a:prstDash val="solid"/>
-          </a:ln>
-        </p:spPr>
-      </p:sp>
-      <p:sp>
-        <p:nvSpPr>
-          <p:cNvPr id="11" name="Text 8"/>
-          <p:cNvSpPr txBox="1"/>
-          <p:nvPr/>
-        </p:nvSpPr>
-        <p:spPr>
-          <a:xfrm>
-            <a:off x="5303520" y="1947672"/>
-            <a:ext cx="274320" cy="274320"/>
-          </a:xfrm>
-          <a:prstGeom prst="rect">
-            <a:avLst/>
-          </a:prstGeom>
-          <a:noFill/>
-          <a:ln/>
-        </p:spPr>
-        <p:txBody>
-          <a:bodyPr wrap="square" lIns="0" tIns="0" rIns="0" bIns="0" rtlCol="0" anchor="ctr"/>
-          <a:lstStyle/>
-          <a:p>
-            <a:pPr algn="ctr" indent="0" marL="0">
-              <a:buNone/>
-            </a:pPr>
-            <a:r>
-              <a:rPr lang="en-US" sz="1100" b="1" dirty="0">
-                <a:solidFill>
-                  <a:schemeClr val="tx1"/>
-                </a:solidFill>
-              </a:rPr>
-              <a:t>2</a:t>
-            </a:r>
-            <a:endParaRPr lang="en-US" sz="1100" dirty="0"/>
-          </a:p>
-        </p:txBody>
-      </p:sp>
-      <p:sp>
-        <p:nvSpPr>
-          <p:cNvPr id="12" name="Text 9"/>
-          <p:cNvSpPr txBox="1"/>
-          <p:nvPr/>
-        </p:nvSpPr>
-        <p:spPr>
-          <a:xfrm>
-            <a:off x="5715000" y="1920240"/>
-            <a:ext cx="2971800" cy="237744"/>
-          </a:xfrm>
-          <a:prstGeom prst="rect">
-            <a:avLst/>
-          </a:prstGeom>
-          <a:noFill/>
-          <a:ln/>
-        </p:spPr>
-        <p:txBody>
-          <a:bodyPr wrap="square" lIns="0" tIns="0" rIns="0" bIns="0" rtlCol="0" anchor="t"/>
-          <a:lstStyle/>
-          <a:p>
-            <a:pPr indent="0" marL="0">
-              <a:buNone/>
-            </a:pPr>
-            <a:r>
-              <a:rPr lang="en-US" sz="1300" b="1" dirty="0">
-                <a:solidFill>
-                  <a:schemeClr val="tx1"/>
-                </a:solidFill>
-              </a:rPr>
-              <a:t>A person walks in front</a:t>
-            </a:r>
-            <a:endParaRPr lang="en-US" sz="1300" dirty="0"/>
-          </a:p>
-        </p:txBody>
-      </p:sp>
-      <p:sp>
-        <p:nvSpPr>
-          <p:cNvPr id="13" name="Text 10"/>
-          <p:cNvSpPr txBox="1"/>
-          <p:nvPr/>
-        </p:nvSpPr>
-        <p:spPr>
-          <a:xfrm>
-            <a:off x="5715000" y="2167128"/>
-            <a:ext cx="2971800" cy="237744"/>
-          </a:xfrm>
-          <a:prstGeom prst="rect">
-            <a:avLst/>
-          </a:prstGeom>
-          <a:noFill/>
-          <a:ln/>
-        </p:spPr>
-        <p:txBody>
-          <a:bodyPr wrap="square" lIns="0" tIns="0" rIns="0" bIns="0" rtlCol="0" anchor="t"/>
-          <a:lstStyle/>
-          <a:p>
-            <a:pPr indent="0" marL="0">
-              <a:buNone/>
-            </a:pPr>
-            <a:r>
-              <a:rPr lang="en-US" sz="1200" dirty="0">
-                <a:solidFill>
-                  <a:schemeClr val="accent5"/>
-                </a:solidFill>
-              </a:rPr>
-              <a:t>slows at 0.9 m, stops at 0.3 m</a:t>
-            </a:r>
-            <a:endParaRPr lang="en-US" sz="1200" dirty="0"/>
-          </a:p>
-        </p:txBody>
-      </p:sp>
-      <p:sp>
-        <p:nvSpPr>
-          <p:cNvPr id="14" name="Marker 3"/>
-          <p:cNvSpPr/>
-          <p:nvPr/>
-        </p:nvSpPr>
-        <p:spPr>
-          <a:xfrm>
-            <a:off x="5303520" y="2496312"/>
-            <a:ext cx="274320" cy="274320"/>
-          </a:xfrm>
-          <a:prstGeom prst="ellipse">
-            <a:avLst/>
-          </a:prstGeom>
-          <a:solidFill>
-            <a:srgbClr val="D9A441"/>
-          </a:solidFill>
-          <a:ln w="19050">
-            <a:solidFill>
-              <a:srgbClr val="FFFFFF"/>
-            </a:solidFill>
-            <a:prstDash val="solid"/>
-          </a:ln>
-        </p:spPr>
-      </p:sp>
-      <p:sp>
-        <p:nvSpPr>
-          <p:cNvPr id="15" name="Text 12"/>
-          <p:cNvSpPr txBox="1"/>
-          <p:nvPr/>
-        </p:nvSpPr>
-        <p:spPr>
-          <a:xfrm>
-            <a:off x="5303520" y="2496312"/>
-            <a:ext cx="274320" cy="274320"/>
-          </a:xfrm>
-          <a:prstGeom prst="rect">
-            <a:avLst/>
-          </a:prstGeom>
-          <a:noFill/>
-          <a:ln/>
-        </p:spPr>
-        <p:txBody>
-          <a:bodyPr wrap="square" lIns="0" tIns="0" rIns="0" bIns="0" rtlCol="0" anchor="ctr"/>
-          <a:lstStyle/>
-          <a:p>
-            <a:pPr algn="ctr" indent="0" marL="0">
-              <a:buNone/>
-            </a:pPr>
-            <a:r>
-              <a:rPr lang="en-US" sz="1100" b="1" dirty="0">
-                <a:solidFill>
-                  <a:schemeClr val="tx1"/>
-                </a:solidFill>
-              </a:rPr>
-              <a:t>3</a:t>
-            </a:r>
-            <a:endParaRPr lang="en-US" sz="1100" dirty="0"/>
-          </a:p>
-        </p:txBody>
-      </p:sp>
-      <p:sp>
-        <p:nvSpPr>
-          <p:cNvPr id="16" name="Text 13"/>
-          <p:cNvSpPr txBox="1"/>
-          <p:nvPr/>
-        </p:nvSpPr>
-        <p:spPr>
-          <a:xfrm>
-            <a:off x="5715000" y="2468880"/>
-            <a:ext cx="2971800" cy="237744"/>
-          </a:xfrm>
-          <a:prstGeom prst="rect">
-            <a:avLst/>
-          </a:prstGeom>
-          <a:noFill/>
-          <a:ln/>
-        </p:spPr>
-        <p:txBody>
-          <a:bodyPr wrap="square" lIns="0" tIns="0" rIns="0" bIns="0" rtlCol="0" anchor="t"/>
-          <a:lstStyle/>
-          <a:p>
-            <a:pPr indent="0" marL="0">
-              <a:buNone/>
-            </a:pPr>
-            <a:r>
-              <a:rPr lang="en-US" sz="1300" b="1" dirty="0">
-                <a:solidFill>
-                  <a:schemeClr val="tx1"/>
-                </a:solidFill>
-              </a:rPr>
-              <a:t>Laptop freezes</a:t>
-            </a:r>
-            <a:endParaRPr lang="en-US" sz="1300" dirty="0"/>
-          </a:p>
-        </p:txBody>
-      </p:sp>
-      <p:sp>
-        <p:nvSpPr>
-          <p:cNvPr id="17" name="Text 14"/>
-          <p:cNvSpPr txBox="1"/>
-          <p:nvPr/>
-        </p:nvSpPr>
-        <p:spPr>
-          <a:xfrm>
-            <a:off x="5715000" y="2715768"/>
-            <a:ext cx="2971800" cy="237744"/>
-          </a:xfrm>
-          <a:prstGeom prst="rect">
-            <a:avLst/>
-          </a:prstGeom>
-          <a:noFill/>
-          <a:ln/>
-        </p:spPr>
-        <p:txBody>
-          <a:bodyPr wrap="square" lIns="0" tIns="0" rIns="0" bIns="0" rtlCol="0" anchor="t"/>
-          <a:lstStyle/>
-          <a:p>
-            <a:pPr indent="0" marL="0">
-              <a:buNone/>
-            </a:pPr>
-            <a:r>
-              <a:rPr lang="en-US" sz="1200" dirty="0">
-                <a:solidFill>
-                  <a:schemeClr val="accent5"/>
-                </a:solidFill>
-              </a:rPr>
-              <a:t>watchdog stops it in 0.5 s</a:t>
-            </a:r>
-            <a:endParaRPr lang="en-US" sz="1200" dirty="0"/>
-          </a:p>
-        </p:txBody>
-      </p:sp>
-      <p:sp>
-        <p:nvSpPr>
-          <p:cNvPr id="18" name="Marker 4"/>
-          <p:cNvSpPr/>
-          <p:nvPr/>
-        </p:nvSpPr>
-        <p:spPr>
-          <a:xfrm>
-            <a:off x="5303520" y="3044952"/>
-            <a:ext cx="274320" cy="274320"/>
-          </a:xfrm>
-          <a:prstGeom prst="ellipse">
-            <a:avLst/>
-          </a:prstGeom>
-          <a:solidFill>
-            <a:srgbClr val="D9A441"/>
-          </a:solidFill>
-          <a:ln w="19050">
-            <a:solidFill>
-              <a:srgbClr val="FFFFFF"/>
-            </a:solidFill>
-            <a:prstDash val="solid"/>
-          </a:ln>
-        </p:spPr>
-      </p:sp>
-      <p:sp>
-        <p:nvSpPr>
-          <p:cNvPr id="19" name="Text 16"/>
-          <p:cNvSpPr txBox="1"/>
-          <p:nvPr/>
-        </p:nvSpPr>
-        <p:spPr>
-          <a:xfrm>
-            <a:off x="5303520" y="3044952"/>
-            <a:ext cx="274320" cy="274320"/>
-          </a:xfrm>
-          <a:prstGeom prst="rect">
-            <a:avLst/>
-          </a:prstGeom>
-          <a:noFill/>
-          <a:ln/>
-        </p:spPr>
-        <p:txBody>
-          <a:bodyPr wrap="square" lIns="0" tIns="0" rIns="0" bIns="0" rtlCol="0" anchor="ctr"/>
-          <a:lstStyle/>
-          <a:p>
-            <a:pPr algn="ctr" indent="0" marL="0">
-              <a:buNone/>
-            </a:pPr>
-            <a:r>
-              <a:rPr lang="en-US" sz="1100" b="1" dirty="0">
-                <a:solidFill>
-                  <a:schemeClr val="tx1"/>
-                </a:solidFill>
-              </a:rPr>
-              <a:t>4</a:t>
-            </a:r>
-            <a:endParaRPr lang="en-US" sz="1100" dirty="0"/>
-          </a:p>
-        </p:txBody>
-      </p:sp>
-      <p:sp>
-        <p:nvSpPr>
-          <p:cNvPr id="20" name="Text 17"/>
-          <p:cNvSpPr txBox="1"/>
-          <p:nvPr/>
-        </p:nvSpPr>
-        <p:spPr>
-          <a:xfrm>
-            <a:off x="5715000" y="3017520"/>
-            <a:ext cx="2971800" cy="237744"/>
-          </a:xfrm>
-          <a:prstGeom prst="rect">
-            <a:avLst/>
-          </a:prstGeom>
-          <a:noFill/>
-          <a:ln/>
-        </p:spPr>
-        <p:txBody>
-          <a:bodyPr wrap="square" lIns="0" tIns="0" rIns="0" bIns="0" rtlCol="0" anchor="t"/>
-          <a:lstStyle/>
-          <a:p>
-            <a:pPr indent="0" marL="0">
-              <a:buNone/>
-            </a:pPr>
-            <a:r>
-              <a:rPr lang="en-US" sz="1300" b="1" dirty="0">
-                <a:solidFill>
-                  <a:schemeClr val="tx1"/>
-                </a:solidFill>
-              </a:rPr>
-              <a:t>Battery low, then empty</a:t>
-            </a:r>
-            <a:endParaRPr lang="en-US" sz="1300" dirty="0"/>
-          </a:p>
-        </p:txBody>
-      </p:sp>
-      <p:sp>
-        <p:nvSpPr>
-          <p:cNvPr id="21" name="Text 18"/>
-          <p:cNvSpPr txBox="1"/>
-          <p:nvPr/>
-        </p:nvSpPr>
-        <p:spPr>
-          <a:xfrm>
-            <a:off x="5715000" y="3264408"/>
-            <a:ext cx="2971800" cy="237744"/>
-          </a:xfrm>
-          <a:prstGeom prst="rect">
-            <a:avLst/>
-          </a:prstGeom>
-          <a:noFill/>
-          <a:ln/>
-        </p:spPr>
-        <p:txBody>
-          <a:bodyPr wrap="square" lIns="0" tIns="0" rIns="0" bIns="0" rtlCol="0" anchor="t"/>
-          <a:lstStyle/>
-          <a:p>
-            <a:pPr indent="0" marL="0">
-              <a:buNone/>
-            </a:pPr>
-            <a:r>
-              <a:rPr lang="en-US" sz="1200" dirty="0">
-                <a:solidFill>
-                  <a:schemeClr val="accent5"/>
-                </a:solidFill>
-              </a:rPr>
-              <a:t>half speed, then motors off</a:t>
-            </a:r>
-            <a:endParaRPr lang="en-US" sz="1200" dirty="0"/>
-          </a:p>
-        </p:txBody>
-      </p:sp>
-      <p:sp>
-        <p:nvSpPr>
-          <p:cNvPr id="22" name="Marker 5"/>
-          <p:cNvSpPr/>
-          <p:nvPr/>
-        </p:nvSpPr>
-        <p:spPr>
-          <a:xfrm>
-            <a:off x="5303520" y="3593592"/>
-            <a:ext cx="274320" cy="274320"/>
-          </a:xfrm>
-          <a:prstGeom prst="ellipse">
-            <a:avLst/>
-          </a:prstGeom>
-          <a:solidFill>
-            <a:srgbClr val="D9A441"/>
-          </a:solidFill>
-          <a:ln w="19050">
-            <a:solidFill>
-              <a:srgbClr val="FFFFFF"/>
-            </a:solidFill>
-            <a:prstDash val="solid"/>
-          </a:ln>
-        </p:spPr>
-      </p:sp>
-      <p:sp>
-        <p:nvSpPr>
-          <p:cNvPr id="23" name="Text 20"/>
-          <p:cNvSpPr txBox="1"/>
-          <p:nvPr/>
-        </p:nvSpPr>
-        <p:spPr>
-          <a:xfrm>
-            <a:off x="5303520" y="3593592"/>
-            <a:ext cx="274320" cy="274320"/>
-          </a:xfrm>
-          <a:prstGeom prst="rect">
-            <a:avLst/>
-          </a:prstGeom>
-          <a:noFill/>
-          <a:ln/>
-        </p:spPr>
-        <p:txBody>
-          <a:bodyPr wrap="square" lIns="0" tIns="0" rIns="0" bIns="0" rtlCol="0" anchor="ctr"/>
-          <a:lstStyle/>
-          <a:p>
-            <a:pPr algn="ctr" indent="0" marL="0">
-              <a:buNone/>
-            </a:pPr>
-            <a:r>
-              <a:rPr lang="en-US" sz="1100" b="1" dirty="0">
-                <a:solidFill>
-                  <a:schemeClr val="tx1"/>
-                </a:solidFill>
-              </a:rPr>
-              <a:t>5</a:t>
-            </a:r>
-            <a:endParaRPr lang="en-US" sz="1100" dirty="0"/>
-          </a:p>
-        </p:txBody>
-      </p:sp>
-      <p:sp>
-        <p:nvSpPr>
-          <p:cNvPr id="24" name="Text 21"/>
-          <p:cNvSpPr txBox="1"/>
-          <p:nvPr/>
-        </p:nvSpPr>
-        <p:spPr>
-          <a:xfrm>
-            <a:off x="5715000" y="3566160"/>
-            <a:ext cx="2971800" cy="237744"/>
-          </a:xfrm>
-          <a:prstGeom prst="rect">
-            <a:avLst/>
-          </a:prstGeom>
-          <a:noFill/>
-          <a:ln/>
-        </p:spPr>
-        <p:txBody>
-          <a:bodyPr wrap="square" lIns="0" tIns="0" rIns="0" bIns="0" rtlCol="0" anchor="t"/>
-          <a:lstStyle/>
-          <a:p>
-            <a:pPr indent="0" marL="0">
-              <a:buNone/>
-            </a:pPr>
-            <a:r>
-              <a:rPr lang="en-US" sz="1300" b="1" dirty="0">
-                <a:solidFill>
-                  <a:schemeClr val="tx1"/>
-                </a:solidFill>
-              </a:rPr>
-              <a:t>E-STOP pressed</a:t>
-            </a:r>
-            <a:endParaRPr lang="en-US" sz="1300" dirty="0"/>
-          </a:p>
-        </p:txBody>
-      </p:sp>
-      <p:sp>
-        <p:nvSpPr>
-          <p:cNvPr id="25" name="Text 22"/>
-          <p:cNvSpPr txBox="1"/>
-          <p:nvPr/>
-        </p:nvSpPr>
-        <p:spPr>
-          <a:xfrm>
-            <a:off x="5715000" y="3813048"/>
-            <a:ext cx="2971800" cy="237744"/>
-          </a:xfrm>
-          <a:prstGeom prst="rect">
-            <a:avLst/>
-          </a:prstGeom>
-          <a:noFill/>
-          <a:ln/>
-        </p:spPr>
-        <p:txBody>
-          <a:bodyPr wrap="square" lIns="0" tIns="0" rIns="0" bIns="0" rtlCol="0" anchor="t"/>
-          <a:lstStyle/>
-          <a:p>
-            <a:pPr indent="0" marL="0">
-              <a:buNone/>
-            </a:pPr>
-            <a:r>
-              <a:rPr lang="en-US" sz="1200" dirty="0">
-                <a:solidFill>
-                  <a:schemeClr val="accent5"/>
-                </a:solidFill>
-              </a:rPr>
-              <a:t>instant stop until reset</a:t>
-            </a:r>
-            <a:endParaRPr lang="en-US" sz="1200" dirty="0"/>
-          </a:p>
-        </p:txBody>
-      </p:sp>
-      <p:sp>
-        <p:nvSpPr>
-          <p:cNvPr id="26" name="Text 23"/>
-          <p:cNvSpPr txBox="1"/>
-          <p:nvPr/>
-        </p:nvSpPr>
-        <p:spPr>
-          <a:xfrm>
-            <a:off x="5303520" y="4114800"/>
-            <a:ext cx="3383280" cy="411480"/>
-          </a:xfrm>
-          <a:prstGeom prst="rect">
-            <a:avLst/>
-          </a:prstGeom>
-          <a:noFill/>
-          <a:ln/>
-        </p:spPr>
-        <p:txBody>
-          <a:bodyPr wrap="square" lIns="0" tIns="0" rIns="0" bIns="0" rtlCol="0" anchor="t"/>
-          <a:lstStyle/>
-          <a:p>
-            <a:pPr indent="0" marL="0">
-              <a:buNone/>
-            </a:pPr>
-            <a:r>
-              <a:rPr lang="en-US" sz="1000" i="1" dirty="0">
-                <a:solidFill>
-                  <a:schemeClr val="accent5"/>
-                </a:solidFill>
-              </a:rPr>
-              <a:t>Each step is explained in the serial monitor. Sliders, knob and button also work by hand.</a:t>
-            </a:r>
-            <a:endParaRPr lang="en-US" sz="1000" dirty="0"/>
-          </a:p>
-        </p:txBody>
-      </p:sp>
-      <p:sp>
-        <p:nvSpPr>
-          <p:cNvPr id="25" name="Slide Number Placeholder 0"/>
-          <p:cNvSpPr>
-            <a:spLocks noGrp="1"/>
-          </p:cNvSpPr>
-          <p:nvPr>
-            <p:ph type="sldNum" sz="quarter" idx="4294967295"/>
-          </p:nvPr>
-        </p:nvSpPr>
-        <p:spPr>
-          <a:xfrm>
-            <a:off x="8229600" y="4800600"/>
-            <a:ext cx="457200" cy="228600"/>
-          </a:xfrm>
-          <a:prstGeom prst="rect">
-            <a:avLst/>
-          </a:prstGeom>
-          <a:extLst>
-            <a:ext uri="{C572A759-6A51-4108-AA02-DFA0A04FC94B}">
-              <ma14:wrappingTextBoxFlag xmlns:ma14="http://schemas.microsoft.com/office/mac/drawingml/2011/main" val="0"/>
-            </a:ext>
-          </a:extLst>
-        </p:spPr>
-        <p:txBody>
-          <a:bodyPr/>
-          <a:lstStyle>
-            <a:lvl1pPr>
-              <a:defRPr sz="900">
-                <a:solidFill>
-                  <a:schemeClr val="accent5"/>
-                </a:solidFill>
-              </a:defRPr>
-            </a:lvl1pPr>
-          </a:lstStyle>
-          <a:p>
-            <a:pPr algn="r"/>
-            <a:fld id="{F7021451-1387-4CA6-816F-3879F97B5CBC}" type="slidenum">
-              <a:rPr b="0" lang="en-US"/>
-              <a:t>11</a:t>
-            </a:fld>
-            <a:endParaRPr lang="en-US"/>
-          </a:p>
-        </p:txBody>
-      </p:sp>
-    </p:spTree>
-  </p:cSld>
-  <p:clrMapOvr>
-    <a:masterClrMapping/>
-  </p:clrMapOvr>
-</p:sld>
-</file>
-
-<file path=ppt/slides/slide12.xml><?xml version="1.0" encoding="utf-8"?>
-<p:sld xmlns:a="http://schemas.openxmlformats.org/drawingml/2006/main" xmlns:r="http://schemas.openxmlformats.org/officeDocument/2006/relationships" xmlns:p="http://schemas.openxmlformats.org/presentationml/2006/main">
-  <p:cSld name="Slide 12">
-    <p:spTree>
-      <p:nvGrpSpPr>
-        <p:cNvPr id="1" name=""/>
-        <p:cNvGrpSpPr/>
-        <p:nvPr/>
-      </p:nvGrpSpPr>
-      <p:grpSpPr>
-        <a:xfrm>
-          <a:off x="0" y="0"/>
-          <a:ext cx="0" cy="0"/>
-          <a:chOff x="0" y="0"/>
-          <a:chExt cx="0" cy="0"/>
-        </a:xfrm>
-      </p:grpSpPr>
-      <p:sp>
-        <p:nvSpPr>
-          <p:cNvPr id="2" name="Text 0"/>
-          <p:cNvSpPr/>
-          <p:nvPr>
-            <p:ph idx="100" type="title" hasCustomPrompt="1"/>
-          </p:nvPr>
-        </p:nvSpPr>
-        <p:spPr>
-          <a:xfrm>
-            <a:off x="457200" y="274320"/>
-            <a:ext cx="8229600" cy="548640"/>
-          </a:xfrm>
-          <a:prstGeom prst="rect">
-            <a:avLst/>
-          </a:prstGeom>
-          <a:noFill/>
-          <a:ln/>
-        </p:spPr>
-        <p:txBody>
-          <a:bodyPr wrap="square" lIns="0" tIns="0" rIns="0" bIns="0" rtlCol="0" anchor="ctr"/>
-          <a:lstStyle/>
-          <a:p>
-            <a:pPr algn="l" indent="0" marL="0">
-              <a:buNone/>
-            </a:pPr>
-            <a:r>
-              <a:rPr lang="en-US" sz="2600" b="1" dirty="0">
-                <a:solidFill>
-                  <a:schemeClr val="tx1"/>
-                </a:solidFill>
-              </a:rPr>
-              <a:t>Cost and runtime</a:t>
-            </a:r>
-            <a:endParaRPr lang="en-US" sz="2600" dirty="0"/>
-          </a:p>
-        </p:txBody>
-      </p:sp>
-      <p:graphicFrame>
-        <p:nvGraphicFramePr>
-          <p:cNvPr id="3" name="Chart 0" descr=""/>
-          <p:cNvGraphicFramePr/>
-          <p:nvPr/>
-        </p:nvGraphicFramePr>
-        <p:xfrm>
-          <a:off x="365760" y="914400"/>
-          <a:ext cx="4572000" cy="3474720"/>
-        </p:xfrm>
-        <a:graphic xmlns:a="http://schemas.openxmlformats.org/drawingml/2006/main">
-          <a:graphicData uri="http://schemas.openxmlformats.org/drawingml/2006/chart">
-            <c:chart xmlns:c="http://schemas.openxmlformats.org/drawingml/2006/chart" r:id="rId1"/>
-          </a:graphicData>
-        </a:graphic>
-      </p:graphicFrame>
-      <p:sp>
-        <p:nvSpPr>
-          <p:cNvPr id="4" name="Text 1"/>
-          <p:cNvSpPr txBox="1"/>
-          <p:nvPr/>
-        </p:nvSpPr>
-        <p:spPr>
-          <a:xfrm>
-            <a:off x="5394960" y="1188720"/>
-            <a:ext cx="3291840" cy="457200"/>
-          </a:xfrm>
-          <a:prstGeom prst="rect">
-            <a:avLst/>
-          </a:prstGeom>
-          <a:noFill/>
-          <a:ln/>
-        </p:spPr>
-        <p:txBody>
-          <a:bodyPr wrap="square" lIns="0" tIns="0" rIns="0" bIns="0" rtlCol="0" anchor="t"/>
-          <a:lstStyle/>
-          <a:p>
-            <a:pPr indent="0" marL="0">
-              <a:buNone/>
-            </a:pPr>
-            <a:r>
-              <a:rPr lang="en-US" sz="2600" b="1" dirty="0">
-                <a:solidFill>
-                  <a:schemeClr val="accent1"/>
-                </a:solidFill>
-              </a:rPr>
-              <a:t>≈ ₹21,000</a:t>
-            </a:r>
-            <a:endParaRPr lang="en-US" sz="2600" dirty="0"/>
-          </a:p>
-        </p:txBody>
-      </p:sp>
-      <p:sp>
-        <p:nvSpPr>
-          <p:cNvPr id="5" name="Text 2"/>
-          <p:cNvSpPr txBox="1"/>
-          <p:nvPr/>
-        </p:nvSpPr>
-        <p:spPr>
-          <a:xfrm>
-            <a:off x="5394960" y="1664208"/>
-            <a:ext cx="3291840" cy="274320"/>
-          </a:xfrm>
-          <a:prstGeom prst="rect">
-            <a:avLst/>
-          </a:prstGeom>
-          <a:noFill/>
-          <a:ln/>
-        </p:spPr>
-        <p:txBody>
-          <a:bodyPr wrap="square" lIns="0" tIns="0" rIns="0" bIns="0" rtlCol="0" anchor="t"/>
-          <a:lstStyle/>
-          <a:p>
-            <a:pPr indent="0" marL="0">
-              <a:buNone/>
-            </a:pPr>
-            <a:r>
-              <a:rPr lang="en-US" sz="1200" dirty="0">
-                <a:solidFill>
-                  <a:schemeClr val="tx1"/>
-                </a:solidFill>
-              </a:rPr>
-              <a:t>full build, using a laptop we already have</a:t>
-            </a:r>
-            <a:endParaRPr lang="en-US" sz="1200" dirty="0"/>
-          </a:p>
-        </p:txBody>
-      </p:sp>
-      <p:sp>
-        <p:nvSpPr>
-          <p:cNvPr id="6" name="Text 3"/>
-          <p:cNvSpPr txBox="1"/>
-          <p:nvPr/>
-        </p:nvSpPr>
-        <p:spPr>
-          <a:xfrm>
-            <a:off x="5394960" y="2194560"/>
-            <a:ext cx="3291840" cy="457200"/>
-          </a:xfrm>
-          <a:prstGeom prst="rect">
-            <a:avLst/>
-          </a:prstGeom>
-          <a:noFill/>
-          <a:ln/>
-        </p:spPr>
-        <p:txBody>
-          <a:bodyPr wrap="square" lIns="0" tIns="0" rIns="0" bIns="0" rtlCol="0" anchor="t"/>
-          <a:lstStyle/>
-          <a:p>
-            <a:pPr indent="0" marL="0">
-              <a:buNone/>
-            </a:pPr>
-            <a:r>
-              <a:rPr lang="en-US" sz="2600" b="1" dirty="0">
-                <a:solidFill>
-                  <a:schemeClr val="accent1"/>
-                </a:solidFill>
-              </a:rPr>
-              <a:t>+ ₹14,400</a:t>
-            </a:r>
-            <a:endParaRPr lang="en-US" sz="2600" dirty="0"/>
-          </a:p>
-        </p:txBody>
-      </p:sp>
-      <p:sp>
-        <p:nvSpPr>
-          <p:cNvPr id="7" name="Text 4"/>
-          <p:cNvSpPr txBox="1"/>
-          <p:nvPr/>
-        </p:nvSpPr>
-        <p:spPr>
-          <a:xfrm>
-            <a:off x="5394960" y="2670048"/>
-            <a:ext cx="3291840" cy="274320"/>
-          </a:xfrm>
-          <a:prstGeom prst="rect">
-            <a:avLst/>
-          </a:prstGeom>
-          <a:noFill/>
-          <a:ln/>
-        </p:spPr>
-        <p:txBody>
-          <a:bodyPr wrap="square" lIns="0" tIns="0" rIns="0" bIns="0" rtlCol="0" anchor="t"/>
-          <a:lstStyle/>
-          <a:p>
-            <a:pPr indent="0" marL="0">
-              <a:buNone/>
-            </a:pPr>
-            <a:r>
-              <a:rPr lang="en-US" sz="1200" dirty="0">
-                <a:solidFill>
-                  <a:schemeClr val="tx1"/>
-                </a:solidFill>
-              </a:rPr>
-              <a:t>optional OAK-D Lite depth camera</a:t>
-            </a:r>
-            <a:endParaRPr lang="en-US" sz="1200" dirty="0"/>
-          </a:p>
-        </p:txBody>
-      </p:sp>
-      <p:sp>
-        <p:nvSpPr>
-          <p:cNvPr id="8" name="Text 5"/>
-          <p:cNvSpPr txBox="1"/>
-          <p:nvPr/>
-        </p:nvSpPr>
-        <p:spPr>
-          <a:xfrm>
-            <a:off x="5394960" y="3200400"/>
-            <a:ext cx="3291840" cy="457200"/>
-          </a:xfrm>
-          <a:prstGeom prst="rect">
-            <a:avLst/>
-          </a:prstGeom>
-          <a:noFill/>
-          <a:ln/>
-        </p:spPr>
-        <p:txBody>
-          <a:bodyPr wrap="square" lIns="0" tIns="0" rIns="0" bIns="0" rtlCol="0" anchor="t"/>
-          <a:lstStyle/>
-          <a:p>
-            <a:pPr indent="0" marL="0">
-              <a:buNone/>
-            </a:pPr>
-            <a:r>
-              <a:rPr lang="en-US" sz="2600" b="1" dirty="0">
-                <a:solidFill>
-                  <a:schemeClr val="accent1"/>
-                </a:solidFill>
-              </a:rPr>
-              <a:t>≈ 2 hours</a:t>
-            </a:r>
-            <a:endParaRPr lang="en-US" sz="2600" dirty="0"/>
-          </a:p>
-        </p:txBody>
-      </p:sp>
-      <p:sp>
-        <p:nvSpPr>
-          <p:cNvPr id="9" name="Text 6"/>
-          <p:cNvSpPr txBox="1"/>
-          <p:nvPr/>
-        </p:nvSpPr>
-        <p:spPr>
-          <a:xfrm>
-            <a:off x="5394960" y="3675888"/>
-            <a:ext cx="3291840" cy="274320"/>
-          </a:xfrm>
-          <a:prstGeom prst="rect">
-            <a:avLst/>
-          </a:prstGeom>
-          <a:noFill/>
-          <a:ln/>
-        </p:spPr>
-        <p:txBody>
-          <a:bodyPr wrap="square" lIns="0" tIns="0" rIns="0" bIns="0" rtlCol="0" anchor="t"/>
-          <a:lstStyle/>
-          <a:p>
-            <a:pPr indent="0" marL="0">
-              <a:buNone/>
-            </a:pPr>
-            <a:r>
-              <a:rPr lang="en-US" sz="1200" dirty="0">
-                <a:solidFill>
-                  <a:schemeClr val="tx1"/>
-                </a:solidFill>
-              </a:rPr>
-              <a:t>per charge, limited by the laptop battery</a:t>
-            </a:r>
-            <a:endParaRPr lang="en-US" sz="1200" dirty="0"/>
-          </a:p>
-        </p:txBody>
-      </p:sp>
-      <p:sp>
-        <p:nvSpPr>
-          <p:cNvPr id="10" name="Text 7"/>
-          <p:cNvSpPr txBox="1"/>
-          <p:nvPr/>
-        </p:nvSpPr>
-        <p:spPr>
-          <a:xfrm>
-            <a:off x="457200" y="4434840"/>
-            <a:ext cx="8229600" cy="228600"/>
-          </a:xfrm>
-          <a:prstGeom prst="rect">
-            <a:avLst/>
-          </a:prstGeom>
-          <a:noFill/>
-          <a:ln/>
-        </p:spPr>
-        <p:txBody>
-          <a:bodyPr wrap="square" lIns="0" tIns="0" rIns="0" bIns="0" rtlCol="0" anchor="t"/>
-          <a:lstStyle/>
-          <a:p>
-            <a:pPr indent="0" marL="0">
-              <a:buNone/>
-            </a:pPr>
-            <a:r>
-              <a:rPr lang="en-US" sz="1000" i="1" dirty="0">
-                <a:solidFill>
-                  <a:schemeClr val="accent5"/>
-                </a:solidFill>
-              </a:rPr>
-              <a:t>Approximate Indian retail prices, October 2026.</a:t>
-            </a:r>
-            <a:endParaRPr lang="en-US" sz="1000" dirty="0"/>
-          </a:p>
-        </p:txBody>
-      </p:sp>
-      <p:sp>
-        <p:nvSpPr>
-          <p:cNvPr id="25" name="Slide Number Placeholder 0"/>
-          <p:cNvSpPr>
-            <a:spLocks noGrp="1"/>
-          </p:cNvSpPr>
-          <p:nvPr>
-            <p:ph type="sldNum" sz="quarter" idx="4294967295"/>
-          </p:nvPr>
-        </p:nvSpPr>
-        <p:spPr>
-          <a:xfrm>
-            <a:off x="8229600" y="4800600"/>
-            <a:ext cx="457200" cy="228600"/>
-          </a:xfrm>
-          <a:prstGeom prst="rect">
-            <a:avLst/>
-          </a:prstGeom>
-          <a:extLst>
-            <a:ext uri="{C572A759-6A51-4108-AA02-DFA0A04FC94B}">
-              <ma14:wrappingTextBoxFlag xmlns:ma14="http://schemas.microsoft.com/office/mac/drawingml/2011/main" val="0"/>
-            </a:ext>
-          </a:extLst>
-        </p:spPr>
-        <p:txBody>
-          <a:bodyPr/>
-          <a:lstStyle>
-            <a:lvl1pPr>
-              <a:defRPr sz="900">
-                <a:solidFill>
-                  <a:schemeClr val="accent5"/>
-                </a:solidFill>
-              </a:defRPr>
-            </a:lvl1pPr>
-          </a:lstStyle>
-          <a:p>
-            <a:pPr algn="r"/>
-            <a:fld id="{F7021451-1387-4CA6-816F-3879F97B5CBC}" type="slidenum">
-              <a:rPr b="0" lang="en-US"/>
-              <a:t>12</a:t>
-            </a:fld>
-            <a:endParaRPr lang="en-US"/>
-          </a:p>
-        </p:txBody>
-      </p:sp>
-    </p:spTree>
-  </p:cSld>
-  <p:clrMapOvr>
-    <a:masterClrMapping/>
-  </p:clrMapOvr>
-</p:sld>
-</file>
-
-<file path=ppt/slides/slide13.xml><?xml version="1.0" encoding="utf-8"?>
-<p:sld xmlns:a="http://schemas.openxmlformats.org/drawingml/2006/main" xmlns:r="http://schemas.openxmlformats.org/officeDocument/2006/relationships" xmlns:p="http://schemas.openxmlformats.org/presentationml/2006/main">
-  <p:cSld name="Slide 13">
-    <p:spTree>
-      <p:nvGrpSpPr>
-        <p:cNvPr id="1" name=""/>
-        <p:cNvGrpSpPr/>
-        <p:nvPr/>
-      </p:nvGrpSpPr>
-      <p:grpSpPr>
-        <a:xfrm>
-          <a:off x="0" y="0"/>
-          <a:ext cx="0" cy="0"/>
-          <a:chOff x="0" y="0"/>
-          <a:chExt cx="0" cy="0"/>
-        </a:xfrm>
-      </p:grpSpPr>
-      <p:sp>
-        <p:nvSpPr>
-          <p:cNvPr id="2" name="Text 0"/>
-          <p:cNvSpPr/>
-          <p:nvPr>
-            <p:ph idx="100" type="title" hasCustomPrompt="1"/>
-          </p:nvPr>
-        </p:nvSpPr>
-        <p:spPr>
-          <a:xfrm>
-            <a:off x="457200" y="274320"/>
-            <a:ext cx="8229600" cy="548640"/>
-          </a:xfrm>
-          <a:prstGeom prst="rect">
-            <a:avLst/>
-          </a:prstGeom>
-          <a:noFill/>
-          <a:ln/>
-        </p:spPr>
-        <p:txBody>
-          <a:bodyPr wrap="square" lIns="0" tIns="0" rIns="0" bIns="0" rtlCol="0" anchor="ctr"/>
-          <a:lstStyle/>
-          <a:p>
-            <a:pPr algn="l" indent="0" marL="0">
-              <a:buNone/>
-            </a:pPr>
-            <a:r>
-              <a:rPr lang="en-US" sz="2600" b="1" dirty="0">
-                <a:solidFill>
-                  <a:schemeClr val="tx1"/>
-                </a:solidFill>
-              </a:rPr>
               <a:t>From simulation to a real robot</a:t>
             </a:r>
             <a:endParaRPr lang="en-US" sz="2600" dirty="0"/>
@@ -5776,245 +3613,9 @@
             <a:pPr algn="r"/>
             <a:fld id="{F7021451-1387-4CA6-816F-3879F97B5CBC}" type="slidenum">
               <a:rPr b="0" lang="en-US"/>
-              <a:t>13</a:t>
+              <a:t>10</a:t>
             </a:fld>
             <a:endParaRPr lang="en-US"/>
-          </a:p>
-        </p:txBody>
-      </p:sp>
-    </p:spTree>
-  </p:cSld>
-  <p:clrMapOvr>
-    <a:masterClrMapping/>
-  </p:clrMapOvr>
-</p:sld>
-</file>
-
-<file path=ppt/slides/slide14.xml><?xml version="1.0" encoding="utf-8"?>
-<p:sld xmlns:a="http://schemas.openxmlformats.org/drawingml/2006/main" xmlns:r="http://schemas.openxmlformats.org/officeDocument/2006/relationships" xmlns:p="http://schemas.openxmlformats.org/presentationml/2006/main">
-  <p:cSld name="Slide 14">
-    <p:spTree>
-      <p:nvGrpSpPr>
-        <p:cNvPr id="1" name=""/>
-        <p:cNvGrpSpPr/>
-        <p:nvPr/>
-      </p:nvGrpSpPr>
-      <p:grpSpPr>
-        <a:xfrm>
-          <a:off x="0" y="0"/>
-          <a:ext cx="0" cy="0"/>
-          <a:chOff x="0" y="0"/>
-          <a:chExt cx="0" cy="0"/>
-        </a:xfrm>
-      </p:grpSpPr>
-      <p:sp>
-        <p:nvSpPr>
-          <p:cNvPr id="2" name="Text 0"/>
-          <p:cNvSpPr txBox="1"/>
-          <p:nvPr/>
-        </p:nvSpPr>
-        <p:spPr>
-          <a:xfrm>
-            <a:off x="457200" y="1097280"/>
-            <a:ext cx="5029200" cy="731520"/>
-          </a:xfrm>
-          <a:prstGeom prst="rect">
-            <a:avLst/>
-          </a:prstGeom>
-          <a:noFill/>
-          <a:ln/>
-        </p:spPr>
-        <p:txBody>
-          <a:bodyPr wrap="square" lIns="0" tIns="0" rIns="0" bIns="0" rtlCol="0" anchor="t"/>
-          <a:lstStyle/>
-          <a:p>
-            <a:pPr indent="0" marL="0">
-              <a:buNone/>
-            </a:pPr>
-            <a:r>
-              <a:rPr lang="en-US" sz="4000" b="1" dirty="0">
-                <a:solidFill>
-                  <a:schemeClr val="accent1"/>
-                </a:solidFill>
-              </a:rPr>
-              <a:t>Thank you</a:t>
-            </a:r>
-            <a:endParaRPr lang="en-US" sz="4000" dirty="0"/>
-          </a:p>
-        </p:txBody>
-      </p:sp>
-      <p:sp>
-        <p:nvSpPr>
-          <p:cNvPr id="3" name="Text 1"/>
-          <p:cNvSpPr txBox="1"/>
-          <p:nvPr/>
-        </p:nvSpPr>
-        <p:spPr>
-          <a:xfrm>
-            <a:off x="457200" y="1920240"/>
-            <a:ext cx="4754880" cy="548640"/>
-          </a:xfrm>
-          <a:prstGeom prst="rect">
-            <a:avLst/>
-          </a:prstGeom>
-          <a:noFill/>
-          <a:ln/>
-        </p:spPr>
-        <p:txBody>
-          <a:bodyPr wrap="square" lIns="0" tIns="0" rIns="0" bIns="0" rtlCol="0" anchor="t"/>
-          <a:lstStyle/>
-          <a:p>
-            <a:pPr indent="0" marL="0">
-              <a:buNone/>
-            </a:pPr>
-            <a:r>
-              <a:rPr lang="en-US" sz="1500" dirty="0">
-                <a:solidFill>
-                  <a:schemeClr val="tx1"/>
-                </a:solidFill>
-              </a:rPr>
-              <a:t>Code, evaluation results, hardware design, circuit and Wokwi simulation are all on GitHub.</a:t>
-            </a:r>
-            <a:endParaRPr lang="en-US" sz="1500" dirty="0"/>
-          </a:p>
-        </p:txBody>
-      </p:sp>
-      <p:sp>
-        <p:nvSpPr>
-          <p:cNvPr id="4" name="Text 2"/>
-          <p:cNvSpPr txBox="1"/>
-          <p:nvPr/>
-        </p:nvSpPr>
-        <p:spPr>
-          <a:xfrm>
-            <a:off x="457200" y="2606040"/>
-            <a:ext cx="4754880" cy="320040"/>
-          </a:xfrm>
-          <a:prstGeom prst="rect">
-            <a:avLst/>
-          </a:prstGeom>
-          <a:noFill/>
-          <a:ln/>
-        </p:spPr>
-        <p:txBody>
-          <a:bodyPr wrap="square" lIns="0" tIns="0" rIns="0" bIns="0" rtlCol="0" anchor="t"/>
-          <a:lstStyle/>
-          <a:p>
-            <a:pPr indent="0" marL="0">
-              <a:buNone/>
-            </a:pPr>
-            <a:r>
-              <a:rPr lang="en-US" sz="1500" b="1" u="sng" dirty="0">
-                <a:solidFill>
-                  <a:schemeClr val="accent1"/>
-                </a:solidFill>
-                <a:hlinkClick r:id="rId1" invalidUrl="" action="" tgtFrame="" tooltip="" history="1" highlightClick="0" endSnd="0">
-                  <a:extLst>
-                    <a:ext uri="{A12FA001-AC4F-418D-AE19-62706E023703}">
-                      <ahyp:hlinkClr xmlns:ahyp="http://schemas.microsoft.com/office/drawing/2018/hyperlinkcolor" val="tx"/>
-                    </a:ext>
-                  </a:extLst>
-                </a:hlinkClick>
-              </a:rPr>
-              <a:t>github.com/RiteshKumar2e/VISTARA-X</a:t>
-            </a:r>
-            <a:endParaRPr lang="en-US" sz="1500" dirty="0"/>
-          </a:p>
-        </p:txBody>
-      </p:sp>
-      <p:sp>
-        <p:nvSpPr>
-          <p:cNvPr id="5" name="Text 3"/>
-          <p:cNvSpPr txBox="1"/>
-          <p:nvPr/>
-        </p:nvSpPr>
-        <p:spPr>
-          <a:xfrm>
-            <a:off x="457200" y="4023360"/>
-            <a:ext cx="4754880" cy="274320"/>
-          </a:xfrm>
-          <a:prstGeom prst="rect">
-            <a:avLst/>
-          </a:prstGeom>
-          <a:noFill/>
-          <a:ln/>
-        </p:spPr>
-        <p:txBody>
-          <a:bodyPr wrap="square" lIns="0" tIns="0" rIns="0" bIns="0" rtlCol="0" anchor="t"/>
-          <a:lstStyle/>
-          <a:p>
-            <a:pPr indent="0" marL="0">
-              <a:buNone/>
-            </a:pPr>
-            <a:r>
-              <a:rPr lang="en-US" sz="1200" dirty="0">
-                <a:solidFill>
-                  <a:schemeClr val="accent5"/>
-                </a:solidFill>
-              </a:rPr>
-              <a:t>Team Hack01  |  Ritesh Kumar, Kainat Afrazi</a:t>
-            </a:r>
-            <a:endParaRPr lang="en-US" sz="1200" dirty="0"/>
-          </a:p>
-        </p:txBody>
-      </p:sp>
-      <p:pic>
-        <p:nvPicPr>
-          <p:cNvPr id="6" name="GitHub QR code" descr="QR code linking to the VISTARA-X GitHub repository">    </p:cNvPr>
-          <p:cNvPicPr>
-            <a:picLocks noChangeAspect="1"/>
-          </p:cNvPicPr>
-          <p:nvPr/>
-        </p:nvPicPr>
-        <p:blipFill>
-          <a:blip r:embed="rId2"/>
-          <a:stretch>
-            <a:fillRect/>
-          </a:stretch>
-        </p:blipFill>
-        <p:spPr>
-          <a:xfrm>
-            <a:off x="6309360" y="1188720"/>
-            <a:ext cx="2011680" cy="2011680"/>
-          </a:xfrm>
-          <a:prstGeom prst="rect">
-            <a:avLst/>
-          </a:prstGeom>
-        </p:spPr>
-      </p:pic>
-      <p:sp>
-        <p:nvSpPr>
-          <p:cNvPr id="7" name="Text 4"/>
-          <p:cNvSpPr txBox="1"/>
-          <p:nvPr/>
-        </p:nvSpPr>
-        <p:spPr>
-          <a:xfrm>
-            <a:off x="6309360" y="3291840"/>
-            <a:ext cx="2011680" cy="274320"/>
-          </a:xfrm>
-          <a:prstGeom prst="rect">
-            <a:avLst/>
-          </a:prstGeom>
-          <a:noFill/>
-          <a:ln/>
-        </p:spPr>
-        <p:txBody>
-          <a:bodyPr wrap="square" lIns="0" tIns="0" rIns="0" bIns="0" rtlCol="0" anchor="t"/>
-          <a:lstStyle/>
-          <a:p>
-            <a:pPr algn="ctr" indent="0" marL="0">
-              <a:buNone/>
-            </a:pPr>
-            <a:r>
-              <a:rPr lang="en-US" sz="1100" dirty="0">
-                <a:solidFill>
-                  <a:schemeClr val="accent5"/>
-                </a:solidFill>
-              </a:rPr>
-              <a:t>Scan for the repository</a:t>
-            </a:r>
-            <a:endParaRPr lang="en-US" sz="1100" dirty="0"/>
           </a:p>
         </p:txBody>
       </p:sp>
@@ -7473,79 +5074,99 @@
                   <a:schemeClr val="tx1"/>
                 </a:solidFill>
               </a:rPr>
-              <a:t>Judge demo: a person crosses the corridor</a:t>
+              <a:t>Results: predictive vs reactive, 9 runs each</a:t>
             </a:r>
             <a:endParaRPr lang="en-US" sz="2600" dirty="0"/>
           </a:p>
         </p:txBody>
       </p:sp>
-      <p:pic>
-        <p:nvPicPr>
-          <p:cNvPr id="3" name="Live mission screenshot" descr="3D crossing corridor with a person and a cart, and the judge demo checklist ticked from telemetry">    </p:cNvPr>
-          <p:cNvPicPr>
-            <a:picLocks noChangeAspect="1"/>
-          </p:cNvPicPr>
-          <p:nvPr/>
-        </p:nvPicPr>
-        <p:blipFill>
-          <a:blip r:embed="rId1"/>
-          <a:stretch>
-            <a:fillRect/>
-          </a:stretch>
-        </p:blipFill>
-        <p:spPr>
-          <a:xfrm>
-            <a:off x="457200" y="960120"/>
-            <a:ext cx="8229600" cy="3090672"/>
-          </a:xfrm>
-          <a:prstGeom prst="rect">
-            <a:avLst/>
-          </a:prstGeom>
-        </p:spPr>
-      </p:pic>
-      <p:sp>
-        <p:nvSpPr>
-          <p:cNvPr id="4" name="Screenshot frame"/>
-          <p:cNvSpPr/>
-          <p:nvPr/>
-        </p:nvSpPr>
-        <p:spPr>
-          <a:xfrm>
-            <a:off x="457200" y="960120"/>
-            <a:ext cx="8229600" cy="3090672"/>
-          </a:xfrm>
-          <a:prstGeom prst="rect">
-            <a:avLst/>
-          </a:prstGeom>
-          <a:ln w="12700">
-            <a:solidFill>
-              <a:srgbClr val="DFE4E9"/>
-            </a:solidFill>
-            <a:prstDash val="solid"/>
-          </a:ln>
-        </p:spPr>
-      </p:sp>
-      <p:sp>
-        <p:nvSpPr>
-          <p:cNvPr id="5" name="Person detected"/>
-          <p:cNvSpPr/>
-          <p:nvPr/>
-        </p:nvSpPr>
-        <p:spPr>
-          <a:xfrm>
-            <a:off x="457200" y="4206240"/>
-            <a:ext cx="1481328" cy="365760"/>
-          </a:xfrm>
-          <a:prstGeom prst="roundRect">
-            <a:avLst>
-              <a:gd name="adj" fmla="val 15000"/>
-            </a:avLst>
-          </a:prstGeom>
-          <a:solidFill>
-            <a:srgbClr val="E2F2F0"/>
-          </a:solidFill>
-          <a:ln/>
-        </p:spPr>
+      <p:graphicFrame>
+        <p:nvGraphicFramePr>
+          <p:cNvPr id="3" name="Chart 0" descr=""/>
+          <p:cNvGraphicFramePr/>
+          <p:nvPr/>
+        </p:nvGraphicFramePr>
+        <p:xfrm>
+          <a:off x="457200" y="960120"/>
+          <a:ext cx="4937760" cy="3383280"/>
+        </p:xfrm>
+        <a:graphic xmlns:a="http://schemas.openxmlformats.org/drawingml/2006/main">
+          <a:graphicData uri="http://schemas.openxmlformats.org/drawingml/2006/chart">
+            <c:chart xmlns:c="http://schemas.openxmlformats.org/drawingml/2006/chart" r:id="rId1"/>
+          </a:graphicData>
+        </a:graphic>
+      </p:graphicFrame>
+      <p:sp>
+        <p:nvSpPr>
+          <p:cNvPr id="4" name="Text 1"/>
+          <p:cNvSpPr txBox="1"/>
+          <p:nvPr/>
+        </p:nvSpPr>
+        <p:spPr>
+          <a:xfrm>
+            <a:off x="5669280" y="1143000"/>
+            <a:ext cx="3017520" cy="457200"/>
+          </a:xfrm>
+          <a:prstGeom prst="rect">
+            <a:avLst/>
+          </a:prstGeom>
+          <a:noFill/>
+          <a:ln/>
+        </p:spPr>
+        <p:txBody>
+          <a:bodyPr wrap="square" lIns="0" tIns="0" rIns="0" bIns="0" rtlCol="0" anchor="t"/>
+          <a:lstStyle/>
+          <a:p>
+            <a:pPr indent="0" marL="0">
+              <a:buNone/>
+            </a:pPr>
+            <a:r>
+              <a:rPr lang="en-US" sz="2600" b="1" dirty="0">
+                <a:solidFill>
+                  <a:schemeClr val="accent1"/>
+                </a:solidFill>
+              </a:rPr>
+              <a:t>0.60 m</a:t>
+            </a:r>
+            <a:endParaRPr lang="en-US" sz="2600" dirty="0"/>
+          </a:p>
+        </p:txBody>
+      </p:sp>
+      <p:sp>
+        <p:nvSpPr>
+          <p:cNvPr id="5" name="Text 2"/>
+          <p:cNvSpPr txBox="1"/>
+          <p:nvPr/>
+        </p:nvSpPr>
+        <p:spPr>
+          <a:xfrm>
+            <a:off x="5669280" y="1600200"/>
+            <a:ext cx="3017520" cy="228600"/>
+          </a:xfrm>
+          <a:prstGeom prst="rect">
+            <a:avLst/>
+          </a:prstGeom>
+          <a:noFill/>
+          <a:ln/>
+        </p:spPr>
+        <p:txBody>
+          <a:bodyPr wrap="square" lIns="0" tIns="0" rIns="0" bIns="0" rtlCol="0" anchor="t"/>
+          <a:lstStyle/>
+          <a:p>
+            <a:pPr indent="0" marL="0">
+              <a:buNone/>
+            </a:pPr>
+            <a:r>
+              <a:rPr lang="en-US" sz="1200" dirty="0">
+                <a:solidFill>
+                  <a:schemeClr val="tx1"/>
+                </a:solidFill>
+              </a:rPr>
+              <a:t>closest approach to the person, worst run</a:t>
+            </a:r>
+            <a:endParaRPr lang="en-US" sz="1200" dirty="0"/>
+          </a:p>
+        </p:txBody>
       </p:sp>
       <p:sp>
         <p:nvSpPr>
@@ -7555,79 +5176,105 @@
         </p:nvSpPr>
         <p:spPr>
           <a:xfrm>
-            <a:off x="457200" y="4206240"/>
-            <a:ext cx="1481328" cy="365760"/>
-          </a:xfrm>
-          <a:prstGeom prst="rect">
-            <a:avLst/>
-          </a:prstGeom>
-          <a:noFill/>
-          <a:ln/>
-        </p:spPr>
-        <p:txBody>
-          <a:bodyPr wrap="square" lIns="0" tIns="0" rIns="0" bIns="0" rtlCol="0" anchor="ctr"/>
-          <a:lstStyle/>
-          <a:p>
-            <a:pPr algn="ctr" indent="0" marL="0">
-              <a:buNone/>
-            </a:pPr>
-            <a:r>
-              <a:rPr lang="en-US" sz="1200" b="1" dirty="0">
+            <a:off x="5669280" y="1819656"/>
+            <a:ext cx="3017520" cy="228600"/>
+          </a:xfrm>
+          <a:prstGeom prst="rect">
+            <a:avLst/>
+          </a:prstGeom>
+          <a:noFill/>
+          <a:ln/>
+        </p:spPr>
+        <p:txBody>
+          <a:bodyPr wrap="square" lIns="0" tIns="0" rIns="0" bIns="0" rtlCol="0" anchor="t"/>
+          <a:lstStyle/>
+          <a:p>
+            <a:pPr indent="0" marL="0">
+              <a:buNone/>
+            </a:pPr>
+            <a:r>
+              <a:rPr lang="en-US" sz="1100" dirty="0">
+                <a:solidFill>
+                  <a:schemeClr val="accent5"/>
+                </a:solidFill>
+              </a:rPr>
+              <a:t>reactive: −0.03 m (contact)</a:t>
+            </a:r>
+            <a:endParaRPr lang="en-US" sz="1100" dirty="0"/>
+          </a:p>
+        </p:txBody>
+      </p:sp>
+      <p:sp>
+        <p:nvSpPr>
+          <p:cNvPr id="7" name="Text 4"/>
+          <p:cNvSpPr txBox="1"/>
+          <p:nvPr/>
+        </p:nvSpPr>
+        <p:spPr>
+          <a:xfrm>
+            <a:off x="5669280" y="2167128"/>
+            <a:ext cx="3017520" cy="457200"/>
+          </a:xfrm>
+          <a:prstGeom prst="rect">
+            <a:avLst/>
+          </a:prstGeom>
+          <a:noFill/>
+          <a:ln/>
+        </p:spPr>
+        <p:txBody>
+          <a:bodyPr wrap="square" lIns="0" tIns="0" rIns="0" bIns="0" rtlCol="0" anchor="t"/>
+          <a:lstStyle/>
+          <a:p>
+            <a:pPr indent="0" marL="0">
+              <a:buNone/>
+            </a:pPr>
+            <a:r>
+              <a:rPr lang="en-US" sz="2600" b="1" dirty="0">
                 <a:solidFill>
                   <a:schemeClr val="accent1"/>
                 </a:solidFill>
               </a:rPr>
-              <a:t>Person detected</a:t>
+              <a:t>1.36 m</a:t>
+            </a:r>
+            <a:endParaRPr lang="en-US" sz="2600" dirty="0"/>
+          </a:p>
+        </p:txBody>
+      </p:sp>
+      <p:sp>
+        <p:nvSpPr>
+          <p:cNvPr id="8" name="Text 5"/>
+          <p:cNvSpPr txBox="1"/>
+          <p:nvPr/>
+        </p:nvSpPr>
+        <p:spPr>
+          <a:xfrm>
+            <a:off x="5669280" y="2624328"/>
+            <a:ext cx="3017520" cy="228600"/>
+          </a:xfrm>
+          <a:prstGeom prst="rect">
+            <a:avLst/>
+          </a:prstGeom>
+          <a:noFill/>
+          <a:ln/>
+        </p:spPr>
+        <p:txBody>
+          <a:bodyPr wrap="square" lIns="0" tIns="0" rIns="0" bIns="0" rtlCol="0" anchor="t"/>
+          <a:lstStyle/>
+          <a:p>
+            <a:pPr indent="0" marL="0">
+              <a:buNone/>
+            </a:pPr>
+            <a:r>
+              <a:rPr lang="en-US" sz="1200" dirty="0">
+                <a:solidFill>
+                  <a:schemeClr val="tx1"/>
+                </a:solidFill>
+              </a:rPr>
+              <a:t>average closest approach</a:t>
             </a:r>
             <a:endParaRPr lang="en-US" sz="1200" dirty="0"/>
           </a:p>
         </p:txBody>
-      </p:sp>
-      <p:sp>
-        <p:nvSpPr>
-          <p:cNvPr id="7" name="Shape 4"/>
-          <p:cNvSpPr/>
-          <p:nvPr/>
-        </p:nvSpPr>
-        <p:spPr>
-          <a:xfrm>
-            <a:off x="1965960" y="4389120"/>
-            <a:ext cx="146304" cy="0"/>
-          </a:xfrm>
-          <a:prstGeom prst="line">
-            <a:avLst/>
-          </a:prstGeom>
-          <a:noFill/>
-          <a:ln w="19050">
-            <a:solidFill>
-              <a:srgbClr val="4B5866"/>
-            </a:solidFill>
-            <a:prstDash val="solid"/>
-            <a:tailEnd type="triangle"/>
-          </a:ln>
-        </p:spPr>
-      </p:sp>
-      <p:sp>
-        <p:nvSpPr>
-          <p:cNvPr id="8" name="Path predicted"/>
-          <p:cNvSpPr/>
-          <p:nvPr/>
-        </p:nvSpPr>
-        <p:spPr>
-          <a:xfrm>
-            <a:off x="2144268" y="4206240"/>
-            <a:ext cx="1481328" cy="365760"/>
-          </a:xfrm>
-          <a:prstGeom prst="roundRect">
-            <a:avLst>
-              <a:gd name="adj" fmla="val 15000"/>
-            </a:avLst>
-          </a:prstGeom>
-          <a:solidFill>
-            <a:srgbClr val="E2F2F0"/>
-          </a:solidFill>
-          <a:ln/>
-        </p:spPr>
       </p:sp>
       <p:sp>
         <p:nvSpPr>
@@ -7637,79 +5284,105 @@
         </p:nvSpPr>
         <p:spPr>
           <a:xfrm>
-            <a:off x="2144268" y="4206240"/>
-            <a:ext cx="1481328" cy="365760"/>
-          </a:xfrm>
-          <a:prstGeom prst="rect">
-            <a:avLst/>
-          </a:prstGeom>
-          <a:noFill/>
-          <a:ln/>
-        </p:spPr>
-        <p:txBody>
-          <a:bodyPr wrap="square" lIns="0" tIns="0" rIns="0" bIns="0" rtlCol="0" anchor="ctr"/>
-          <a:lstStyle/>
-          <a:p>
-            <a:pPr algn="ctr" indent="0" marL="0">
-              <a:buNone/>
-            </a:pPr>
-            <a:r>
-              <a:rPr lang="en-US" sz="1200" b="1" dirty="0">
-                <a:solidFill>
-                  <a:schemeClr val="accent1"/>
-                </a:solidFill>
-              </a:rPr>
-              <a:t>Path predicted</a:t>
+            <a:off x="5669280" y="2843784"/>
+            <a:ext cx="3017520" cy="228600"/>
+          </a:xfrm>
+          <a:prstGeom prst="rect">
+            <a:avLst/>
+          </a:prstGeom>
+          <a:noFill/>
+          <a:ln/>
+        </p:spPr>
+        <p:txBody>
+          <a:bodyPr wrap="square" lIns="0" tIns="0" rIns="0" bIns="0" rtlCol="0" anchor="t"/>
+          <a:lstStyle/>
+          <a:p>
+            <a:pPr indent="0" marL="0">
+              <a:buNone/>
+            </a:pPr>
+            <a:r>
+              <a:rPr lang="en-US" sz="1100" dirty="0">
+                <a:solidFill>
+                  <a:schemeClr val="accent5"/>
+                </a:solidFill>
+              </a:rPr>
+              <a:t>reactive: 1.01 m</a:t>
+            </a:r>
+            <a:endParaRPr lang="en-US" sz="1100" dirty="0"/>
+          </a:p>
+        </p:txBody>
+      </p:sp>
+      <p:sp>
+        <p:nvSpPr>
+          <p:cNvPr id="10" name="Text 7"/>
+          <p:cNvSpPr txBox="1"/>
+          <p:nvPr/>
+        </p:nvSpPr>
+        <p:spPr>
+          <a:xfrm>
+            <a:off x="5669280" y="3191256"/>
+            <a:ext cx="3017520" cy="457200"/>
+          </a:xfrm>
+          <a:prstGeom prst="rect">
+            <a:avLst/>
+          </a:prstGeom>
+          <a:noFill/>
+          <a:ln/>
+        </p:spPr>
+        <p:txBody>
+          <a:bodyPr wrap="square" lIns="0" tIns="0" rIns="0" bIns="0" rtlCol="0" anchor="t"/>
+          <a:lstStyle/>
+          <a:p>
+            <a:pPr indent="0" marL="0">
+              <a:buNone/>
+            </a:pPr>
+            <a:r>
+              <a:rPr lang="en-US" sz="2600" b="1" dirty="0">
+                <a:solidFill>
+                  <a:schemeClr val="tx2"/>
+                </a:solidFill>
+              </a:rPr>
+              <a:t>+1.5 s</a:t>
+            </a:r>
+            <a:endParaRPr lang="en-US" sz="2600" dirty="0"/>
+          </a:p>
+        </p:txBody>
+      </p:sp>
+      <p:sp>
+        <p:nvSpPr>
+          <p:cNvPr id="11" name="Text 8"/>
+          <p:cNvSpPr txBox="1"/>
+          <p:nvPr/>
+        </p:nvSpPr>
+        <p:spPr>
+          <a:xfrm>
+            <a:off x="5669280" y="3648456"/>
+            <a:ext cx="3017520" cy="228600"/>
+          </a:xfrm>
+          <a:prstGeom prst="rect">
+            <a:avLst/>
+          </a:prstGeom>
+          <a:noFill/>
+          <a:ln/>
+        </p:spPr>
+        <p:txBody>
+          <a:bodyPr wrap="square" lIns="0" tIns="0" rIns="0" bIns="0" rtlCol="0" anchor="t"/>
+          <a:lstStyle/>
+          <a:p>
+            <a:pPr indent="0" marL="0">
+              <a:buNone/>
+            </a:pPr>
+            <a:r>
+              <a:rPr lang="en-US" sz="1200" dirty="0">
+                <a:solidFill>
+                  <a:schemeClr val="tx1"/>
+                </a:solidFill>
+              </a:rPr>
+              <a:t>longer per mission</a:t>
             </a:r>
             <a:endParaRPr lang="en-US" sz="1200" dirty="0"/>
           </a:p>
         </p:txBody>
-      </p:sp>
-      <p:sp>
-        <p:nvSpPr>
-          <p:cNvPr id="10" name="Shape 7"/>
-          <p:cNvSpPr/>
-          <p:nvPr/>
-        </p:nvSpPr>
-        <p:spPr>
-          <a:xfrm>
-            <a:off x="3653028" y="4389120"/>
-            <a:ext cx="146304" cy="0"/>
-          </a:xfrm>
-          <a:prstGeom prst="line">
-            <a:avLst/>
-          </a:prstGeom>
-          <a:noFill/>
-          <a:ln w="19050">
-            <a:solidFill>
-              <a:srgbClr val="4B5866"/>
-            </a:solidFill>
-            <a:prstDash val="solid"/>
-            <a:tailEnd type="triangle"/>
-          </a:ln>
-        </p:spPr>
-      </p:sp>
-      <p:sp>
-        <p:nvSpPr>
-          <p:cNvPr id="11" name="Slows to 50%"/>
-          <p:cNvSpPr/>
-          <p:nvPr/>
-        </p:nvSpPr>
-        <p:spPr>
-          <a:xfrm>
-            <a:off x="3831336" y="4206240"/>
-            <a:ext cx="1481328" cy="365760"/>
-          </a:xfrm>
-          <a:prstGeom prst="roundRect">
-            <a:avLst>
-              <a:gd name="adj" fmla="val 15000"/>
-            </a:avLst>
-          </a:prstGeom>
-          <a:solidFill>
-            <a:srgbClr val="E2F2F0"/>
-          </a:solidFill>
-          <a:ln/>
-        </p:spPr>
       </p:sp>
       <p:sp>
         <p:nvSpPr>
@@ -7719,195 +5392,67 @@
         </p:nvSpPr>
         <p:spPr>
           <a:xfrm>
-            <a:off x="3831336" y="4206240"/>
-            <a:ext cx="1481328" cy="365760"/>
-          </a:xfrm>
-          <a:prstGeom prst="rect">
-            <a:avLst/>
-          </a:prstGeom>
-          <a:noFill/>
-          <a:ln/>
-        </p:spPr>
-        <p:txBody>
-          <a:bodyPr wrap="square" lIns="0" tIns="0" rIns="0" bIns="0" rtlCol="0" anchor="ctr"/>
-          <a:lstStyle/>
-          <a:p>
-            <a:pPr algn="ctr" indent="0" marL="0">
-              <a:buNone/>
-            </a:pPr>
-            <a:r>
-              <a:rPr lang="en-US" sz="1200" b="1" dirty="0">
-                <a:solidFill>
-                  <a:schemeClr val="accent1"/>
-                </a:solidFill>
-              </a:rPr>
-              <a:t>Slows to 50%</a:t>
-            </a:r>
-            <a:endParaRPr lang="en-US" sz="1200" dirty="0"/>
-          </a:p>
-        </p:txBody>
-      </p:sp>
-      <p:sp>
-        <p:nvSpPr>
-          <p:cNvPr id="13" name="Shape 10"/>
-          <p:cNvSpPr/>
-          <p:nvPr/>
-        </p:nvSpPr>
-        <p:spPr>
-          <a:xfrm>
-            <a:off x="5340096" y="4389120"/>
-            <a:ext cx="146304" cy="0"/>
-          </a:xfrm>
-          <a:prstGeom prst="line">
-            <a:avLst/>
-          </a:prstGeom>
-          <a:noFill/>
-          <a:ln w="19050">
-            <a:solidFill>
-              <a:srgbClr val="4B5866"/>
-            </a:solidFill>
-            <a:prstDash val="solid"/>
-            <a:tailEnd type="triangle"/>
-          </a:ln>
-        </p:spPr>
-      </p:sp>
-      <p:sp>
-        <p:nvSpPr>
-          <p:cNvPr id="14" name="Re-routes"/>
-          <p:cNvSpPr/>
-          <p:nvPr/>
-        </p:nvSpPr>
-        <p:spPr>
-          <a:xfrm>
-            <a:off x="5518404" y="4206240"/>
-            <a:ext cx="1481328" cy="365760"/>
-          </a:xfrm>
-          <a:prstGeom prst="roundRect">
-            <a:avLst>
-              <a:gd name="adj" fmla="val 15000"/>
-            </a:avLst>
-          </a:prstGeom>
-          <a:solidFill>
-            <a:srgbClr val="E2F2F0"/>
-          </a:solidFill>
-          <a:ln/>
-        </p:spPr>
-      </p:sp>
-      <p:sp>
-        <p:nvSpPr>
-          <p:cNvPr id="15" name="Text 12"/>
+            <a:off x="5669280" y="3867912"/>
+            <a:ext cx="3017520" cy="228600"/>
+          </a:xfrm>
+          <a:prstGeom prst="rect">
+            <a:avLst/>
+          </a:prstGeom>
+          <a:noFill/>
+          <a:ln/>
+        </p:spPr>
+        <p:txBody>
+          <a:bodyPr wrap="square" lIns="0" tIns="0" rIns="0" bIns="0" rtlCol="0" anchor="t"/>
+          <a:lstStyle/>
+          <a:p>
+            <a:pPr indent="0" marL="0">
+              <a:buNone/>
+            </a:pPr>
+            <a:r>
+              <a:rPr lang="en-US" sz="1100" dirty="0">
+                <a:solidFill>
+                  <a:schemeClr val="accent5"/>
+                </a:solidFill>
+              </a:rPr>
+              <a:t>the cost of slowing early</a:t>
+            </a:r>
+            <a:endParaRPr lang="en-US" sz="1100" dirty="0"/>
+          </a:p>
+        </p:txBody>
+      </p:sp>
+      <p:sp>
+        <p:nvSpPr>
+          <p:cNvPr id="13" name="Text 10"/>
           <p:cNvSpPr txBox="1"/>
           <p:nvPr/>
         </p:nvSpPr>
         <p:spPr>
           <a:xfrm>
-            <a:off x="5518404" y="4206240"/>
-            <a:ext cx="1481328" cy="365760"/>
-          </a:xfrm>
-          <a:prstGeom prst="rect">
-            <a:avLst/>
-          </a:prstGeom>
-          <a:noFill/>
-          <a:ln/>
-        </p:spPr>
-        <p:txBody>
-          <a:bodyPr wrap="square" lIns="0" tIns="0" rIns="0" bIns="0" rtlCol="0" anchor="ctr"/>
-          <a:lstStyle/>
-          <a:p>
-            <a:pPr algn="ctr" indent="0" marL="0">
-              <a:buNone/>
-            </a:pPr>
-            <a:r>
-              <a:rPr lang="en-US" sz="1200" b="1" dirty="0">
-                <a:solidFill>
-                  <a:schemeClr val="accent1"/>
-                </a:solidFill>
-              </a:rPr>
-              <a:t>Re-routes</a:t>
-            </a:r>
-            <a:endParaRPr lang="en-US" sz="1200" dirty="0"/>
-          </a:p>
-        </p:txBody>
-      </p:sp>
-      <p:sp>
-        <p:nvSpPr>
-          <p:cNvPr id="16" name="Shape 13"/>
-          <p:cNvSpPr/>
-          <p:nvPr/>
-        </p:nvSpPr>
-        <p:spPr>
-          <a:xfrm>
-            <a:off x="7027164" y="4389120"/>
-            <a:ext cx="146304" cy="0"/>
-          </a:xfrm>
-          <a:prstGeom prst="line">
-            <a:avLst/>
-          </a:prstGeom>
-          <a:noFill/>
-          <a:ln w="19050">
-            <a:solidFill>
-              <a:srgbClr val="4B5866"/>
-            </a:solidFill>
-            <a:prstDash val="solid"/>
-            <a:tailEnd type="triangle"/>
-          </a:ln>
-        </p:spPr>
-      </p:sp>
-      <p:sp>
-        <p:nvSpPr>
-          <p:cNvPr id="17" name="Goal, 0 collisions"/>
-          <p:cNvSpPr/>
-          <p:nvPr/>
-        </p:nvSpPr>
-        <p:spPr>
-          <a:xfrm>
-            <a:off x="7205472" y="4206240"/>
-            <a:ext cx="1481328" cy="365760"/>
-          </a:xfrm>
-          <a:prstGeom prst="roundRect">
-            <a:avLst>
-              <a:gd name="adj" fmla="val 15000"/>
-            </a:avLst>
-          </a:prstGeom>
-          <a:solidFill>
-            <a:srgbClr val="0B7D73"/>
-          </a:solidFill>
-          <a:ln/>
-        </p:spPr>
-      </p:sp>
-      <p:sp>
-        <p:nvSpPr>
-          <p:cNvPr id="18" name="Text 15"/>
-          <p:cNvSpPr txBox="1"/>
-          <p:nvPr/>
-        </p:nvSpPr>
-        <p:spPr>
-          <a:xfrm>
-            <a:off x="7205472" y="4206240"/>
-            <a:ext cx="1481328" cy="365760"/>
-          </a:xfrm>
-          <a:prstGeom prst="rect">
-            <a:avLst/>
-          </a:prstGeom>
-          <a:noFill/>
-          <a:ln/>
-        </p:spPr>
-        <p:txBody>
-          <a:bodyPr wrap="square" lIns="0" tIns="0" rIns="0" bIns="0" rtlCol="0" anchor="ctr"/>
-          <a:lstStyle/>
-          <a:p>
-            <a:pPr algn="ctr" indent="0" marL="0">
-              <a:buNone/>
-            </a:pPr>
-            <a:r>
-              <a:rPr lang="en-US" sz="1200" b="1" dirty="0">
-                <a:solidFill>
-                  <a:schemeClr val="bg1"/>
-                </a:solidFill>
-              </a:rPr>
-              <a:t>Goal, 0 collisions</a:t>
-            </a:r>
-            <a:endParaRPr lang="en-US" sz="1200" dirty="0"/>
+            <a:off x="457200" y="4434840"/>
+            <a:ext cx="8229600" cy="228600"/>
+          </a:xfrm>
+          <a:prstGeom prst="rect">
+            <a:avLst/>
+          </a:prstGeom>
+          <a:noFill/>
+          <a:ln/>
+        </p:spPr>
+        <p:txBody>
+          <a:bodyPr wrap="square" lIns="0" tIns="0" rIns="0" bIns="0" rtlCol="0" anchor="t"/>
+          <a:lstStyle/>
+          <a:p>
+            <a:pPr indent="0" marL="0">
+              <a:buNone/>
+            </a:pPr>
+            <a:r>
+              <a:rPr lang="en-US" sz="1000" i="1" dirty="0">
+                <a:solidFill>
+                  <a:schemeClr val="accent5"/>
+                </a:solidFill>
+              </a:rPr>
+              <a:t>Source: backend/evaluation/results.md (python -m app.evaluation). Simulation only, not a safety certification.</a:t>
+            </a:r>
+            <a:endParaRPr lang="en-US" sz="1000" dirty="0"/>
           </a:p>
         </p:txBody>
       </p:sp>
@@ -8013,491 +5558,7 @@
                   <a:schemeClr val="tx1"/>
                 </a:solidFill>
               </a:rPr>
-              <a:t>Results: predictive vs reactive, 9 runs each</a:t>
-            </a:r>
-            <a:endParaRPr lang="en-US" sz="2600" dirty="0"/>
-          </a:p>
-        </p:txBody>
-      </p:sp>
-      <p:graphicFrame>
-        <p:nvGraphicFramePr>
-          <p:cNvPr id="3" name="Chart 0" descr=""/>
-          <p:cNvGraphicFramePr/>
-          <p:nvPr/>
-        </p:nvGraphicFramePr>
-        <p:xfrm>
-          <a:off x="457200" y="960120"/>
-          <a:ext cx="4937760" cy="3383280"/>
-        </p:xfrm>
-        <a:graphic xmlns:a="http://schemas.openxmlformats.org/drawingml/2006/main">
-          <a:graphicData uri="http://schemas.openxmlformats.org/drawingml/2006/chart">
-            <c:chart xmlns:c="http://schemas.openxmlformats.org/drawingml/2006/chart" r:id="rId1"/>
-          </a:graphicData>
-        </a:graphic>
-      </p:graphicFrame>
-      <p:sp>
-        <p:nvSpPr>
-          <p:cNvPr id="4" name="Text 1"/>
-          <p:cNvSpPr txBox="1"/>
-          <p:nvPr/>
-        </p:nvSpPr>
-        <p:spPr>
-          <a:xfrm>
-            <a:off x="5669280" y="1143000"/>
-            <a:ext cx="3017520" cy="457200"/>
-          </a:xfrm>
-          <a:prstGeom prst="rect">
-            <a:avLst/>
-          </a:prstGeom>
-          <a:noFill/>
-          <a:ln/>
-        </p:spPr>
-        <p:txBody>
-          <a:bodyPr wrap="square" lIns="0" tIns="0" rIns="0" bIns="0" rtlCol="0" anchor="t"/>
-          <a:lstStyle/>
-          <a:p>
-            <a:pPr indent="0" marL="0">
-              <a:buNone/>
-            </a:pPr>
-            <a:r>
-              <a:rPr lang="en-US" sz="2600" b="1" dirty="0">
-                <a:solidFill>
-                  <a:schemeClr val="accent1"/>
-                </a:solidFill>
-              </a:rPr>
-              <a:t>0.60 m</a:t>
-            </a:r>
-            <a:endParaRPr lang="en-US" sz="2600" dirty="0"/>
-          </a:p>
-        </p:txBody>
-      </p:sp>
-      <p:sp>
-        <p:nvSpPr>
-          <p:cNvPr id="5" name="Text 2"/>
-          <p:cNvSpPr txBox="1"/>
-          <p:nvPr/>
-        </p:nvSpPr>
-        <p:spPr>
-          <a:xfrm>
-            <a:off x="5669280" y="1600200"/>
-            <a:ext cx="3017520" cy="228600"/>
-          </a:xfrm>
-          <a:prstGeom prst="rect">
-            <a:avLst/>
-          </a:prstGeom>
-          <a:noFill/>
-          <a:ln/>
-        </p:spPr>
-        <p:txBody>
-          <a:bodyPr wrap="square" lIns="0" tIns="0" rIns="0" bIns="0" rtlCol="0" anchor="t"/>
-          <a:lstStyle/>
-          <a:p>
-            <a:pPr indent="0" marL="0">
-              <a:buNone/>
-            </a:pPr>
-            <a:r>
-              <a:rPr lang="en-US" sz="1200" dirty="0">
-                <a:solidFill>
-                  <a:schemeClr val="tx1"/>
-                </a:solidFill>
-              </a:rPr>
-              <a:t>closest approach to the person, worst run</a:t>
-            </a:r>
-            <a:endParaRPr lang="en-US" sz="1200" dirty="0"/>
-          </a:p>
-        </p:txBody>
-      </p:sp>
-      <p:sp>
-        <p:nvSpPr>
-          <p:cNvPr id="6" name="Text 3"/>
-          <p:cNvSpPr txBox="1"/>
-          <p:nvPr/>
-        </p:nvSpPr>
-        <p:spPr>
-          <a:xfrm>
-            <a:off x="5669280" y="1819656"/>
-            <a:ext cx="3017520" cy="228600"/>
-          </a:xfrm>
-          <a:prstGeom prst="rect">
-            <a:avLst/>
-          </a:prstGeom>
-          <a:noFill/>
-          <a:ln/>
-        </p:spPr>
-        <p:txBody>
-          <a:bodyPr wrap="square" lIns="0" tIns="0" rIns="0" bIns="0" rtlCol="0" anchor="t"/>
-          <a:lstStyle/>
-          <a:p>
-            <a:pPr indent="0" marL="0">
-              <a:buNone/>
-            </a:pPr>
-            <a:r>
-              <a:rPr lang="en-US" sz="1100" dirty="0">
-                <a:solidFill>
-                  <a:schemeClr val="accent5"/>
-                </a:solidFill>
-              </a:rPr>
-              <a:t>reactive: −0.03 m (contact)</a:t>
-            </a:r>
-            <a:endParaRPr lang="en-US" sz="1100" dirty="0"/>
-          </a:p>
-        </p:txBody>
-      </p:sp>
-      <p:sp>
-        <p:nvSpPr>
-          <p:cNvPr id="7" name="Text 4"/>
-          <p:cNvSpPr txBox="1"/>
-          <p:nvPr/>
-        </p:nvSpPr>
-        <p:spPr>
-          <a:xfrm>
-            <a:off x="5669280" y="2167128"/>
-            <a:ext cx="3017520" cy="457200"/>
-          </a:xfrm>
-          <a:prstGeom prst="rect">
-            <a:avLst/>
-          </a:prstGeom>
-          <a:noFill/>
-          <a:ln/>
-        </p:spPr>
-        <p:txBody>
-          <a:bodyPr wrap="square" lIns="0" tIns="0" rIns="0" bIns="0" rtlCol="0" anchor="t"/>
-          <a:lstStyle/>
-          <a:p>
-            <a:pPr indent="0" marL="0">
-              <a:buNone/>
-            </a:pPr>
-            <a:r>
-              <a:rPr lang="en-US" sz="2600" b="1" dirty="0">
-                <a:solidFill>
-                  <a:schemeClr val="accent1"/>
-                </a:solidFill>
-              </a:rPr>
-              <a:t>1.36 m</a:t>
-            </a:r>
-            <a:endParaRPr lang="en-US" sz="2600" dirty="0"/>
-          </a:p>
-        </p:txBody>
-      </p:sp>
-      <p:sp>
-        <p:nvSpPr>
-          <p:cNvPr id="8" name="Text 5"/>
-          <p:cNvSpPr txBox="1"/>
-          <p:nvPr/>
-        </p:nvSpPr>
-        <p:spPr>
-          <a:xfrm>
-            <a:off x="5669280" y="2624328"/>
-            <a:ext cx="3017520" cy="228600"/>
-          </a:xfrm>
-          <a:prstGeom prst="rect">
-            <a:avLst/>
-          </a:prstGeom>
-          <a:noFill/>
-          <a:ln/>
-        </p:spPr>
-        <p:txBody>
-          <a:bodyPr wrap="square" lIns="0" tIns="0" rIns="0" bIns="0" rtlCol="0" anchor="t"/>
-          <a:lstStyle/>
-          <a:p>
-            <a:pPr indent="0" marL="0">
-              <a:buNone/>
-            </a:pPr>
-            <a:r>
-              <a:rPr lang="en-US" sz="1200" dirty="0">
-                <a:solidFill>
-                  <a:schemeClr val="tx1"/>
-                </a:solidFill>
-              </a:rPr>
-              <a:t>average closest approach</a:t>
-            </a:r>
-            <a:endParaRPr lang="en-US" sz="1200" dirty="0"/>
-          </a:p>
-        </p:txBody>
-      </p:sp>
-      <p:sp>
-        <p:nvSpPr>
-          <p:cNvPr id="9" name="Text 6"/>
-          <p:cNvSpPr txBox="1"/>
-          <p:nvPr/>
-        </p:nvSpPr>
-        <p:spPr>
-          <a:xfrm>
-            <a:off x="5669280" y="2843784"/>
-            <a:ext cx="3017520" cy="228600"/>
-          </a:xfrm>
-          <a:prstGeom prst="rect">
-            <a:avLst/>
-          </a:prstGeom>
-          <a:noFill/>
-          <a:ln/>
-        </p:spPr>
-        <p:txBody>
-          <a:bodyPr wrap="square" lIns="0" tIns="0" rIns="0" bIns="0" rtlCol="0" anchor="t"/>
-          <a:lstStyle/>
-          <a:p>
-            <a:pPr indent="0" marL="0">
-              <a:buNone/>
-            </a:pPr>
-            <a:r>
-              <a:rPr lang="en-US" sz="1100" dirty="0">
-                <a:solidFill>
-                  <a:schemeClr val="accent5"/>
-                </a:solidFill>
-              </a:rPr>
-              <a:t>reactive: 1.01 m</a:t>
-            </a:r>
-            <a:endParaRPr lang="en-US" sz="1100" dirty="0"/>
-          </a:p>
-        </p:txBody>
-      </p:sp>
-      <p:sp>
-        <p:nvSpPr>
-          <p:cNvPr id="10" name="Text 7"/>
-          <p:cNvSpPr txBox="1"/>
-          <p:nvPr/>
-        </p:nvSpPr>
-        <p:spPr>
-          <a:xfrm>
-            <a:off x="5669280" y="3191256"/>
-            <a:ext cx="3017520" cy="457200"/>
-          </a:xfrm>
-          <a:prstGeom prst="rect">
-            <a:avLst/>
-          </a:prstGeom>
-          <a:noFill/>
-          <a:ln/>
-        </p:spPr>
-        <p:txBody>
-          <a:bodyPr wrap="square" lIns="0" tIns="0" rIns="0" bIns="0" rtlCol="0" anchor="t"/>
-          <a:lstStyle/>
-          <a:p>
-            <a:pPr indent="0" marL="0">
-              <a:buNone/>
-            </a:pPr>
-            <a:r>
-              <a:rPr lang="en-US" sz="2600" b="1" dirty="0">
-                <a:solidFill>
-                  <a:schemeClr val="tx2"/>
-                </a:solidFill>
-              </a:rPr>
-              <a:t>+1.5 s</a:t>
-            </a:r>
-            <a:endParaRPr lang="en-US" sz="2600" dirty="0"/>
-          </a:p>
-        </p:txBody>
-      </p:sp>
-      <p:sp>
-        <p:nvSpPr>
-          <p:cNvPr id="11" name="Text 8"/>
-          <p:cNvSpPr txBox="1"/>
-          <p:nvPr/>
-        </p:nvSpPr>
-        <p:spPr>
-          <a:xfrm>
-            <a:off x="5669280" y="3648456"/>
-            <a:ext cx="3017520" cy="228600"/>
-          </a:xfrm>
-          <a:prstGeom prst="rect">
-            <a:avLst/>
-          </a:prstGeom>
-          <a:noFill/>
-          <a:ln/>
-        </p:spPr>
-        <p:txBody>
-          <a:bodyPr wrap="square" lIns="0" tIns="0" rIns="0" bIns="0" rtlCol="0" anchor="t"/>
-          <a:lstStyle/>
-          <a:p>
-            <a:pPr indent="0" marL="0">
-              <a:buNone/>
-            </a:pPr>
-            <a:r>
-              <a:rPr lang="en-US" sz="1200" dirty="0">
-                <a:solidFill>
-                  <a:schemeClr val="tx1"/>
-                </a:solidFill>
-              </a:rPr>
-              <a:t>longer per mission</a:t>
-            </a:r>
-            <a:endParaRPr lang="en-US" sz="1200" dirty="0"/>
-          </a:p>
-        </p:txBody>
-      </p:sp>
-      <p:sp>
-        <p:nvSpPr>
-          <p:cNvPr id="12" name="Text 9"/>
-          <p:cNvSpPr txBox="1"/>
-          <p:nvPr/>
-        </p:nvSpPr>
-        <p:spPr>
-          <a:xfrm>
-            <a:off x="5669280" y="3867912"/>
-            <a:ext cx="3017520" cy="228600"/>
-          </a:xfrm>
-          <a:prstGeom prst="rect">
-            <a:avLst/>
-          </a:prstGeom>
-          <a:noFill/>
-          <a:ln/>
-        </p:spPr>
-        <p:txBody>
-          <a:bodyPr wrap="square" lIns="0" tIns="0" rIns="0" bIns="0" rtlCol="0" anchor="t"/>
-          <a:lstStyle/>
-          <a:p>
-            <a:pPr indent="0" marL="0">
-              <a:buNone/>
-            </a:pPr>
-            <a:r>
-              <a:rPr lang="en-US" sz="1100" dirty="0">
-                <a:solidFill>
-                  <a:schemeClr val="accent5"/>
-                </a:solidFill>
-              </a:rPr>
-              <a:t>the cost of slowing early</a:t>
-            </a:r>
-            <a:endParaRPr lang="en-US" sz="1100" dirty="0"/>
-          </a:p>
-        </p:txBody>
-      </p:sp>
-      <p:sp>
-        <p:nvSpPr>
-          <p:cNvPr id="13" name="Text 10"/>
-          <p:cNvSpPr txBox="1"/>
-          <p:nvPr/>
-        </p:nvSpPr>
-        <p:spPr>
-          <a:xfrm>
-            <a:off x="457200" y="4434840"/>
-            <a:ext cx="8229600" cy="228600"/>
-          </a:xfrm>
-          <a:prstGeom prst="rect">
-            <a:avLst/>
-          </a:prstGeom>
-          <a:noFill/>
-          <a:ln/>
-        </p:spPr>
-        <p:txBody>
-          <a:bodyPr wrap="square" lIns="0" tIns="0" rIns="0" bIns="0" rtlCol="0" anchor="t"/>
-          <a:lstStyle/>
-          <a:p>
-            <a:pPr indent="0" marL="0">
-              <a:buNone/>
-            </a:pPr>
-            <a:r>
-              <a:rPr lang="en-US" sz="1000" i="1" dirty="0">
-                <a:solidFill>
-                  <a:schemeClr val="accent5"/>
-                </a:solidFill>
-              </a:rPr>
-              <a:t>Source: backend/evaluation/results.md (python -m app.evaluation). Simulation only, not a safety certification.</a:t>
-            </a:r>
-            <a:endParaRPr lang="en-US" sz="1000" dirty="0"/>
-          </a:p>
-        </p:txBody>
-      </p:sp>
-      <p:sp>
-        <p:nvSpPr>
-          <p:cNvPr id="25" name="Slide Number Placeholder 0"/>
-          <p:cNvSpPr>
-            <a:spLocks noGrp="1"/>
-          </p:cNvSpPr>
-          <p:nvPr>
-            <p:ph type="sldNum" sz="quarter" idx="4294967295"/>
-          </p:nvPr>
-        </p:nvSpPr>
-        <p:spPr>
-          <a:xfrm>
-            <a:off x="8229600" y="4800600"/>
-            <a:ext cx="457200" cy="228600"/>
-          </a:xfrm>
-          <a:prstGeom prst="rect">
-            <a:avLst/>
-          </a:prstGeom>
-          <a:extLst>
-            <a:ext uri="{C572A759-6A51-4108-AA02-DFA0A04FC94B}">
-              <ma14:wrappingTextBoxFlag xmlns:ma14="http://schemas.microsoft.com/office/mac/drawingml/2011/main" val="0"/>
-            </a:ext>
-          </a:extLst>
-        </p:spPr>
-        <p:txBody>
-          <a:bodyPr/>
-          <a:lstStyle>
-            <a:lvl1pPr>
-              <a:defRPr sz="900">
-                <a:solidFill>
-                  <a:schemeClr val="accent5"/>
-                </a:solidFill>
-              </a:defRPr>
-            </a:lvl1pPr>
-          </a:lstStyle>
-          <a:p>
-            <a:pPr algn="r"/>
-            <a:fld id="{F7021451-1387-4CA6-816F-3879F97B5CBC}" type="slidenum">
-              <a:rPr b="0" lang="en-US"/>
-              <a:t>7</a:t>
-            </a:fld>
-            <a:endParaRPr lang="en-US"/>
-          </a:p>
-        </p:txBody>
-      </p:sp>
-    </p:spTree>
-  </p:cSld>
-  <p:clrMapOvr>
-    <a:masterClrMapping/>
-  </p:clrMapOvr>
-</p:sld>
-</file>
-
-<file path=ppt/slides/slide8.xml><?xml version="1.0" encoding="utf-8"?>
-<p:sld xmlns:a="http://schemas.openxmlformats.org/drawingml/2006/main" xmlns:r="http://schemas.openxmlformats.org/officeDocument/2006/relationships" xmlns:p="http://schemas.openxmlformats.org/presentationml/2006/main">
-  <p:cSld name="Slide 8">
-    <p:spTree>
-      <p:nvGrpSpPr>
-        <p:cNvPr id="1" name=""/>
-        <p:cNvGrpSpPr/>
-        <p:nvPr/>
-      </p:nvGrpSpPr>
-      <p:grpSpPr>
-        <a:xfrm>
-          <a:off x="0" y="0"/>
-          <a:ext cx="0" cy="0"/>
-          <a:chOff x="0" y="0"/>
-          <a:chExt cx="0" cy="0"/>
-        </a:xfrm>
-      </p:grpSpPr>
-      <p:sp>
-        <p:nvSpPr>
-          <p:cNvPr id="2" name="Text 0"/>
-          <p:cNvSpPr/>
-          <p:nvPr>
-            <p:ph idx="100" type="title" hasCustomPrompt="1"/>
-          </p:nvPr>
-        </p:nvSpPr>
-        <p:spPr>
-          <a:xfrm>
-            <a:off x="457200" y="274320"/>
-            <a:ext cx="8229600" cy="548640"/>
-          </a:xfrm>
-          <a:prstGeom prst="rect">
-            <a:avLst/>
-          </a:prstGeom>
-          <a:noFill/>
-          <a:ln/>
-        </p:spPr>
-        <p:txBody>
-          <a:bodyPr wrap="square" lIns="0" tIns="0" rIns="0" bIns="0" rtlCol="0" anchor="ctr"/>
-          <a:lstStyle/>
-          <a:p>
-            <a:pPr algn="l" indent="0" marL="0">
-              <a:buNone/>
-            </a:pPr>
-            <a:r>
-              <a:rPr lang="en-US" sz="2600" b="1" dirty="0">
-                <a:solidFill>
-                  <a:schemeClr val="tx1"/>
-                </a:solidFill>
-              </a:rPr>
-              <a:t>Hardware we use</a:t>
+              <a:t>Hardware and cost</a:t>
             </a:r>
             <a:endParaRPr lang="en-US" sz="2600" dirty="0"/>
           </a:p>
@@ -9153,7 +6214,7 @@
       </p:sp>
       <p:graphicFrame>
         <p:nvGraphicFramePr>
-          <p:cNvPr id="9" name="Table 0"/>
+          <p:cNvPr id="8" name="Table 0"/>
           <p:cNvGraphicFramePr>
             <a:graphicFrameLocks noGrp="1"/>
           </p:cNvGraphicFramePr>
@@ -11147,8 +8208,8 @@
         </p:nvSpPr>
         <p:spPr>
           <a:xfrm>
-            <a:off x="5120640" y="4206240"/>
-            <a:ext cx="3566160" cy="228600"/>
+            <a:off x="5120640" y="4160520"/>
+            <a:ext cx="3566160" cy="411480"/>
           </a:xfrm>
           <a:prstGeom prst="rect">
             <a:avLst/>
@@ -11169,12 +8230,144 @@
                   <a:schemeClr val="accent5"/>
                 </a:solidFill>
               </a:rPr>
-              <a:t>Full specs and wiring: hardware/README.md</a:t>
+              <a:t>≈ 2 h per charge (the laptop battery is the limit). Optional OAK-D Lite depth camera: + ₹14,400.</a:t>
             </a:r>
             <a:endParaRPr lang="en-US" sz="1000" dirty="0"/>
           </a:p>
         </p:txBody>
       </p:sp>
+      <p:sp>
+        <p:nvSpPr>
+          <p:cNvPr id="25" name="Slide Number Placeholder 0"/>
+          <p:cNvSpPr>
+            <a:spLocks noGrp="1"/>
+          </p:cNvSpPr>
+          <p:nvPr>
+            <p:ph type="sldNum" sz="quarter" idx="4294967295"/>
+          </p:nvPr>
+        </p:nvSpPr>
+        <p:spPr>
+          <a:xfrm>
+            <a:off x="8229600" y="4800600"/>
+            <a:ext cx="457200" cy="228600"/>
+          </a:xfrm>
+          <a:prstGeom prst="rect">
+            <a:avLst/>
+          </a:prstGeom>
+          <a:extLst>
+            <a:ext uri="{C572A759-6A51-4108-AA02-DFA0A04FC94B}">
+              <ma14:wrappingTextBoxFlag xmlns:ma14="http://schemas.microsoft.com/office/mac/drawingml/2011/main" val="0"/>
+            </a:ext>
+          </a:extLst>
+        </p:spPr>
+        <p:txBody>
+          <a:bodyPr/>
+          <a:lstStyle>
+            <a:lvl1pPr>
+              <a:defRPr sz="900">
+                <a:solidFill>
+                  <a:schemeClr val="accent5"/>
+                </a:solidFill>
+              </a:defRPr>
+            </a:lvl1pPr>
+          </a:lstStyle>
+          <a:p>
+            <a:pPr algn="r"/>
+            <a:fld id="{F7021451-1387-4CA6-816F-3879F97B5CBC}" type="slidenum">
+              <a:rPr b="0" lang="en-US"/>
+              <a:t>7</a:t>
+            </a:fld>
+            <a:endParaRPr lang="en-US"/>
+          </a:p>
+        </p:txBody>
+      </p:sp>
+    </p:spTree>
+  </p:cSld>
+  <p:clrMapOvr>
+    <a:masterClrMapping/>
+  </p:clrMapOvr>
+</p:sld>
+</file>
+
+<file path=ppt/slides/slide8.xml><?xml version="1.0" encoding="utf-8"?>
+<p:sld xmlns:a="http://schemas.openxmlformats.org/drawingml/2006/main" xmlns:r="http://schemas.openxmlformats.org/officeDocument/2006/relationships" xmlns:p="http://schemas.openxmlformats.org/presentationml/2006/main">
+  <p:cSld name="Slide 8">
+    <p:spTree>
+      <p:nvGrpSpPr>
+        <p:cNvPr id="1" name=""/>
+        <p:cNvGrpSpPr/>
+        <p:nvPr/>
+      </p:nvGrpSpPr>
+      <p:grpSpPr>
+        <a:xfrm>
+          <a:off x="0" y="0"/>
+          <a:ext cx="0" cy="0"/>
+          <a:chOff x="0" y="0"/>
+          <a:chExt cx="0" cy="0"/>
+        </a:xfrm>
+      </p:grpSpPr>
+      <p:sp>
+        <p:nvSpPr>
+          <p:cNvPr id="2" name="Text 0"/>
+          <p:cNvSpPr/>
+          <p:nvPr>
+            <p:ph idx="100" type="title" hasCustomPrompt="1"/>
+          </p:nvPr>
+        </p:nvSpPr>
+        <p:spPr>
+          <a:xfrm>
+            <a:off x="457200" y="274320"/>
+            <a:ext cx="8229600" cy="548640"/>
+          </a:xfrm>
+          <a:prstGeom prst="rect">
+            <a:avLst/>
+          </a:prstGeom>
+          <a:noFill/>
+          <a:ln/>
+        </p:spPr>
+        <p:txBody>
+          <a:bodyPr wrap="square" lIns="0" tIns="0" rIns="0" bIns="0" rtlCol="0" anchor="ctr"/>
+          <a:lstStyle/>
+          <a:p>
+            <a:pPr algn="l" indent="0" marL="0">
+              <a:buNone/>
+            </a:pPr>
+            <a:r>
+              <a:rPr lang="en-US" sz="2600" b="1" dirty="0">
+                <a:solidFill>
+                  <a:schemeClr val="tx1"/>
+                </a:solidFill>
+              </a:rPr>
+              <a:t>How the circuit works</a:t>
+            </a:r>
+            <a:endParaRPr lang="en-US" sz="2600" dirty="0"/>
+          </a:p>
+        </p:txBody>
+      </p:sp>
+      <p:pic>
+        <p:nvPicPr>
+          <p:cNvPr id="3" name="How the circuit works" descr="Sense, think, act: sensors into the Arduino, laptop sends speed commands, Arduino drives motors, buzzer and LED; separate power path through the E-stop">    </p:cNvPr>
+          <p:cNvPicPr>
+            <a:picLocks noChangeAspect="1"/>
+          </p:cNvPicPr>
+          <p:nvPr/>
+        </p:nvPicPr>
+        <p:blipFill>
+          <a:blip r:embed="rId1"/>
+          <a:stretch>
+            <a:fillRect/>
+          </a:stretch>
+        </p:blipFill>
+        <p:spPr>
+          <a:xfrm>
+            <a:off x="457200" y="960120"/>
+            <a:ext cx="8229600" cy="3602736"/>
+          </a:xfrm>
+          <a:prstGeom prst="rect">
+            <a:avLst/>
+          </a:prstGeom>
+        </p:spPr>
+      </p:pic>
       <p:sp>
         <p:nvSpPr>
           <p:cNvPr id="25" name="Slide Number Placeholder 0"/>
@@ -11277,7 +8470,7 @@
                   <a:schemeClr val="tx1"/>
                 </a:solidFill>
               </a:rPr>
-              <a:t>How the circuit works</a:t>
+              <a:t>Simulated in Wokwi</a:t>
             </a:r>
             <a:endParaRPr lang="en-US" sz="2600" dirty="0"/>
           </a:p>
@@ -11285,7 +8478,7 @@
       </p:sp>
       <p:pic>
         <p:nvPicPr>
-          <p:cNvPr id="3" name="How the circuit works" descr="Sense, think, act: sensors into the Arduino, laptop sends speed commands, Arduino drives motors, buzzer and LED; separate power path through the E-stop">    </p:cNvPr>
+          <p:cNvPr id="3" name="Wokwi screenshot" descr="Wokwi simulation: Arduino Mega with six HC-SR04 sensors placed around it as on the robot, IMU, E-stop, buzzer, battery knob, motor LEDs and a wire colour legend">    </p:cNvPr>
           <p:cNvPicPr>
             <a:picLocks noChangeAspect="1"/>
           </p:cNvPicPr>
@@ -11299,14 +8492,773 @@
         </p:blipFill>
         <p:spPr>
           <a:xfrm>
-            <a:off x="457200" y="960120"/>
-            <a:ext cx="8229600" cy="3602736"/>
+            <a:off x="457200" y="914400"/>
+            <a:ext cx="4535424" cy="3611880"/>
           </a:xfrm>
           <a:prstGeom prst="rect">
             <a:avLst/>
           </a:prstGeom>
         </p:spPr>
       </p:pic>
+      <p:sp>
+        <p:nvSpPr>
+          <p:cNvPr id="4" name="Screenshot frame"/>
+          <p:cNvSpPr/>
+          <p:nvPr/>
+        </p:nvSpPr>
+        <p:spPr>
+          <a:xfrm>
+            <a:off x="457200" y="914400"/>
+            <a:ext cx="4535424" cy="3611880"/>
+          </a:xfrm>
+          <a:prstGeom prst="rect">
+            <a:avLst/>
+          </a:prstGeom>
+          <a:ln w="12700">
+            <a:solidFill>
+              <a:srgbClr val="DFE4E9"/>
+            </a:solidFill>
+            <a:prstDash val="solid"/>
+          </a:ln>
+        </p:spPr>
+      </p:sp>
+      <p:sp>
+        <p:nvSpPr>
+          <p:cNvPr id="5" name="Text 2"/>
+          <p:cNvSpPr txBox="1"/>
+          <p:nvPr/>
+        </p:nvSpPr>
+        <p:spPr>
+          <a:xfrm>
+            <a:off x="5303520" y="914400"/>
+            <a:ext cx="3383280" cy="320040"/>
+          </a:xfrm>
+          <a:prstGeom prst="rect">
+            <a:avLst/>
+          </a:prstGeom>
+          <a:noFill/>
+          <a:ln/>
+        </p:spPr>
+        <p:txBody>
+          <a:bodyPr wrap="square" lIns="0" tIns="0" rIns="0" bIns="0" rtlCol="0" anchor="t"/>
+          <a:lstStyle/>
+          <a:p>
+            <a:pPr indent="0" marL="0">
+              <a:buNone/>
+            </a:pPr>
+            <a:r>
+              <a:rPr lang="en-US" sz="1500" b="1" dirty="0">
+                <a:solidFill>
+                  <a:schemeClr val="tx1"/>
+                </a:solidFill>
+              </a:rPr>
+              <a:t>Press Start: a 46 s tour runs itself</a:t>
+            </a:r>
+            <a:endParaRPr lang="en-US" sz="1500" dirty="0"/>
+          </a:p>
+        </p:txBody>
+      </p:sp>
+      <p:sp>
+        <p:nvSpPr>
+          <p:cNvPr id="6" name="Marker 1"/>
+          <p:cNvSpPr/>
+          <p:nvPr/>
+        </p:nvSpPr>
+        <p:spPr>
+          <a:xfrm>
+            <a:off x="5303520" y="1399032"/>
+            <a:ext cx="274320" cy="274320"/>
+          </a:xfrm>
+          <a:prstGeom prst="ellipse">
+            <a:avLst/>
+          </a:prstGeom>
+          <a:solidFill>
+            <a:srgbClr val="D9A441"/>
+          </a:solidFill>
+          <a:ln w="19050">
+            <a:solidFill>
+              <a:srgbClr val="FFFFFF"/>
+            </a:solidFill>
+            <a:prstDash val="solid"/>
+          </a:ln>
+        </p:spPr>
+      </p:sp>
+      <p:sp>
+        <p:nvSpPr>
+          <p:cNvPr id="7" name="Text 4"/>
+          <p:cNvSpPr txBox="1"/>
+          <p:nvPr/>
+        </p:nvSpPr>
+        <p:spPr>
+          <a:xfrm>
+            <a:off x="5303520" y="1399032"/>
+            <a:ext cx="274320" cy="274320"/>
+          </a:xfrm>
+          <a:prstGeom prst="rect">
+            <a:avLst/>
+          </a:prstGeom>
+          <a:noFill/>
+          <a:ln/>
+        </p:spPr>
+        <p:txBody>
+          <a:bodyPr wrap="square" lIns="0" tIns="0" rIns="0" bIns="0" rtlCol="0" anchor="ctr"/>
+          <a:lstStyle/>
+          <a:p>
+            <a:pPr algn="ctr" indent="0" marL="0">
+              <a:buNone/>
+            </a:pPr>
+            <a:r>
+              <a:rPr lang="en-US" sz="1100" b="1" dirty="0">
+                <a:solidFill>
+                  <a:schemeClr val="tx1"/>
+                </a:solidFill>
+              </a:rPr>
+              <a:t>1</a:t>
+            </a:r>
+            <a:endParaRPr lang="en-US" sz="1100" dirty="0"/>
+          </a:p>
+        </p:txBody>
+      </p:sp>
+      <p:sp>
+        <p:nvSpPr>
+          <p:cNvPr id="8" name="Text 5"/>
+          <p:cNvSpPr txBox="1"/>
+          <p:nvPr/>
+        </p:nvSpPr>
+        <p:spPr>
+          <a:xfrm>
+            <a:off x="5715000" y="1371600"/>
+            <a:ext cx="2971800" cy="237744"/>
+          </a:xfrm>
+          <a:prstGeom prst="rect">
+            <a:avLst/>
+          </a:prstGeom>
+          <a:noFill/>
+          <a:ln/>
+        </p:spPr>
+        <p:txBody>
+          <a:bodyPr wrap="square" lIns="0" tIns="0" rIns="0" bIns="0" rtlCol="0" anchor="t"/>
+          <a:lstStyle/>
+          <a:p>
+            <a:pPr indent="0" marL="0">
+              <a:buNone/>
+            </a:pPr>
+            <a:r>
+              <a:rPr lang="en-US" sz="1300" b="1" dirty="0">
+                <a:solidFill>
+                  <a:schemeClr val="tx1"/>
+                </a:solidFill>
+              </a:rPr>
+              <a:t>Drive forward</a:t>
+            </a:r>
+            <a:endParaRPr lang="en-US" sz="1300" dirty="0"/>
+          </a:p>
+        </p:txBody>
+      </p:sp>
+      <p:sp>
+        <p:nvSpPr>
+          <p:cNvPr id="9" name="Text 6"/>
+          <p:cNvSpPr txBox="1"/>
+          <p:nvPr/>
+        </p:nvSpPr>
+        <p:spPr>
+          <a:xfrm>
+            <a:off x="5715000" y="1618488"/>
+            <a:ext cx="2971800" cy="237744"/>
+          </a:xfrm>
+          <a:prstGeom prst="rect">
+            <a:avLst/>
+          </a:prstGeom>
+          <a:noFill/>
+          <a:ln/>
+        </p:spPr>
+        <p:txBody>
+          <a:bodyPr wrap="square" lIns="0" tIns="0" rIns="0" bIns="0" rtlCol="0" anchor="t"/>
+          <a:lstStyle/>
+          <a:p>
+            <a:pPr indent="0" marL="0">
+              <a:buNone/>
+            </a:pPr>
+            <a:r>
+              <a:rPr lang="en-US" sz="1200" dirty="0">
+                <a:solidFill>
+                  <a:schemeClr val="accent5"/>
+                </a:solidFill>
+              </a:rPr>
+              <a:t>green motor LEDs light up</a:t>
+            </a:r>
+            <a:endParaRPr lang="en-US" sz="1200" dirty="0"/>
+          </a:p>
+        </p:txBody>
+      </p:sp>
+      <p:sp>
+        <p:nvSpPr>
+          <p:cNvPr id="10" name="Marker 2"/>
+          <p:cNvSpPr/>
+          <p:nvPr/>
+        </p:nvSpPr>
+        <p:spPr>
+          <a:xfrm>
+            <a:off x="5303520" y="1947672"/>
+            <a:ext cx="274320" cy="274320"/>
+          </a:xfrm>
+          <a:prstGeom prst="ellipse">
+            <a:avLst/>
+          </a:prstGeom>
+          <a:solidFill>
+            <a:srgbClr val="D9A441"/>
+          </a:solidFill>
+          <a:ln w="19050">
+            <a:solidFill>
+              <a:srgbClr val="FFFFFF"/>
+            </a:solidFill>
+            <a:prstDash val="solid"/>
+          </a:ln>
+        </p:spPr>
+      </p:sp>
+      <p:sp>
+        <p:nvSpPr>
+          <p:cNvPr id="11" name="Text 8"/>
+          <p:cNvSpPr txBox="1"/>
+          <p:nvPr/>
+        </p:nvSpPr>
+        <p:spPr>
+          <a:xfrm>
+            <a:off x="5303520" y="1947672"/>
+            <a:ext cx="274320" cy="274320"/>
+          </a:xfrm>
+          <a:prstGeom prst="rect">
+            <a:avLst/>
+          </a:prstGeom>
+          <a:noFill/>
+          <a:ln/>
+        </p:spPr>
+        <p:txBody>
+          <a:bodyPr wrap="square" lIns="0" tIns="0" rIns="0" bIns="0" rtlCol="0" anchor="ctr"/>
+          <a:lstStyle/>
+          <a:p>
+            <a:pPr algn="ctr" indent="0" marL="0">
+              <a:buNone/>
+            </a:pPr>
+            <a:r>
+              <a:rPr lang="en-US" sz="1100" b="1" dirty="0">
+                <a:solidFill>
+                  <a:schemeClr val="tx1"/>
+                </a:solidFill>
+              </a:rPr>
+              <a:t>2</a:t>
+            </a:r>
+            <a:endParaRPr lang="en-US" sz="1100" dirty="0"/>
+          </a:p>
+        </p:txBody>
+      </p:sp>
+      <p:sp>
+        <p:nvSpPr>
+          <p:cNvPr id="12" name="Text 9"/>
+          <p:cNvSpPr txBox="1"/>
+          <p:nvPr/>
+        </p:nvSpPr>
+        <p:spPr>
+          <a:xfrm>
+            <a:off x="5715000" y="1920240"/>
+            <a:ext cx="2971800" cy="237744"/>
+          </a:xfrm>
+          <a:prstGeom prst="rect">
+            <a:avLst/>
+          </a:prstGeom>
+          <a:noFill/>
+          <a:ln/>
+        </p:spPr>
+        <p:txBody>
+          <a:bodyPr wrap="square" lIns="0" tIns="0" rIns="0" bIns="0" rtlCol="0" anchor="t"/>
+          <a:lstStyle/>
+          <a:p>
+            <a:pPr indent="0" marL="0">
+              <a:buNone/>
+            </a:pPr>
+            <a:r>
+              <a:rPr lang="en-US" sz="1300" b="1" dirty="0">
+                <a:solidFill>
+                  <a:schemeClr val="tx1"/>
+                </a:solidFill>
+              </a:rPr>
+              <a:t>A person walks in front</a:t>
+            </a:r>
+            <a:endParaRPr lang="en-US" sz="1300" dirty="0"/>
+          </a:p>
+        </p:txBody>
+      </p:sp>
+      <p:sp>
+        <p:nvSpPr>
+          <p:cNvPr id="13" name="Text 10"/>
+          <p:cNvSpPr txBox="1"/>
+          <p:nvPr/>
+        </p:nvSpPr>
+        <p:spPr>
+          <a:xfrm>
+            <a:off x="5715000" y="2167128"/>
+            <a:ext cx="2971800" cy="237744"/>
+          </a:xfrm>
+          <a:prstGeom prst="rect">
+            <a:avLst/>
+          </a:prstGeom>
+          <a:noFill/>
+          <a:ln/>
+        </p:spPr>
+        <p:txBody>
+          <a:bodyPr wrap="square" lIns="0" tIns="0" rIns="0" bIns="0" rtlCol="0" anchor="t"/>
+          <a:lstStyle/>
+          <a:p>
+            <a:pPr indent="0" marL="0">
+              <a:buNone/>
+            </a:pPr>
+            <a:r>
+              <a:rPr lang="en-US" sz="1200" dirty="0">
+                <a:solidFill>
+                  <a:schemeClr val="accent5"/>
+                </a:solidFill>
+              </a:rPr>
+              <a:t>slows at 0.9 m, stops at 0.3 m</a:t>
+            </a:r>
+            <a:endParaRPr lang="en-US" sz="1200" dirty="0"/>
+          </a:p>
+        </p:txBody>
+      </p:sp>
+      <p:sp>
+        <p:nvSpPr>
+          <p:cNvPr id="14" name="Marker 3"/>
+          <p:cNvSpPr/>
+          <p:nvPr/>
+        </p:nvSpPr>
+        <p:spPr>
+          <a:xfrm>
+            <a:off x="5303520" y="2496312"/>
+            <a:ext cx="274320" cy="274320"/>
+          </a:xfrm>
+          <a:prstGeom prst="ellipse">
+            <a:avLst/>
+          </a:prstGeom>
+          <a:solidFill>
+            <a:srgbClr val="D9A441"/>
+          </a:solidFill>
+          <a:ln w="19050">
+            <a:solidFill>
+              <a:srgbClr val="FFFFFF"/>
+            </a:solidFill>
+            <a:prstDash val="solid"/>
+          </a:ln>
+        </p:spPr>
+      </p:sp>
+      <p:sp>
+        <p:nvSpPr>
+          <p:cNvPr id="15" name="Text 12"/>
+          <p:cNvSpPr txBox="1"/>
+          <p:nvPr/>
+        </p:nvSpPr>
+        <p:spPr>
+          <a:xfrm>
+            <a:off x="5303520" y="2496312"/>
+            <a:ext cx="274320" cy="274320"/>
+          </a:xfrm>
+          <a:prstGeom prst="rect">
+            <a:avLst/>
+          </a:prstGeom>
+          <a:noFill/>
+          <a:ln/>
+        </p:spPr>
+        <p:txBody>
+          <a:bodyPr wrap="square" lIns="0" tIns="0" rIns="0" bIns="0" rtlCol="0" anchor="ctr"/>
+          <a:lstStyle/>
+          <a:p>
+            <a:pPr algn="ctr" indent="0" marL="0">
+              <a:buNone/>
+            </a:pPr>
+            <a:r>
+              <a:rPr lang="en-US" sz="1100" b="1" dirty="0">
+                <a:solidFill>
+                  <a:schemeClr val="tx1"/>
+                </a:solidFill>
+              </a:rPr>
+              <a:t>3</a:t>
+            </a:r>
+            <a:endParaRPr lang="en-US" sz="1100" dirty="0"/>
+          </a:p>
+        </p:txBody>
+      </p:sp>
+      <p:sp>
+        <p:nvSpPr>
+          <p:cNvPr id="16" name="Text 13"/>
+          <p:cNvSpPr txBox="1"/>
+          <p:nvPr/>
+        </p:nvSpPr>
+        <p:spPr>
+          <a:xfrm>
+            <a:off x="5715000" y="2468880"/>
+            <a:ext cx="2971800" cy="237744"/>
+          </a:xfrm>
+          <a:prstGeom prst="rect">
+            <a:avLst/>
+          </a:prstGeom>
+          <a:noFill/>
+          <a:ln/>
+        </p:spPr>
+        <p:txBody>
+          <a:bodyPr wrap="square" lIns="0" tIns="0" rIns="0" bIns="0" rtlCol="0" anchor="t"/>
+          <a:lstStyle/>
+          <a:p>
+            <a:pPr indent="0" marL="0">
+              <a:buNone/>
+            </a:pPr>
+            <a:r>
+              <a:rPr lang="en-US" sz="1300" b="1" dirty="0">
+                <a:solidFill>
+                  <a:schemeClr val="tx1"/>
+                </a:solidFill>
+              </a:rPr>
+              <a:t>Laptop freezes</a:t>
+            </a:r>
+            <a:endParaRPr lang="en-US" sz="1300" dirty="0"/>
+          </a:p>
+        </p:txBody>
+      </p:sp>
+      <p:sp>
+        <p:nvSpPr>
+          <p:cNvPr id="17" name="Text 14"/>
+          <p:cNvSpPr txBox="1"/>
+          <p:nvPr/>
+        </p:nvSpPr>
+        <p:spPr>
+          <a:xfrm>
+            <a:off x="5715000" y="2715768"/>
+            <a:ext cx="2971800" cy="237744"/>
+          </a:xfrm>
+          <a:prstGeom prst="rect">
+            <a:avLst/>
+          </a:prstGeom>
+          <a:noFill/>
+          <a:ln/>
+        </p:spPr>
+        <p:txBody>
+          <a:bodyPr wrap="square" lIns="0" tIns="0" rIns="0" bIns="0" rtlCol="0" anchor="t"/>
+          <a:lstStyle/>
+          <a:p>
+            <a:pPr indent="0" marL="0">
+              <a:buNone/>
+            </a:pPr>
+            <a:r>
+              <a:rPr lang="en-US" sz="1200" dirty="0">
+                <a:solidFill>
+                  <a:schemeClr val="accent5"/>
+                </a:solidFill>
+              </a:rPr>
+              <a:t>watchdog stops it in 0.5 s</a:t>
+            </a:r>
+            <a:endParaRPr lang="en-US" sz="1200" dirty="0"/>
+          </a:p>
+        </p:txBody>
+      </p:sp>
+      <p:sp>
+        <p:nvSpPr>
+          <p:cNvPr id="18" name="Marker 4"/>
+          <p:cNvSpPr/>
+          <p:nvPr/>
+        </p:nvSpPr>
+        <p:spPr>
+          <a:xfrm>
+            <a:off x="5303520" y="3044952"/>
+            <a:ext cx="274320" cy="274320"/>
+          </a:xfrm>
+          <a:prstGeom prst="ellipse">
+            <a:avLst/>
+          </a:prstGeom>
+          <a:solidFill>
+            <a:srgbClr val="D9A441"/>
+          </a:solidFill>
+          <a:ln w="19050">
+            <a:solidFill>
+              <a:srgbClr val="FFFFFF"/>
+            </a:solidFill>
+            <a:prstDash val="solid"/>
+          </a:ln>
+        </p:spPr>
+      </p:sp>
+      <p:sp>
+        <p:nvSpPr>
+          <p:cNvPr id="19" name="Text 16"/>
+          <p:cNvSpPr txBox="1"/>
+          <p:nvPr/>
+        </p:nvSpPr>
+        <p:spPr>
+          <a:xfrm>
+            <a:off x="5303520" y="3044952"/>
+            <a:ext cx="274320" cy="274320"/>
+          </a:xfrm>
+          <a:prstGeom prst="rect">
+            <a:avLst/>
+          </a:prstGeom>
+          <a:noFill/>
+          <a:ln/>
+        </p:spPr>
+        <p:txBody>
+          <a:bodyPr wrap="square" lIns="0" tIns="0" rIns="0" bIns="0" rtlCol="0" anchor="ctr"/>
+          <a:lstStyle/>
+          <a:p>
+            <a:pPr algn="ctr" indent="0" marL="0">
+              <a:buNone/>
+            </a:pPr>
+            <a:r>
+              <a:rPr lang="en-US" sz="1100" b="1" dirty="0">
+                <a:solidFill>
+                  <a:schemeClr val="tx1"/>
+                </a:solidFill>
+              </a:rPr>
+              <a:t>4</a:t>
+            </a:r>
+            <a:endParaRPr lang="en-US" sz="1100" dirty="0"/>
+          </a:p>
+        </p:txBody>
+      </p:sp>
+      <p:sp>
+        <p:nvSpPr>
+          <p:cNvPr id="20" name="Text 17"/>
+          <p:cNvSpPr txBox="1"/>
+          <p:nvPr/>
+        </p:nvSpPr>
+        <p:spPr>
+          <a:xfrm>
+            <a:off x="5715000" y="3017520"/>
+            <a:ext cx="2971800" cy="237744"/>
+          </a:xfrm>
+          <a:prstGeom prst="rect">
+            <a:avLst/>
+          </a:prstGeom>
+          <a:noFill/>
+          <a:ln/>
+        </p:spPr>
+        <p:txBody>
+          <a:bodyPr wrap="square" lIns="0" tIns="0" rIns="0" bIns="0" rtlCol="0" anchor="t"/>
+          <a:lstStyle/>
+          <a:p>
+            <a:pPr indent="0" marL="0">
+              <a:buNone/>
+            </a:pPr>
+            <a:r>
+              <a:rPr lang="en-US" sz="1300" b="1" dirty="0">
+                <a:solidFill>
+                  <a:schemeClr val="tx1"/>
+                </a:solidFill>
+              </a:rPr>
+              <a:t>Battery low, then empty</a:t>
+            </a:r>
+            <a:endParaRPr lang="en-US" sz="1300" dirty="0"/>
+          </a:p>
+        </p:txBody>
+      </p:sp>
+      <p:sp>
+        <p:nvSpPr>
+          <p:cNvPr id="21" name="Text 18"/>
+          <p:cNvSpPr txBox="1"/>
+          <p:nvPr/>
+        </p:nvSpPr>
+        <p:spPr>
+          <a:xfrm>
+            <a:off x="5715000" y="3264408"/>
+            <a:ext cx="2971800" cy="237744"/>
+          </a:xfrm>
+          <a:prstGeom prst="rect">
+            <a:avLst/>
+          </a:prstGeom>
+          <a:noFill/>
+          <a:ln/>
+        </p:spPr>
+        <p:txBody>
+          <a:bodyPr wrap="square" lIns="0" tIns="0" rIns="0" bIns="0" rtlCol="0" anchor="t"/>
+          <a:lstStyle/>
+          <a:p>
+            <a:pPr indent="0" marL="0">
+              <a:buNone/>
+            </a:pPr>
+            <a:r>
+              <a:rPr lang="en-US" sz="1200" dirty="0">
+                <a:solidFill>
+                  <a:schemeClr val="accent5"/>
+                </a:solidFill>
+              </a:rPr>
+              <a:t>half speed, then motors off</a:t>
+            </a:r>
+            <a:endParaRPr lang="en-US" sz="1200" dirty="0"/>
+          </a:p>
+        </p:txBody>
+      </p:sp>
+      <p:sp>
+        <p:nvSpPr>
+          <p:cNvPr id="22" name="Marker 5"/>
+          <p:cNvSpPr/>
+          <p:nvPr/>
+        </p:nvSpPr>
+        <p:spPr>
+          <a:xfrm>
+            <a:off x="5303520" y="3593592"/>
+            <a:ext cx="274320" cy="274320"/>
+          </a:xfrm>
+          <a:prstGeom prst="ellipse">
+            <a:avLst/>
+          </a:prstGeom>
+          <a:solidFill>
+            <a:srgbClr val="D9A441"/>
+          </a:solidFill>
+          <a:ln w="19050">
+            <a:solidFill>
+              <a:srgbClr val="FFFFFF"/>
+            </a:solidFill>
+            <a:prstDash val="solid"/>
+          </a:ln>
+        </p:spPr>
+      </p:sp>
+      <p:sp>
+        <p:nvSpPr>
+          <p:cNvPr id="23" name="Text 20"/>
+          <p:cNvSpPr txBox="1"/>
+          <p:nvPr/>
+        </p:nvSpPr>
+        <p:spPr>
+          <a:xfrm>
+            <a:off x="5303520" y="3593592"/>
+            <a:ext cx="274320" cy="274320"/>
+          </a:xfrm>
+          <a:prstGeom prst="rect">
+            <a:avLst/>
+          </a:prstGeom>
+          <a:noFill/>
+          <a:ln/>
+        </p:spPr>
+        <p:txBody>
+          <a:bodyPr wrap="square" lIns="0" tIns="0" rIns="0" bIns="0" rtlCol="0" anchor="ctr"/>
+          <a:lstStyle/>
+          <a:p>
+            <a:pPr algn="ctr" indent="0" marL="0">
+              <a:buNone/>
+            </a:pPr>
+            <a:r>
+              <a:rPr lang="en-US" sz="1100" b="1" dirty="0">
+                <a:solidFill>
+                  <a:schemeClr val="tx1"/>
+                </a:solidFill>
+              </a:rPr>
+              <a:t>5</a:t>
+            </a:r>
+            <a:endParaRPr lang="en-US" sz="1100" dirty="0"/>
+          </a:p>
+        </p:txBody>
+      </p:sp>
+      <p:sp>
+        <p:nvSpPr>
+          <p:cNvPr id="24" name="Text 21"/>
+          <p:cNvSpPr txBox="1"/>
+          <p:nvPr/>
+        </p:nvSpPr>
+        <p:spPr>
+          <a:xfrm>
+            <a:off x="5715000" y="3566160"/>
+            <a:ext cx="2971800" cy="237744"/>
+          </a:xfrm>
+          <a:prstGeom prst="rect">
+            <a:avLst/>
+          </a:prstGeom>
+          <a:noFill/>
+          <a:ln/>
+        </p:spPr>
+        <p:txBody>
+          <a:bodyPr wrap="square" lIns="0" tIns="0" rIns="0" bIns="0" rtlCol="0" anchor="t"/>
+          <a:lstStyle/>
+          <a:p>
+            <a:pPr indent="0" marL="0">
+              <a:buNone/>
+            </a:pPr>
+            <a:r>
+              <a:rPr lang="en-US" sz="1300" b="1" dirty="0">
+                <a:solidFill>
+                  <a:schemeClr val="tx1"/>
+                </a:solidFill>
+              </a:rPr>
+              <a:t>E-STOP pressed</a:t>
+            </a:r>
+            <a:endParaRPr lang="en-US" sz="1300" dirty="0"/>
+          </a:p>
+        </p:txBody>
+      </p:sp>
+      <p:sp>
+        <p:nvSpPr>
+          <p:cNvPr id="25" name="Text 22"/>
+          <p:cNvSpPr txBox="1"/>
+          <p:nvPr/>
+        </p:nvSpPr>
+        <p:spPr>
+          <a:xfrm>
+            <a:off x="5715000" y="3813048"/>
+            <a:ext cx="2971800" cy="237744"/>
+          </a:xfrm>
+          <a:prstGeom prst="rect">
+            <a:avLst/>
+          </a:prstGeom>
+          <a:noFill/>
+          <a:ln/>
+        </p:spPr>
+        <p:txBody>
+          <a:bodyPr wrap="square" lIns="0" tIns="0" rIns="0" bIns="0" rtlCol="0" anchor="t"/>
+          <a:lstStyle/>
+          <a:p>
+            <a:pPr indent="0" marL="0">
+              <a:buNone/>
+            </a:pPr>
+            <a:r>
+              <a:rPr lang="en-US" sz="1200" dirty="0">
+                <a:solidFill>
+                  <a:schemeClr val="accent5"/>
+                </a:solidFill>
+              </a:rPr>
+              <a:t>instant stop until reset</a:t>
+            </a:r>
+            <a:endParaRPr lang="en-US" sz="1200" dirty="0"/>
+          </a:p>
+        </p:txBody>
+      </p:sp>
+      <p:sp>
+        <p:nvSpPr>
+          <p:cNvPr id="26" name="Text 23"/>
+          <p:cNvSpPr txBox="1"/>
+          <p:nvPr/>
+        </p:nvSpPr>
+        <p:spPr>
+          <a:xfrm>
+            <a:off x="5303520" y="4114800"/>
+            <a:ext cx="3383280" cy="411480"/>
+          </a:xfrm>
+          <a:prstGeom prst="rect">
+            <a:avLst/>
+          </a:prstGeom>
+          <a:noFill/>
+          <a:ln/>
+        </p:spPr>
+        <p:txBody>
+          <a:bodyPr wrap="square" lIns="0" tIns="0" rIns="0" bIns="0" rtlCol="0" anchor="t"/>
+          <a:lstStyle/>
+          <a:p>
+            <a:pPr indent="0" marL="0">
+              <a:buNone/>
+            </a:pPr>
+            <a:r>
+              <a:rPr lang="en-US" sz="1000" i="1" dirty="0">
+                <a:solidFill>
+                  <a:schemeClr val="accent5"/>
+                </a:solidFill>
+              </a:rPr>
+              <a:t>Each step is explained in the serial monitor. Sliders, knob and button also work by hand.</a:t>
+            </a:r>
+            <a:endParaRPr lang="en-US" sz="1000" dirty="0"/>
+          </a:p>
+        </p:txBody>
+      </p:sp>
       <p:sp>
         <p:nvSpPr>
           <p:cNvPr id="25" name="Slide Number Placeholder 0"/>

</xml_diff>